<commit_message>
Make the deck plain black and white
Every colour mapped to its grey value and both images converted, so
nothing in the deck is coloured. Slide 9 said blue and orange, which it
now describes as dark and light blocks. The accent grey was darkened
once for contrast against the card backgrounds.
</commit_message>
<xml_diff>
--- a/Presentation.pptx
+++ b/Presentation.pptx
@@ -3702,7 +3702,7 @@
                   <a:tcPr marL="128016" marR="128016" marT="54864" marB="54864" anchor="ctr">
                     <a:lnL w="12700" cap="flat" cmpd="sng" algn="ctr">
                       <a:solidFill>
-                        <a:srgbClr val="D5DEE9"/>
+                        <a:srgbClr val="DDDDDD"/>
                       </a:solidFill>
                       <a:prstDash val="solid"/>
                       <a:round/>
@@ -3711,7 +3711,7 @@
                     </a:lnL>
                     <a:lnR w="12700" cap="flat" cmpd="sng" algn="ctr">
                       <a:solidFill>
-                        <a:srgbClr val="D5DEE9"/>
+                        <a:srgbClr val="DDDDDD"/>
                       </a:solidFill>
                       <a:prstDash val="solid"/>
                       <a:round/>
@@ -3720,7 +3720,7 @@
                     </a:lnR>
                     <a:lnT w="12700" cap="flat" cmpd="sng" algn="ctr">
                       <a:solidFill>
-                        <a:srgbClr val="D5DEE9"/>
+                        <a:srgbClr val="DDDDDD"/>
                       </a:solidFill>
                       <a:prstDash val="solid"/>
                       <a:round/>
@@ -3729,7 +3729,7 @@
                     </a:lnT>
                     <a:lnB w="12700" cap="flat" cmpd="sng" algn="ctr">
                       <a:solidFill>
-                        <a:srgbClr val="D5DEE9"/>
+                        <a:srgbClr val="DDDDDD"/>
                       </a:solidFill>
                       <a:prstDash val="solid"/>
                       <a:round/>
@@ -3737,7 +3737,7 @@
                       <a:tailEnd type="none" w="med" len="med"/>
                     </a:lnB>
                     <a:solidFill>
-                      <a:srgbClr val="16233F"/>
+                      <a:srgbClr val="222222"/>
                     </a:solidFill>
                   </a:tcPr>
                 </a:tc>
@@ -3770,7 +3770,7 @@
                   <a:tcPr marL="128016" marR="128016" marT="54864" marB="54864" anchor="ctr">
                     <a:lnL w="12700" cap="flat" cmpd="sng" algn="ctr">
                       <a:solidFill>
-                        <a:srgbClr val="D5DEE9"/>
+                        <a:srgbClr val="DDDDDD"/>
                       </a:solidFill>
                       <a:prstDash val="solid"/>
                       <a:round/>
@@ -3779,7 +3779,7 @@
                     </a:lnL>
                     <a:lnR w="12700" cap="flat" cmpd="sng" algn="ctr">
                       <a:solidFill>
-                        <a:srgbClr val="D5DEE9"/>
+                        <a:srgbClr val="DDDDDD"/>
                       </a:solidFill>
                       <a:prstDash val="solid"/>
                       <a:round/>
@@ -3788,7 +3788,7 @@
                     </a:lnR>
                     <a:lnT w="12700" cap="flat" cmpd="sng" algn="ctr">
                       <a:solidFill>
-                        <a:srgbClr val="D5DEE9"/>
+                        <a:srgbClr val="DDDDDD"/>
                       </a:solidFill>
                       <a:prstDash val="solid"/>
                       <a:round/>
@@ -3797,7 +3797,7 @@
                     </a:lnT>
                     <a:lnB w="12700" cap="flat" cmpd="sng" algn="ctr">
                       <a:solidFill>
-                        <a:srgbClr val="D5DEE9"/>
+                        <a:srgbClr val="DDDDDD"/>
                       </a:solidFill>
                       <a:prstDash val="solid"/>
                       <a:round/>
@@ -3805,7 +3805,7 @@
                       <a:tailEnd type="none" w="med" len="med"/>
                     </a:lnB>
                     <a:solidFill>
-                      <a:srgbClr val="16233F"/>
+                      <a:srgbClr val="222222"/>
                     </a:solidFill>
                   </a:tcPr>
                 </a:tc>
@@ -3838,7 +3838,7 @@
                   <a:tcPr marL="128016" marR="128016" marT="54864" marB="54864" anchor="ctr">
                     <a:lnL w="12700" cap="flat" cmpd="sng" algn="ctr">
                       <a:solidFill>
-                        <a:srgbClr val="D5DEE9"/>
+                        <a:srgbClr val="DDDDDD"/>
                       </a:solidFill>
                       <a:prstDash val="solid"/>
                       <a:round/>
@@ -3847,7 +3847,7 @@
                     </a:lnL>
                     <a:lnR w="12700" cap="flat" cmpd="sng" algn="ctr">
                       <a:solidFill>
-                        <a:srgbClr val="D5DEE9"/>
+                        <a:srgbClr val="DDDDDD"/>
                       </a:solidFill>
                       <a:prstDash val="solid"/>
                       <a:round/>
@@ -3856,7 +3856,7 @@
                     </a:lnR>
                     <a:lnT w="12700" cap="flat" cmpd="sng" algn="ctr">
                       <a:solidFill>
-                        <a:srgbClr val="D5DEE9"/>
+                        <a:srgbClr val="DDDDDD"/>
                       </a:solidFill>
                       <a:prstDash val="solid"/>
                       <a:round/>
@@ -3865,7 +3865,7 @@
                     </a:lnT>
                     <a:lnB w="12700" cap="flat" cmpd="sng" algn="ctr">
                       <a:solidFill>
-                        <a:srgbClr val="D5DEE9"/>
+                        <a:srgbClr val="DDDDDD"/>
                       </a:solidFill>
                       <a:prstDash val="solid"/>
                       <a:round/>
@@ -3873,7 +3873,7 @@
                       <a:tailEnd type="none" w="med" len="med"/>
                     </a:lnB>
                     <a:solidFill>
-                      <a:srgbClr val="16233F"/>
+                      <a:srgbClr val="222222"/>
                     </a:solidFill>
                   </a:tcPr>
                 </a:tc>
@@ -3906,7 +3906,7 @@
                   <a:tcPr marL="128016" marR="128016" marT="54864" marB="54864" anchor="ctr">
                     <a:lnL w="12700" cap="flat" cmpd="sng" algn="ctr">
                       <a:solidFill>
-                        <a:srgbClr val="D5DEE9"/>
+                        <a:srgbClr val="DDDDDD"/>
                       </a:solidFill>
                       <a:prstDash val="solid"/>
                       <a:round/>
@@ -3915,7 +3915,7 @@
                     </a:lnL>
                     <a:lnR w="12700" cap="flat" cmpd="sng" algn="ctr">
                       <a:solidFill>
-                        <a:srgbClr val="D5DEE9"/>
+                        <a:srgbClr val="DDDDDD"/>
                       </a:solidFill>
                       <a:prstDash val="solid"/>
                       <a:round/>
@@ -3924,7 +3924,7 @@
                     </a:lnR>
                     <a:lnT w="12700" cap="flat" cmpd="sng" algn="ctr">
                       <a:solidFill>
-                        <a:srgbClr val="D5DEE9"/>
+                        <a:srgbClr val="DDDDDD"/>
                       </a:solidFill>
                       <a:prstDash val="solid"/>
                       <a:round/>
@@ -3933,7 +3933,7 @@
                     </a:lnT>
                     <a:lnB w="12700" cap="flat" cmpd="sng" algn="ctr">
                       <a:solidFill>
-                        <a:srgbClr val="D5DEE9"/>
+                        <a:srgbClr val="DDDDDD"/>
                       </a:solidFill>
                       <a:prstDash val="solid"/>
                       <a:round/>
@@ -3941,7 +3941,7 @@
                       <a:tailEnd type="none" w="med" len="med"/>
                     </a:lnB>
                     <a:solidFill>
-                      <a:srgbClr val="16233F"/>
+                      <a:srgbClr val="222222"/>
                     </a:solidFill>
                   </a:tcPr>
                 </a:tc>
@@ -3974,7 +3974,7 @@
                   <a:tcPr marL="128016" marR="128016" marT="54864" marB="54864" anchor="ctr">
                     <a:lnL w="12700" cap="flat" cmpd="sng" algn="ctr">
                       <a:solidFill>
-                        <a:srgbClr val="D5DEE9"/>
+                        <a:srgbClr val="DDDDDD"/>
                       </a:solidFill>
                       <a:prstDash val="solid"/>
                       <a:round/>
@@ -3983,7 +3983,7 @@
                     </a:lnL>
                     <a:lnR w="12700" cap="flat" cmpd="sng" algn="ctr">
                       <a:solidFill>
-                        <a:srgbClr val="D5DEE9"/>
+                        <a:srgbClr val="DDDDDD"/>
                       </a:solidFill>
                       <a:prstDash val="solid"/>
                       <a:round/>
@@ -3992,7 +3992,7 @@
                     </a:lnR>
                     <a:lnT w="12700" cap="flat" cmpd="sng" algn="ctr">
                       <a:solidFill>
-                        <a:srgbClr val="D5DEE9"/>
+                        <a:srgbClr val="DDDDDD"/>
                       </a:solidFill>
                       <a:prstDash val="solid"/>
                       <a:round/>
@@ -4001,7 +4001,7 @@
                     </a:lnT>
                     <a:lnB w="12700" cap="flat" cmpd="sng" algn="ctr">
                       <a:solidFill>
-                        <a:srgbClr val="D5DEE9"/>
+                        <a:srgbClr val="DDDDDD"/>
                       </a:solidFill>
                       <a:prstDash val="solid"/>
                       <a:round/>
@@ -4009,7 +4009,7 @@
                       <a:tailEnd type="none" w="med" len="med"/>
                     </a:lnB>
                     <a:solidFill>
-                      <a:srgbClr val="16233F"/>
+                      <a:srgbClr val="222222"/>
                     </a:solidFill>
                   </a:tcPr>
                 </a:tc>
@@ -4026,7 +4026,7 @@
                       <a:r>
                         <a:rPr lang="en-US" sz="1500" b="1" dirty="0">
                           <a:solidFill>
-                            <a:srgbClr val="378ADD"/>
+                            <a:srgbClr val="7B7B7B"/>
                           </a:solidFill>
                           <a:latin typeface="Calibri" pitchFamily="34" charset="0"/>
                           <a:ea typeface="Calibri" pitchFamily="34" charset="-122"/>
@@ -4044,7 +4044,7 @@
                   <a:tcPr marL="128016" marR="128016" marT="54864" marB="54864" anchor="ctr">
                     <a:lnL w="12700" cap="flat" cmpd="sng" algn="ctr">
                       <a:solidFill>
-                        <a:srgbClr val="D5DEE9"/>
+                        <a:srgbClr val="DDDDDD"/>
                       </a:solidFill>
                       <a:prstDash val="solid"/>
                       <a:round/>
@@ -4053,7 +4053,7 @@
                     </a:lnL>
                     <a:lnR w="12700" cap="flat" cmpd="sng" algn="ctr">
                       <a:solidFill>
-                        <a:srgbClr val="D5DEE9"/>
+                        <a:srgbClr val="DDDDDD"/>
                       </a:solidFill>
                       <a:prstDash val="solid"/>
                       <a:round/>
@@ -4062,7 +4062,7 @@
                     </a:lnR>
                     <a:lnT w="12700" cap="flat" cmpd="sng" algn="ctr">
                       <a:solidFill>
-                        <a:srgbClr val="D5DEE9"/>
+                        <a:srgbClr val="DDDDDD"/>
                       </a:solidFill>
                       <a:prstDash val="solid"/>
                       <a:round/>
@@ -4071,7 +4071,7 @@
                     </a:lnT>
                     <a:lnB w="12700" cap="flat" cmpd="sng" algn="ctr">
                       <a:solidFill>
-                        <a:srgbClr val="D5DEE9"/>
+                        <a:srgbClr val="DDDDDD"/>
                       </a:solidFill>
                       <a:prstDash val="solid"/>
                       <a:round/>
@@ -4079,7 +4079,7 @@
                       <a:tailEnd type="none" w="med" len="med"/>
                     </a:lnB>
                     <a:solidFill>
-                      <a:srgbClr val="EEF3F9"/>
+                      <a:srgbClr val="F2F2F2"/>
                     </a:solidFill>
                   </a:tcPr>
                 </a:tc>
@@ -4094,7 +4094,7 @@
                       <a:r>
                         <a:rPr lang="en-US" sz="1500" dirty="0">
                           <a:solidFill>
-                            <a:srgbClr val="11182B"/>
+                            <a:srgbClr val="181818"/>
                           </a:solidFill>
                           <a:latin typeface="Calibri" pitchFamily="34" charset="0"/>
                           <a:ea typeface="Calibri" pitchFamily="34" charset="-122"/>
@@ -4112,7 +4112,7 @@
                   <a:tcPr marL="128016" marR="128016" marT="54864" marB="54864" anchor="ctr">
                     <a:lnL w="12700" cap="flat" cmpd="sng" algn="ctr">
                       <a:solidFill>
-                        <a:srgbClr val="D5DEE9"/>
+                        <a:srgbClr val="DDDDDD"/>
                       </a:solidFill>
                       <a:prstDash val="solid"/>
                       <a:round/>
@@ -4121,7 +4121,7 @@
                     </a:lnL>
                     <a:lnR w="12700" cap="flat" cmpd="sng" algn="ctr">
                       <a:solidFill>
-                        <a:srgbClr val="D5DEE9"/>
+                        <a:srgbClr val="DDDDDD"/>
                       </a:solidFill>
                       <a:prstDash val="solid"/>
                       <a:round/>
@@ -4130,7 +4130,7 @@
                     </a:lnR>
                     <a:lnT w="12700" cap="flat" cmpd="sng" algn="ctr">
                       <a:solidFill>
-                        <a:srgbClr val="D5DEE9"/>
+                        <a:srgbClr val="DDDDDD"/>
                       </a:solidFill>
                       <a:prstDash val="solid"/>
                       <a:round/>
@@ -4139,7 +4139,7 @@
                     </a:lnT>
                     <a:lnB w="12700" cap="flat" cmpd="sng" algn="ctr">
                       <a:solidFill>
-                        <a:srgbClr val="D5DEE9"/>
+                        <a:srgbClr val="DDDDDD"/>
                       </a:solidFill>
                       <a:prstDash val="solid"/>
                       <a:round/>
@@ -4147,7 +4147,7 @@
                       <a:tailEnd type="none" w="med" len="med"/>
                     </a:lnB>
                     <a:solidFill>
-                      <a:srgbClr val="EEF3F9"/>
+                      <a:srgbClr val="F2F2F2"/>
                     </a:solidFill>
                   </a:tcPr>
                 </a:tc>
@@ -4162,7 +4162,7 @@
                       <a:r>
                         <a:rPr lang="en-US" sz="1500" dirty="0">
                           <a:solidFill>
-                            <a:srgbClr val="11182B"/>
+                            <a:srgbClr val="181818"/>
                           </a:solidFill>
                           <a:latin typeface="Calibri" pitchFamily="34" charset="0"/>
                           <a:ea typeface="Calibri" pitchFamily="34" charset="-122"/>
@@ -4180,7 +4180,7 @@
                   <a:tcPr marL="128016" marR="128016" marT="54864" marB="54864" anchor="ctr">
                     <a:lnL w="12700" cap="flat" cmpd="sng" algn="ctr">
                       <a:solidFill>
-                        <a:srgbClr val="D5DEE9"/>
+                        <a:srgbClr val="DDDDDD"/>
                       </a:solidFill>
                       <a:prstDash val="solid"/>
                       <a:round/>
@@ -4189,7 +4189,7 @@
                     </a:lnL>
                     <a:lnR w="12700" cap="flat" cmpd="sng" algn="ctr">
                       <a:solidFill>
-                        <a:srgbClr val="D5DEE9"/>
+                        <a:srgbClr val="DDDDDD"/>
                       </a:solidFill>
                       <a:prstDash val="solid"/>
                       <a:round/>
@@ -4198,7 +4198,7 @@
                     </a:lnR>
                     <a:lnT w="12700" cap="flat" cmpd="sng" algn="ctr">
                       <a:solidFill>
-                        <a:srgbClr val="D5DEE9"/>
+                        <a:srgbClr val="DDDDDD"/>
                       </a:solidFill>
                       <a:prstDash val="solid"/>
                       <a:round/>
@@ -4207,7 +4207,7 @@
                     </a:lnT>
                     <a:lnB w="12700" cap="flat" cmpd="sng" algn="ctr">
                       <a:solidFill>
-                        <a:srgbClr val="D5DEE9"/>
+                        <a:srgbClr val="DDDDDD"/>
                       </a:solidFill>
                       <a:prstDash val="solid"/>
                       <a:round/>
@@ -4215,7 +4215,7 @@
                       <a:tailEnd type="none" w="med" len="med"/>
                     </a:lnB>
                     <a:solidFill>
-                      <a:srgbClr val="EEF3F9"/>
+                      <a:srgbClr val="F2F2F2"/>
                     </a:solidFill>
                   </a:tcPr>
                 </a:tc>
@@ -4230,7 +4230,7 @@
                       <a:r>
                         <a:rPr lang="en-US" sz="1500" dirty="0">
                           <a:solidFill>
-                            <a:srgbClr val="11182B"/>
+                            <a:srgbClr val="181818"/>
                           </a:solidFill>
                           <a:latin typeface="Calibri" pitchFamily="34" charset="0"/>
                           <a:ea typeface="Calibri" pitchFamily="34" charset="-122"/>
@@ -4248,7 +4248,7 @@
                   <a:tcPr marL="128016" marR="128016" marT="54864" marB="54864" anchor="ctr">
                     <a:lnL w="12700" cap="flat" cmpd="sng" algn="ctr">
                       <a:solidFill>
-                        <a:srgbClr val="D5DEE9"/>
+                        <a:srgbClr val="DDDDDD"/>
                       </a:solidFill>
                       <a:prstDash val="solid"/>
                       <a:round/>
@@ -4257,7 +4257,7 @@
                     </a:lnL>
                     <a:lnR w="12700" cap="flat" cmpd="sng" algn="ctr">
                       <a:solidFill>
-                        <a:srgbClr val="D5DEE9"/>
+                        <a:srgbClr val="DDDDDD"/>
                       </a:solidFill>
                       <a:prstDash val="solid"/>
                       <a:round/>
@@ -4266,7 +4266,7 @@
                     </a:lnR>
                     <a:lnT w="12700" cap="flat" cmpd="sng" algn="ctr">
                       <a:solidFill>
-                        <a:srgbClr val="D5DEE9"/>
+                        <a:srgbClr val="DDDDDD"/>
                       </a:solidFill>
                       <a:prstDash val="solid"/>
                       <a:round/>
@@ -4275,7 +4275,7 @@
                     </a:lnT>
                     <a:lnB w="12700" cap="flat" cmpd="sng" algn="ctr">
                       <a:solidFill>
-                        <a:srgbClr val="D5DEE9"/>
+                        <a:srgbClr val="DDDDDD"/>
                       </a:solidFill>
                       <a:prstDash val="solid"/>
                       <a:round/>
@@ -4283,7 +4283,7 @@
                       <a:tailEnd type="none" w="med" len="med"/>
                     </a:lnB>
                     <a:solidFill>
-                      <a:srgbClr val="EEF3F9"/>
+                      <a:srgbClr val="F2F2F2"/>
                     </a:solidFill>
                   </a:tcPr>
                 </a:tc>
@@ -4298,7 +4298,7 @@
                       <a:r>
                         <a:rPr lang="en-US" sz="1500" dirty="0">
                           <a:solidFill>
-                            <a:srgbClr val="11182B"/>
+                            <a:srgbClr val="181818"/>
                           </a:solidFill>
                           <a:latin typeface="Calibri" pitchFamily="34" charset="0"/>
                           <a:ea typeface="Calibri" pitchFamily="34" charset="-122"/>
@@ -4316,7 +4316,7 @@
                   <a:tcPr marL="128016" marR="128016" marT="54864" marB="54864" anchor="ctr">
                     <a:lnL w="12700" cap="flat" cmpd="sng" algn="ctr">
                       <a:solidFill>
-                        <a:srgbClr val="D5DEE9"/>
+                        <a:srgbClr val="DDDDDD"/>
                       </a:solidFill>
                       <a:prstDash val="solid"/>
                       <a:round/>
@@ -4325,7 +4325,7 @@
                     </a:lnL>
                     <a:lnR w="12700" cap="flat" cmpd="sng" algn="ctr">
                       <a:solidFill>
-                        <a:srgbClr val="D5DEE9"/>
+                        <a:srgbClr val="DDDDDD"/>
                       </a:solidFill>
                       <a:prstDash val="solid"/>
                       <a:round/>
@@ -4334,7 +4334,7 @@
                     </a:lnR>
                     <a:lnT w="12700" cap="flat" cmpd="sng" algn="ctr">
                       <a:solidFill>
-                        <a:srgbClr val="D5DEE9"/>
+                        <a:srgbClr val="DDDDDD"/>
                       </a:solidFill>
                       <a:prstDash val="solid"/>
                       <a:round/>
@@ -4343,7 +4343,7 @@
                     </a:lnT>
                     <a:lnB w="12700" cap="flat" cmpd="sng" algn="ctr">
                       <a:solidFill>
-                        <a:srgbClr val="D5DEE9"/>
+                        <a:srgbClr val="DDDDDD"/>
                       </a:solidFill>
                       <a:prstDash val="solid"/>
                       <a:round/>
@@ -4351,7 +4351,7 @@
                       <a:tailEnd type="none" w="med" len="med"/>
                     </a:lnB>
                     <a:solidFill>
-                      <a:srgbClr val="EEF3F9"/>
+                      <a:srgbClr val="F2F2F2"/>
                     </a:solidFill>
                   </a:tcPr>
                 </a:tc>
@@ -4368,7 +4368,7 @@
                       <a:r>
                         <a:rPr lang="en-US" sz="1500" b="1" dirty="0">
                           <a:solidFill>
-                            <a:srgbClr val="378ADD"/>
+                            <a:srgbClr val="7B7B7B"/>
                           </a:solidFill>
                           <a:latin typeface="Calibri" pitchFamily="34" charset="0"/>
                           <a:ea typeface="Calibri" pitchFamily="34" charset="-122"/>
@@ -4386,7 +4386,7 @@
                   <a:tcPr marL="128016" marR="128016" marT="54864" marB="54864" anchor="ctr">
                     <a:lnL w="12700" cap="flat" cmpd="sng" algn="ctr">
                       <a:solidFill>
-                        <a:srgbClr val="D5DEE9"/>
+                        <a:srgbClr val="DDDDDD"/>
                       </a:solidFill>
                       <a:prstDash val="solid"/>
                       <a:round/>
@@ -4395,7 +4395,7 @@
                     </a:lnL>
                     <a:lnR w="12700" cap="flat" cmpd="sng" algn="ctr">
                       <a:solidFill>
-                        <a:srgbClr val="D5DEE9"/>
+                        <a:srgbClr val="DDDDDD"/>
                       </a:solidFill>
                       <a:prstDash val="solid"/>
                       <a:round/>
@@ -4404,7 +4404,7 @@
                     </a:lnR>
                     <a:lnT w="12700" cap="flat" cmpd="sng" algn="ctr">
                       <a:solidFill>
-                        <a:srgbClr val="D5DEE9"/>
+                        <a:srgbClr val="DDDDDD"/>
                       </a:solidFill>
                       <a:prstDash val="solid"/>
                       <a:round/>
@@ -4413,7 +4413,7 @@
                     </a:lnT>
                     <a:lnB w="12700" cap="flat" cmpd="sng" algn="ctr">
                       <a:solidFill>
-                        <a:srgbClr val="D5DEE9"/>
+                        <a:srgbClr val="DDDDDD"/>
                       </a:solidFill>
                       <a:prstDash val="solid"/>
                       <a:round/>
@@ -4436,7 +4436,7 @@
                       <a:r>
                         <a:rPr lang="en-US" sz="1500" dirty="0">
                           <a:solidFill>
-                            <a:srgbClr val="11182B"/>
+                            <a:srgbClr val="181818"/>
                           </a:solidFill>
                           <a:latin typeface="Calibri" pitchFamily="34" charset="0"/>
                           <a:ea typeface="Calibri" pitchFamily="34" charset="-122"/>
@@ -4454,7 +4454,7 @@
                   <a:tcPr marL="128016" marR="128016" marT="54864" marB="54864" anchor="ctr">
                     <a:lnL w="12700" cap="flat" cmpd="sng" algn="ctr">
                       <a:solidFill>
-                        <a:srgbClr val="D5DEE9"/>
+                        <a:srgbClr val="DDDDDD"/>
                       </a:solidFill>
                       <a:prstDash val="solid"/>
                       <a:round/>
@@ -4463,7 +4463,7 @@
                     </a:lnL>
                     <a:lnR w="12700" cap="flat" cmpd="sng" algn="ctr">
                       <a:solidFill>
-                        <a:srgbClr val="D5DEE9"/>
+                        <a:srgbClr val="DDDDDD"/>
                       </a:solidFill>
                       <a:prstDash val="solid"/>
                       <a:round/>
@@ -4472,7 +4472,7 @@
                     </a:lnR>
                     <a:lnT w="12700" cap="flat" cmpd="sng" algn="ctr">
                       <a:solidFill>
-                        <a:srgbClr val="D5DEE9"/>
+                        <a:srgbClr val="DDDDDD"/>
                       </a:solidFill>
                       <a:prstDash val="solid"/>
                       <a:round/>
@@ -4481,7 +4481,7 @@
                     </a:lnT>
                     <a:lnB w="12700" cap="flat" cmpd="sng" algn="ctr">
                       <a:solidFill>
-                        <a:srgbClr val="D5DEE9"/>
+                        <a:srgbClr val="DDDDDD"/>
                       </a:solidFill>
                       <a:prstDash val="solid"/>
                       <a:round/>
@@ -4504,7 +4504,7 @@
                       <a:r>
                         <a:rPr lang="en-US" sz="1500" dirty="0">
                           <a:solidFill>
-                            <a:srgbClr val="11182B"/>
+                            <a:srgbClr val="181818"/>
                           </a:solidFill>
                           <a:latin typeface="Calibri" pitchFamily="34" charset="0"/>
                           <a:ea typeface="Calibri" pitchFamily="34" charset="-122"/>
@@ -4522,7 +4522,7 @@
                   <a:tcPr marL="128016" marR="128016" marT="54864" marB="54864" anchor="ctr">
                     <a:lnL w="12700" cap="flat" cmpd="sng" algn="ctr">
                       <a:solidFill>
-                        <a:srgbClr val="D5DEE9"/>
+                        <a:srgbClr val="DDDDDD"/>
                       </a:solidFill>
                       <a:prstDash val="solid"/>
                       <a:round/>
@@ -4531,7 +4531,7 @@
                     </a:lnL>
                     <a:lnR w="12700" cap="flat" cmpd="sng" algn="ctr">
                       <a:solidFill>
-                        <a:srgbClr val="D5DEE9"/>
+                        <a:srgbClr val="DDDDDD"/>
                       </a:solidFill>
                       <a:prstDash val="solid"/>
                       <a:round/>
@@ -4540,7 +4540,7 @@
                     </a:lnR>
                     <a:lnT w="12700" cap="flat" cmpd="sng" algn="ctr">
                       <a:solidFill>
-                        <a:srgbClr val="D5DEE9"/>
+                        <a:srgbClr val="DDDDDD"/>
                       </a:solidFill>
                       <a:prstDash val="solid"/>
                       <a:round/>
@@ -4549,7 +4549,7 @@
                     </a:lnT>
                     <a:lnB w="12700" cap="flat" cmpd="sng" algn="ctr">
                       <a:solidFill>
-                        <a:srgbClr val="D5DEE9"/>
+                        <a:srgbClr val="DDDDDD"/>
                       </a:solidFill>
                       <a:prstDash val="solid"/>
                       <a:round/>
@@ -4572,7 +4572,7 @@
                       <a:r>
                         <a:rPr lang="en-US" sz="1500" dirty="0">
                           <a:solidFill>
-                            <a:srgbClr val="11182B"/>
+                            <a:srgbClr val="181818"/>
                           </a:solidFill>
                           <a:latin typeface="Calibri" pitchFamily="34" charset="0"/>
                           <a:ea typeface="Calibri" pitchFamily="34" charset="-122"/>
@@ -4590,7 +4590,7 @@
                   <a:tcPr marL="128016" marR="128016" marT="54864" marB="54864" anchor="ctr">
                     <a:lnL w="12700" cap="flat" cmpd="sng" algn="ctr">
                       <a:solidFill>
-                        <a:srgbClr val="D5DEE9"/>
+                        <a:srgbClr val="DDDDDD"/>
                       </a:solidFill>
                       <a:prstDash val="solid"/>
                       <a:round/>
@@ -4599,7 +4599,7 @@
                     </a:lnL>
                     <a:lnR w="12700" cap="flat" cmpd="sng" algn="ctr">
                       <a:solidFill>
-                        <a:srgbClr val="D5DEE9"/>
+                        <a:srgbClr val="DDDDDD"/>
                       </a:solidFill>
                       <a:prstDash val="solid"/>
                       <a:round/>
@@ -4608,7 +4608,7 @@
                     </a:lnR>
                     <a:lnT w="12700" cap="flat" cmpd="sng" algn="ctr">
                       <a:solidFill>
-                        <a:srgbClr val="D5DEE9"/>
+                        <a:srgbClr val="DDDDDD"/>
                       </a:solidFill>
                       <a:prstDash val="solid"/>
                       <a:round/>
@@ -4617,7 +4617,7 @@
                     </a:lnT>
                     <a:lnB w="12700" cap="flat" cmpd="sng" algn="ctr">
                       <a:solidFill>
-                        <a:srgbClr val="D5DEE9"/>
+                        <a:srgbClr val="DDDDDD"/>
                       </a:solidFill>
                       <a:prstDash val="solid"/>
                       <a:round/>
@@ -4640,7 +4640,7 @@
                       <a:r>
                         <a:rPr lang="en-US" sz="1500" dirty="0">
                           <a:solidFill>
-                            <a:srgbClr val="11182B"/>
+                            <a:srgbClr val="181818"/>
                           </a:solidFill>
                           <a:latin typeface="Calibri" pitchFamily="34" charset="0"/>
                           <a:ea typeface="Calibri" pitchFamily="34" charset="-122"/>
@@ -4658,7 +4658,7 @@
                   <a:tcPr marL="128016" marR="128016" marT="54864" marB="54864" anchor="ctr">
                     <a:lnL w="12700" cap="flat" cmpd="sng" algn="ctr">
                       <a:solidFill>
-                        <a:srgbClr val="D5DEE9"/>
+                        <a:srgbClr val="DDDDDD"/>
                       </a:solidFill>
                       <a:prstDash val="solid"/>
                       <a:round/>
@@ -4667,7 +4667,7 @@
                     </a:lnL>
                     <a:lnR w="12700" cap="flat" cmpd="sng" algn="ctr">
                       <a:solidFill>
-                        <a:srgbClr val="D5DEE9"/>
+                        <a:srgbClr val="DDDDDD"/>
                       </a:solidFill>
                       <a:prstDash val="solid"/>
                       <a:round/>
@@ -4676,7 +4676,7 @@
                     </a:lnR>
                     <a:lnT w="12700" cap="flat" cmpd="sng" algn="ctr">
                       <a:solidFill>
-                        <a:srgbClr val="D5DEE9"/>
+                        <a:srgbClr val="DDDDDD"/>
                       </a:solidFill>
                       <a:prstDash val="solid"/>
                       <a:round/>
@@ -4685,7 +4685,7 @@
                     </a:lnT>
                     <a:lnB w="12700" cap="flat" cmpd="sng" algn="ctr">
                       <a:solidFill>
-                        <a:srgbClr val="D5DEE9"/>
+                        <a:srgbClr val="DDDDDD"/>
                       </a:solidFill>
                       <a:prstDash val="solid"/>
                       <a:round/>
@@ -4710,7 +4710,7 @@
                       <a:r>
                         <a:rPr lang="en-US" sz="1500" b="1" dirty="0">
                           <a:solidFill>
-                            <a:srgbClr val="378ADD"/>
+                            <a:srgbClr val="7B7B7B"/>
                           </a:solidFill>
                           <a:latin typeface="Calibri" pitchFamily="34" charset="0"/>
                           <a:ea typeface="Calibri" pitchFamily="34" charset="-122"/>
@@ -4728,7 +4728,7 @@
                   <a:tcPr marL="128016" marR="128016" marT="54864" marB="54864" anchor="ctr">
                     <a:lnL w="12700" cap="flat" cmpd="sng" algn="ctr">
                       <a:solidFill>
-                        <a:srgbClr val="D5DEE9"/>
+                        <a:srgbClr val="DDDDDD"/>
                       </a:solidFill>
                       <a:prstDash val="solid"/>
                       <a:round/>
@@ -4737,7 +4737,7 @@
                     </a:lnL>
                     <a:lnR w="12700" cap="flat" cmpd="sng" algn="ctr">
                       <a:solidFill>
-                        <a:srgbClr val="D5DEE9"/>
+                        <a:srgbClr val="DDDDDD"/>
                       </a:solidFill>
                       <a:prstDash val="solid"/>
                       <a:round/>
@@ -4746,7 +4746,7 @@
                     </a:lnR>
                     <a:lnT w="12700" cap="flat" cmpd="sng" algn="ctr">
                       <a:solidFill>
-                        <a:srgbClr val="D5DEE9"/>
+                        <a:srgbClr val="DDDDDD"/>
                       </a:solidFill>
                       <a:prstDash val="solid"/>
                       <a:round/>
@@ -4755,7 +4755,7 @@
                     </a:lnT>
                     <a:lnB w="12700" cap="flat" cmpd="sng" algn="ctr">
                       <a:solidFill>
-                        <a:srgbClr val="D5DEE9"/>
+                        <a:srgbClr val="DDDDDD"/>
                       </a:solidFill>
                       <a:prstDash val="solid"/>
                       <a:round/>
@@ -4763,7 +4763,7 @@
                       <a:tailEnd type="none" w="med" len="med"/>
                     </a:lnB>
                     <a:solidFill>
-                      <a:srgbClr val="EEF3F9"/>
+                      <a:srgbClr val="F2F2F2"/>
                     </a:solidFill>
                   </a:tcPr>
                 </a:tc>
@@ -4778,7 +4778,7 @@
                       <a:r>
                         <a:rPr lang="en-US" sz="1500" dirty="0">
                           <a:solidFill>
-                            <a:srgbClr val="11182B"/>
+                            <a:srgbClr val="181818"/>
                           </a:solidFill>
                           <a:latin typeface="Calibri" pitchFamily="34" charset="0"/>
                           <a:ea typeface="Calibri" pitchFamily="34" charset="-122"/>
@@ -4796,7 +4796,7 @@
                   <a:tcPr marL="128016" marR="128016" marT="54864" marB="54864" anchor="ctr">
                     <a:lnL w="12700" cap="flat" cmpd="sng" algn="ctr">
                       <a:solidFill>
-                        <a:srgbClr val="D5DEE9"/>
+                        <a:srgbClr val="DDDDDD"/>
                       </a:solidFill>
                       <a:prstDash val="solid"/>
                       <a:round/>
@@ -4805,7 +4805,7 @@
                     </a:lnL>
                     <a:lnR w="12700" cap="flat" cmpd="sng" algn="ctr">
                       <a:solidFill>
-                        <a:srgbClr val="D5DEE9"/>
+                        <a:srgbClr val="DDDDDD"/>
                       </a:solidFill>
                       <a:prstDash val="solid"/>
                       <a:round/>
@@ -4814,7 +4814,7 @@
                     </a:lnR>
                     <a:lnT w="12700" cap="flat" cmpd="sng" algn="ctr">
                       <a:solidFill>
-                        <a:srgbClr val="D5DEE9"/>
+                        <a:srgbClr val="DDDDDD"/>
                       </a:solidFill>
                       <a:prstDash val="solid"/>
                       <a:round/>
@@ -4823,7 +4823,7 @@
                     </a:lnT>
                     <a:lnB w="12700" cap="flat" cmpd="sng" algn="ctr">
                       <a:solidFill>
-                        <a:srgbClr val="D5DEE9"/>
+                        <a:srgbClr val="DDDDDD"/>
                       </a:solidFill>
                       <a:prstDash val="solid"/>
                       <a:round/>
@@ -4831,7 +4831,7 @@
                       <a:tailEnd type="none" w="med" len="med"/>
                     </a:lnB>
                     <a:solidFill>
-                      <a:srgbClr val="EEF3F9"/>
+                      <a:srgbClr val="F2F2F2"/>
                     </a:solidFill>
                   </a:tcPr>
                 </a:tc>
@@ -4846,7 +4846,7 @@
                       <a:r>
                         <a:rPr lang="en-US" sz="1500" dirty="0">
                           <a:solidFill>
-                            <a:srgbClr val="11182B"/>
+                            <a:srgbClr val="181818"/>
                           </a:solidFill>
                           <a:latin typeface="Calibri" pitchFamily="34" charset="0"/>
                           <a:ea typeface="Calibri" pitchFamily="34" charset="-122"/>
@@ -4864,7 +4864,7 @@
                   <a:tcPr marL="128016" marR="128016" marT="54864" marB="54864" anchor="ctr">
                     <a:lnL w="12700" cap="flat" cmpd="sng" algn="ctr">
                       <a:solidFill>
-                        <a:srgbClr val="D5DEE9"/>
+                        <a:srgbClr val="DDDDDD"/>
                       </a:solidFill>
                       <a:prstDash val="solid"/>
                       <a:round/>
@@ -4873,7 +4873,7 @@
                     </a:lnL>
                     <a:lnR w="12700" cap="flat" cmpd="sng" algn="ctr">
                       <a:solidFill>
-                        <a:srgbClr val="D5DEE9"/>
+                        <a:srgbClr val="DDDDDD"/>
                       </a:solidFill>
                       <a:prstDash val="solid"/>
                       <a:round/>
@@ -4882,7 +4882,7 @@
                     </a:lnR>
                     <a:lnT w="12700" cap="flat" cmpd="sng" algn="ctr">
                       <a:solidFill>
-                        <a:srgbClr val="D5DEE9"/>
+                        <a:srgbClr val="DDDDDD"/>
                       </a:solidFill>
                       <a:prstDash val="solid"/>
                       <a:round/>
@@ -4891,7 +4891,7 @@
                     </a:lnT>
                     <a:lnB w="12700" cap="flat" cmpd="sng" algn="ctr">
                       <a:solidFill>
-                        <a:srgbClr val="D5DEE9"/>
+                        <a:srgbClr val="DDDDDD"/>
                       </a:solidFill>
                       <a:prstDash val="solid"/>
                       <a:round/>
@@ -4899,7 +4899,7 @@
                       <a:tailEnd type="none" w="med" len="med"/>
                     </a:lnB>
                     <a:solidFill>
-                      <a:srgbClr val="EEF3F9"/>
+                      <a:srgbClr val="F2F2F2"/>
                     </a:solidFill>
                   </a:tcPr>
                 </a:tc>
@@ -4914,7 +4914,7 @@
                       <a:r>
                         <a:rPr lang="en-US" sz="1500" dirty="0">
                           <a:solidFill>
-                            <a:srgbClr val="11182B"/>
+                            <a:srgbClr val="181818"/>
                           </a:solidFill>
                           <a:latin typeface="Calibri" pitchFamily="34" charset="0"/>
                           <a:ea typeface="Calibri" pitchFamily="34" charset="-122"/>
@@ -4932,7 +4932,7 @@
                   <a:tcPr marL="128016" marR="128016" marT="54864" marB="54864" anchor="ctr">
                     <a:lnL w="12700" cap="flat" cmpd="sng" algn="ctr">
                       <a:solidFill>
-                        <a:srgbClr val="D5DEE9"/>
+                        <a:srgbClr val="DDDDDD"/>
                       </a:solidFill>
                       <a:prstDash val="solid"/>
                       <a:round/>
@@ -4941,7 +4941,7 @@
                     </a:lnL>
                     <a:lnR w="12700" cap="flat" cmpd="sng" algn="ctr">
                       <a:solidFill>
-                        <a:srgbClr val="D5DEE9"/>
+                        <a:srgbClr val="DDDDDD"/>
                       </a:solidFill>
                       <a:prstDash val="solid"/>
                       <a:round/>
@@ -4950,7 +4950,7 @@
                     </a:lnR>
                     <a:lnT w="12700" cap="flat" cmpd="sng" algn="ctr">
                       <a:solidFill>
-                        <a:srgbClr val="D5DEE9"/>
+                        <a:srgbClr val="DDDDDD"/>
                       </a:solidFill>
                       <a:prstDash val="solid"/>
                       <a:round/>
@@ -4959,7 +4959,7 @@
                     </a:lnT>
                     <a:lnB w="12700" cap="flat" cmpd="sng" algn="ctr">
                       <a:solidFill>
-                        <a:srgbClr val="D5DEE9"/>
+                        <a:srgbClr val="DDDDDD"/>
                       </a:solidFill>
                       <a:prstDash val="solid"/>
                       <a:round/>
@@ -4967,7 +4967,7 @@
                       <a:tailEnd type="none" w="med" len="med"/>
                     </a:lnB>
                     <a:solidFill>
-                      <a:srgbClr val="EEF3F9"/>
+                      <a:srgbClr val="F2F2F2"/>
                     </a:solidFill>
                   </a:tcPr>
                 </a:tc>
@@ -4982,7 +4982,7 @@
                       <a:r>
                         <a:rPr lang="en-US" sz="1500" dirty="0">
                           <a:solidFill>
-                            <a:srgbClr val="11182B"/>
+                            <a:srgbClr val="181818"/>
                           </a:solidFill>
                           <a:latin typeface="Calibri" pitchFamily="34" charset="0"/>
                           <a:ea typeface="Calibri" pitchFamily="34" charset="-122"/>
@@ -5000,7 +5000,7 @@
                   <a:tcPr marL="128016" marR="128016" marT="54864" marB="54864" anchor="ctr">
                     <a:lnL w="12700" cap="flat" cmpd="sng" algn="ctr">
                       <a:solidFill>
-                        <a:srgbClr val="D5DEE9"/>
+                        <a:srgbClr val="DDDDDD"/>
                       </a:solidFill>
                       <a:prstDash val="solid"/>
                       <a:round/>
@@ -5009,7 +5009,7 @@
                     </a:lnL>
                     <a:lnR w="12700" cap="flat" cmpd="sng" algn="ctr">
                       <a:solidFill>
-                        <a:srgbClr val="D5DEE9"/>
+                        <a:srgbClr val="DDDDDD"/>
                       </a:solidFill>
                       <a:prstDash val="solid"/>
                       <a:round/>
@@ -5018,7 +5018,7 @@
                     </a:lnR>
                     <a:lnT w="12700" cap="flat" cmpd="sng" algn="ctr">
                       <a:solidFill>
-                        <a:srgbClr val="D5DEE9"/>
+                        <a:srgbClr val="DDDDDD"/>
                       </a:solidFill>
                       <a:prstDash val="solid"/>
                       <a:round/>
@@ -5027,7 +5027,7 @@
                     </a:lnT>
                     <a:lnB w="12700" cap="flat" cmpd="sng" algn="ctr">
                       <a:solidFill>
-                        <a:srgbClr val="D5DEE9"/>
+                        <a:srgbClr val="DDDDDD"/>
                       </a:solidFill>
                       <a:prstDash val="solid"/>
                       <a:round/>
@@ -5035,7 +5035,7 @@
                       <a:tailEnd type="none" w="med" len="med"/>
                     </a:lnB>
                     <a:solidFill>
-                      <a:srgbClr val="EEF3F9"/>
+                      <a:srgbClr val="F2F2F2"/>
                     </a:solidFill>
                   </a:tcPr>
                 </a:tc>
@@ -5052,7 +5052,7 @@
                       <a:r>
                         <a:rPr lang="en-US" sz="1500" b="1" dirty="0">
                           <a:solidFill>
-                            <a:srgbClr val="378ADD"/>
+                            <a:srgbClr val="7B7B7B"/>
                           </a:solidFill>
                           <a:latin typeface="Calibri" pitchFamily="34" charset="0"/>
                           <a:ea typeface="Calibri" pitchFamily="34" charset="-122"/>
@@ -5070,7 +5070,7 @@
                   <a:tcPr marL="128016" marR="128016" marT="54864" marB="54864" anchor="ctr">
                     <a:lnL w="12700" cap="flat" cmpd="sng" algn="ctr">
                       <a:solidFill>
-                        <a:srgbClr val="D5DEE9"/>
+                        <a:srgbClr val="DDDDDD"/>
                       </a:solidFill>
                       <a:prstDash val="solid"/>
                       <a:round/>
@@ -5079,7 +5079,7 @@
                     </a:lnL>
                     <a:lnR w="12700" cap="flat" cmpd="sng" algn="ctr">
                       <a:solidFill>
-                        <a:srgbClr val="D5DEE9"/>
+                        <a:srgbClr val="DDDDDD"/>
                       </a:solidFill>
                       <a:prstDash val="solid"/>
                       <a:round/>
@@ -5088,7 +5088,7 @@
                     </a:lnR>
                     <a:lnT w="12700" cap="flat" cmpd="sng" algn="ctr">
                       <a:solidFill>
-                        <a:srgbClr val="D5DEE9"/>
+                        <a:srgbClr val="DDDDDD"/>
                       </a:solidFill>
                       <a:prstDash val="solid"/>
                       <a:round/>
@@ -5097,7 +5097,7 @@
                     </a:lnT>
                     <a:lnB w="12700" cap="flat" cmpd="sng" algn="ctr">
                       <a:solidFill>
-                        <a:srgbClr val="D5DEE9"/>
+                        <a:srgbClr val="DDDDDD"/>
                       </a:solidFill>
                       <a:prstDash val="solid"/>
                       <a:round/>
@@ -5120,7 +5120,7 @@
                       <a:r>
                         <a:rPr lang="en-US" sz="1500" dirty="0">
                           <a:solidFill>
-                            <a:srgbClr val="11182B"/>
+                            <a:srgbClr val="181818"/>
                           </a:solidFill>
                           <a:latin typeface="Calibri" pitchFamily="34" charset="0"/>
                           <a:ea typeface="Calibri" pitchFamily="34" charset="-122"/>
@@ -5138,7 +5138,7 @@
                   <a:tcPr marL="128016" marR="128016" marT="54864" marB="54864" anchor="ctr">
                     <a:lnL w="12700" cap="flat" cmpd="sng" algn="ctr">
                       <a:solidFill>
-                        <a:srgbClr val="D5DEE9"/>
+                        <a:srgbClr val="DDDDDD"/>
                       </a:solidFill>
                       <a:prstDash val="solid"/>
                       <a:round/>
@@ -5147,7 +5147,7 @@
                     </a:lnL>
                     <a:lnR w="12700" cap="flat" cmpd="sng" algn="ctr">
                       <a:solidFill>
-                        <a:srgbClr val="D5DEE9"/>
+                        <a:srgbClr val="DDDDDD"/>
                       </a:solidFill>
                       <a:prstDash val="solid"/>
                       <a:round/>
@@ -5156,7 +5156,7 @@
                     </a:lnR>
                     <a:lnT w="12700" cap="flat" cmpd="sng" algn="ctr">
                       <a:solidFill>
-                        <a:srgbClr val="D5DEE9"/>
+                        <a:srgbClr val="DDDDDD"/>
                       </a:solidFill>
                       <a:prstDash val="solid"/>
                       <a:round/>
@@ -5165,7 +5165,7 @@
                     </a:lnT>
                     <a:lnB w="12700" cap="flat" cmpd="sng" algn="ctr">
                       <a:solidFill>
-                        <a:srgbClr val="D5DEE9"/>
+                        <a:srgbClr val="DDDDDD"/>
                       </a:solidFill>
                       <a:prstDash val="solid"/>
                       <a:round/>
@@ -5188,7 +5188,7 @@
                       <a:r>
                         <a:rPr lang="en-US" sz="1500" dirty="0">
                           <a:solidFill>
-                            <a:srgbClr val="11182B"/>
+                            <a:srgbClr val="181818"/>
                           </a:solidFill>
                           <a:latin typeface="Calibri" pitchFamily="34" charset="0"/>
                           <a:ea typeface="Calibri" pitchFamily="34" charset="-122"/>
@@ -5206,7 +5206,7 @@
                   <a:tcPr marL="128016" marR="128016" marT="54864" marB="54864" anchor="ctr">
                     <a:lnL w="12700" cap="flat" cmpd="sng" algn="ctr">
                       <a:solidFill>
-                        <a:srgbClr val="D5DEE9"/>
+                        <a:srgbClr val="DDDDDD"/>
                       </a:solidFill>
                       <a:prstDash val="solid"/>
                       <a:round/>
@@ -5215,7 +5215,7 @@
                     </a:lnL>
                     <a:lnR w="12700" cap="flat" cmpd="sng" algn="ctr">
                       <a:solidFill>
-                        <a:srgbClr val="D5DEE9"/>
+                        <a:srgbClr val="DDDDDD"/>
                       </a:solidFill>
                       <a:prstDash val="solid"/>
                       <a:round/>
@@ -5224,7 +5224,7 @@
                     </a:lnR>
                     <a:lnT w="12700" cap="flat" cmpd="sng" algn="ctr">
                       <a:solidFill>
-                        <a:srgbClr val="D5DEE9"/>
+                        <a:srgbClr val="DDDDDD"/>
                       </a:solidFill>
                       <a:prstDash val="solid"/>
                       <a:round/>
@@ -5233,7 +5233,7 @@
                     </a:lnT>
                     <a:lnB w="12700" cap="flat" cmpd="sng" algn="ctr">
                       <a:solidFill>
-                        <a:srgbClr val="D5DEE9"/>
+                        <a:srgbClr val="DDDDDD"/>
                       </a:solidFill>
                       <a:prstDash val="solid"/>
                       <a:round/>
@@ -5256,7 +5256,7 @@
                       <a:r>
                         <a:rPr lang="en-US" sz="1500" dirty="0">
                           <a:solidFill>
-                            <a:srgbClr val="11182B"/>
+                            <a:srgbClr val="181818"/>
                           </a:solidFill>
                           <a:latin typeface="Calibri" pitchFamily="34" charset="0"/>
                           <a:ea typeface="Calibri" pitchFamily="34" charset="-122"/>
@@ -5274,7 +5274,7 @@
                   <a:tcPr marL="128016" marR="128016" marT="54864" marB="54864" anchor="ctr">
                     <a:lnL w="12700" cap="flat" cmpd="sng" algn="ctr">
                       <a:solidFill>
-                        <a:srgbClr val="D5DEE9"/>
+                        <a:srgbClr val="DDDDDD"/>
                       </a:solidFill>
                       <a:prstDash val="solid"/>
                       <a:round/>
@@ -5283,7 +5283,7 @@
                     </a:lnL>
                     <a:lnR w="12700" cap="flat" cmpd="sng" algn="ctr">
                       <a:solidFill>
-                        <a:srgbClr val="D5DEE9"/>
+                        <a:srgbClr val="DDDDDD"/>
                       </a:solidFill>
                       <a:prstDash val="solid"/>
                       <a:round/>
@@ -5292,7 +5292,7 @@
                     </a:lnR>
                     <a:lnT w="12700" cap="flat" cmpd="sng" algn="ctr">
                       <a:solidFill>
-                        <a:srgbClr val="D5DEE9"/>
+                        <a:srgbClr val="DDDDDD"/>
                       </a:solidFill>
                       <a:prstDash val="solid"/>
                       <a:round/>
@@ -5301,7 +5301,7 @@
                     </a:lnT>
                     <a:lnB w="12700" cap="flat" cmpd="sng" algn="ctr">
                       <a:solidFill>
-                        <a:srgbClr val="D5DEE9"/>
+                        <a:srgbClr val="DDDDDD"/>
                       </a:solidFill>
                       <a:prstDash val="solid"/>
                       <a:round/>
@@ -5324,7 +5324,7 @@
                       <a:r>
                         <a:rPr lang="en-US" sz="1500" dirty="0">
                           <a:solidFill>
-                            <a:srgbClr val="11182B"/>
+                            <a:srgbClr val="181818"/>
                           </a:solidFill>
                           <a:latin typeface="Calibri" pitchFamily="34" charset="0"/>
                           <a:ea typeface="Calibri" pitchFamily="34" charset="-122"/>
@@ -5342,7 +5342,7 @@
                   <a:tcPr marL="128016" marR="128016" marT="54864" marB="54864" anchor="ctr">
                     <a:lnL w="12700" cap="flat" cmpd="sng" algn="ctr">
                       <a:solidFill>
-                        <a:srgbClr val="D5DEE9"/>
+                        <a:srgbClr val="DDDDDD"/>
                       </a:solidFill>
                       <a:prstDash val="solid"/>
                       <a:round/>
@@ -5351,7 +5351,7 @@
                     </a:lnL>
                     <a:lnR w="12700" cap="flat" cmpd="sng" algn="ctr">
                       <a:solidFill>
-                        <a:srgbClr val="D5DEE9"/>
+                        <a:srgbClr val="DDDDDD"/>
                       </a:solidFill>
                       <a:prstDash val="solid"/>
                       <a:round/>
@@ -5360,7 +5360,7 @@
                     </a:lnR>
                     <a:lnT w="12700" cap="flat" cmpd="sng" algn="ctr">
                       <a:solidFill>
-                        <a:srgbClr val="D5DEE9"/>
+                        <a:srgbClr val="DDDDDD"/>
                       </a:solidFill>
                       <a:prstDash val="solid"/>
                       <a:round/>
@@ -5369,7 +5369,7 @@
                     </a:lnT>
                     <a:lnB w="12700" cap="flat" cmpd="sng" algn="ctr">
                       <a:solidFill>
-                        <a:srgbClr val="D5DEE9"/>
+                        <a:srgbClr val="DDDDDD"/>
                       </a:solidFill>
                       <a:prstDash val="solid"/>
                       <a:round/>
@@ -5394,7 +5394,7 @@
                       <a:r>
                         <a:rPr lang="en-US" sz="1500" b="1" dirty="0">
                           <a:solidFill>
-                            <a:srgbClr val="378ADD"/>
+                            <a:srgbClr val="7B7B7B"/>
                           </a:solidFill>
                           <a:latin typeface="Calibri" pitchFamily="34" charset="0"/>
                           <a:ea typeface="Calibri" pitchFamily="34" charset="-122"/>
@@ -5412,7 +5412,7 @@
                   <a:tcPr marL="128016" marR="128016" marT="54864" marB="54864" anchor="ctr">
                     <a:lnL w="12700" cap="flat" cmpd="sng" algn="ctr">
                       <a:solidFill>
-                        <a:srgbClr val="D5DEE9"/>
+                        <a:srgbClr val="DDDDDD"/>
                       </a:solidFill>
                       <a:prstDash val="solid"/>
                       <a:round/>
@@ -5421,7 +5421,7 @@
                     </a:lnL>
                     <a:lnR w="12700" cap="flat" cmpd="sng" algn="ctr">
                       <a:solidFill>
-                        <a:srgbClr val="D5DEE9"/>
+                        <a:srgbClr val="DDDDDD"/>
                       </a:solidFill>
                       <a:prstDash val="solid"/>
                       <a:round/>
@@ -5430,7 +5430,7 @@
                     </a:lnR>
                     <a:lnT w="12700" cap="flat" cmpd="sng" algn="ctr">
                       <a:solidFill>
-                        <a:srgbClr val="D5DEE9"/>
+                        <a:srgbClr val="DDDDDD"/>
                       </a:solidFill>
                       <a:prstDash val="solid"/>
                       <a:round/>
@@ -5439,7 +5439,7 @@
                     </a:lnT>
                     <a:lnB w="12700" cap="flat" cmpd="sng" algn="ctr">
                       <a:solidFill>
-                        <a:srgbClr val="D5DEE9"/>
+                        <a:srgbClr val="DDDDDD"/>
                       </a:solidFill>
                       <a:prstDash val="solid"/>
                       <a:round/>
@@ -5447,7 +5447,7 @@
                       <a:tailEnd type="none" w="med" len="med"/>
                     </a:lnB>
                     <a:solidFill>
-                      <a:srgbClr val="EEF3F9"/>
+                      <a:srgbClr val="F2F2F2"/>
                     </a:solidFill>
                   </a:tcPr>
                 </a:tc>
@@ -5462,7 +5462,7 @@
                       <a:r>
                         <a:rPr lang="en-US" sz="1500" dirty="0">
                           <a:solidFill>
-                            <a:srgbClr val="11182B"/>
+                            <a:srgbClr val="181818"/>
                           </a:solidFill>
                           <a:latin typeface="Calibri" pitchFamily="34" charset="0"/>
                           <a:ea typeface="Calibri" pitchFamily="34" charset="-122"/>
@@ -5480,7 +5480,7 @@
                   <a:tcPr marL="128016" marR="128016" marT="54864" marB="54864" anchor="ctr">
                     <a:lnL w="12700" cap="flat" cmpd="sng" algn="ctr">
                       <a:solidFill>
-                        <a:srgbClr val="D5DEE9"/>
+                        <a:srgbClr val="DDDDDD"/>
                       </a:solidFill>
                       <a:prstDash val="solid"/>
                       <a:round/>
@@ -5489,7 +5489,7 @@
                     </a:lnL>
                     <a:lnR w="12700" cap="flat" cmpd="sng" algn="ctr">
                       <a:solidFill>
-                        <a:srgbClr val="D5DEE9"/>
+                        <a:srgbClr val="DDDDDD"/>
                       </a:solidFill>
                       <a:prstDash val="solid"/>
                       <a:round/>
@@ -5498,7 +5498,7 @@
                     </a:lnR>
                     <a:lnT w="12700" cap="flat" cmpd="sng" algn="ctr">
                       <a:solidFill>
-                        <a:srgbClr val="D5DEE9"/>
+                        <a:srgbClr val="DDDDDD"/>
                       </a:solidFill>
                       <a:prstDash val="solid"/>
                       <a:round/>
@@ -5507,7 +5507,7 @@
                     </a:lnT>
                     <a:lnB w="12700" cap="flat" cmpd="sng" algn="ctr">
                       <a:solidFill>
-                        <a:srgbClr val="D5DEE9"/>
+                        <a:srgbClr val="DDDDDD"/>
                       </a:solidFill>
                       <a:prstDash val="solid"/>
                       <a:round/>
@@ -5515,7 +5515,7 @@
                       <a:tailEnd type="none" w="med" len="med"/>
                     </a:lnB>
                     <a:solidFill>
-                      <a:srgbClr val="EEF3F9"/>
+                      <a:srgbClr val="F2F2F2"/>
                     </a:solidFill>
                   </a:tcPr>
                 </a:tc>
@@ -5530,7 +5530,7 @@
                       <a:r>
                         <a:rPr lang="en-US" sz="1500" dirty="0">
                           <a:solidFill>
-                            <a:srgbClr val="11182B"/>
+                            <a:srgbClr val="181818"/>
                           </a:solidFill>
                           <a:latin typeface="Calibri" pitchFamily="34" charset="0"/>
                           <a:ea typeface="Calibri" pitchFamily="34" charset="-122"/>
@@ -5548,7 +5548,7 @@
                   <a:tcPr marL="128016" marR="128016" marT="54864" marB="54864" anchor="ctr">
                     <a:lnL w="12700" cap="flat" cmpd="sng" algn="ctr">
                       <a:solidFill>
-                        <a:srgbClr val="D5DEE9"/>
+                        <a:srgbClr val="DDDDDD"/>
                       </a:solidFill>
                       <a:prstDash val="solid"/>
                       <a:round/>
@@ -5557,7 +5557,7 @@
                     </a:lnL>
                     <a:lnR w="12700" cap="flat" cmpd="sng" algn="ctr">
                       <a:solidFill>
-                        <a:srgbClr val="D5DEE9"/>
+                        <a:srgbClr val="DDDDDD"/>
                       </a:solidFill>
                       <a:prstDash val="solid"/>
                       <a:round/>
@@ -5566,7 +5566,7 @@
                     </a:lnR>
                     <a:lnT w="12700" cap="flat" cmpd="sng" algn="ctr">
                       <a:solidFill>
-                        <a:srgbClr val="D5DEE9"/>
+                        <a:srgbClr val="DDDDDD"/>
                       </a:solidFill>
                       <a:prstDash val="solid"/>
                       <a:round/>
@@ -5575,7 +5575,7 @@
                     </a:lnT>
                     <a:lnB w="12700" cap="flat" cmpd="sng" algn="ctr">
                       <a:solidFill>
-                        <a:srgbClr val="D5DEE9"/>
+                        <a:srgbClr val="DDDDDD"/>
                       </a:solidFill>
                       <a:prstDash val="solid"/>
                       <a:round/>
@@ -5583,7 +5583,7 @@
                       <a:tailEnd type="none" w="med" len="med"/>
                     </a:lnB>
                     <a:solidFill>
-                      <a:srgbClr val="EEF3F9"/>
+                      <a:srgbClr val="F2F2F2"/>
                     </a:solidFill>
                   </a:tcPr>
                 </a:tc>
@@ -5598,7 +5598,7 @@
                       <a:r>
                         <a:rPr lang="en-US" sz="1500" dirty="0">
                           <a:solidFill>
-                            <a:srgbClr val="11182B"/>
+                            <a:srgbClr val="181818"/>
                           </a:solidFill>
                           <a:latin typeface="Calibri" pitchFamily="34" charset="0"/>
                           <a:ea typeface="Calibri" pitchFamily="34" charset="-122"/>
@@ -5616,7 +5616,7 @@
                   <a:tcPr marL="128016" marR="128016" marT="54864" marB="54864" anchor="ctr">
                     <a:lnL w="12700" cap="flat" cmpd="sng" algn="ctr">
                       <a:solidFill>
-                        <a:srgbClr val="D5DEE9"/>
+                        <a:srgbClr val="DDDDDD"/>
                       </a:solidFill>
                       <a:prstDash val="solid"/>
                       <a:round/>
@@ -5625,7 +5625,7 @@
                     </a:lnL>
                     <a:lnR w="12700" cap="flat" cmpd="sng" algn="ctr">
                       <a:solidFill>
-                        <a:srgbClr val="D5DEE9"/>
+                        <a:srgbClr val="DDDDDD"/>
                       </a:solidFill>
                       <a:prstDash val="solid"/>
                       <a:round/>
@@ -5634,7 +5634,7 @@
                     </a:lnR>
                     <a:lnT w="12700" cap="flat" cmpd="sng" algn="ctr">
                       <a:solidFill>
-                        <a:srgbClr val="D5DEE9"/>
+                        <a:srgbClr val="DDDDDD"/>
                       </a:solidFill>
                       <a:prstDash val="solid"/>
                       <a:round/>
@@ -5643,7 +5643,7 @@
                     </a:lnT>
                     <a:lnB w="12700" cap="flat" cmpd="sng" algn="ctr">
                       <a:solidFill>
-                        <a:srgbClr val="D5DEE9"/>
+                        <a:srgbClr val="DDDDDD"/>
                       </a:solidFill>
                       <a:prstDash val="solid"/>
                       <a:round/>
@@ -5651,7 +5651,7 @@
                       <a:tailEnd type="none" w="med" len="med"/>
                     </a:lnB>
                     <a:solidFill>
-                      <a:srgbClr val="EEF3F9"/>
+                      <a:srgbClr val="F2F2F2"/>
                     </a:solidFill>
                   </a:tcPr>
                 </a:tc>
@@ -5666,7 +5666,7 @@
                       <a:r>
                         <a:rPr lang="en-US" sz="1500" dirty="0">
                           <a:solidFill>
-                            <a:srgbClr val="11182B"/>
+                            <a:srgbClr val="181818"/>
                           </a:solidFill>
                           <a:latin typeface="Calibri" pitchFamily="34" charset="0"/>
                           <a:ea typeface="Calibri" pitchFamily="34" charset="-122"/>
@@ -5684,7 +5684,7 @@
                   <a:tcPr marL="128016" marR="128016" marT="54864" marB="54864" anchor="ctr">
                     <a:lnL w="12700" cap="flat" cmpd="sng" algn="ctr">
                       <a:solidFill>
-                        <a:srgbClr val="D5DEE9"/>
+                        <a:srgbClr val="DDDDDD"/>
                       </a:solidFill>
                       <a:prstDash val="solid"/>
                       <a:round/>
@@ -5693,7 +5693,7 @@
                     </a:lnL>
                     <a:lnR w="12700" cap="flat" cmpd="sng" algn="ctr">
                       <a:solidFill>
-                        <a:srgbClr val="D5DEE9"/>
+                        <a:srgbClr val="DDDDDD"/>
                       </a:solidFill>
                       <a:prstDash val="solid"/>
                       <a:round/>
@@ -5702,7 +5702,7 @@
                     </a:lnR>
                     <a:lnT w="12700" cap="flat" cmpd="sng" algn="ctr">
                       <a:solidFill>
-                        <a:srgbClr val="D5DEE9"/>
+                        <a:srgbClr val="DDDDDD"/>
                       </a:solidFill>
                       <a:prstDash val="solid"/>
                       <a:round/>
@@ -5711,7 +5711,7 @@
                     </a:lnT>
                     <a:lnB w="12700" cap="flat" cmpd="sng" algn="ctr">
                       <a:solidFill>
-                        <a:srgbClr val="D5DEE9"/>
+                        <a:srgbClr val="DDDDDD"/>
                       </a:solidFill>
                       <a:prstDash val="solid"/>
                       <a:round/>
@@ -5719,7 +5719,7 @@
                       <a:tailEnd type="none" w="med" len="med"/>
                     </a:lnB>
                     <a:solidFill>
-                      <a:srgbClr val="EEF3F9"/>
+                      <a:srgbClr val="F2F2F2"/>
                     </a:solidFill>
                   </a:tcPr>
                 </a:tc>
@@ -5755,7 +5755,7 @@
           </a:ln>
           <a:effectLst>
             <a:outerShdw sx="100000" sy="100000" kx="0" ky="0" algn="bl" rotWithShape="0" blurRad="127000" dist="25400" dir="5400000">
-              <a:srgbClr val="11182B">
+              <a:srgbClr val="181818">
                 <a:alpha val="10000"/>
               </a:srgbClr>
             </a:outerShdw>
@@ -5872,7 +5872,7 @@
           </a:ln>
           <a:effectLst>
             <a:outerShdw sx="100000" sy="100000" kx="0" ky="0" algn="bl" rotWithShape="0" blurRad="127000" dist="25400" dir="5400000">
-              <a:srgbClr val="11182B">
+              <a:srgbClr val="181818">
                 <a:alpha val="10000"/>
               </a:srgbClr>
             </a:outerShdw>
@@ -6441,7 +6441,7 @@
           </a:ln>
           <a:effectLst>
             <a:outerShdw sx="100000" sy="100000" kx="0" ky="0" algn="bl" rotWithShape="0" blurRad="127000" dist="25400" dir="5400000">
-              <a:srgbClr val="11182B">
+              <a:srgbClr val="181818">
                 <a:alpha val="10000"/>
               </a:srgbClr>
             </a:outerShdw>
@@ -6685,7 +6685,7 @@
           </a:ln>
           <a:effectLst>
             <a:outerShdw sx="100000" sy="100000" kx="0" ky="0" algn="bl" rotWithShape="0" blurRad="127000" dist="25400" dir="5400000">
-              <a:srgbClr val="11182B">
+              <a:srgbClr val="181818">
                 <a:alpha val="10000"/>
               </a:srgbClr>
             </a:outerShdw>
@@ -6811,7 +6811,7 @@
           </a:ln>
           <a:effectLst>
             <a:outerShdw sx="100000" sy="100000" kx="0" ky="0" algn="bl" rotWithShape="0" blurRad="127000" dist="25400" dir="5400000">
-              <a:srgbClr val="11182B">
+              <a:srgbClr val="181818">
                 <a:alpha val="10000"/>
               </a:srgbClr>
             </a:outerShdw>
@@ -6937,7 +6937,7 @@
           </a:ln>
           <a:effectLst>
             <a:outerShdw sx="100000" sy="100000" kx="0" ky="0" algn="bl" rotWithShape="0" blurRad="127000" dist="25400" dir="5400000">
-              <a:srgbClr val="11182B">
+              <a:srgbClr val="181818">
                 <a:alpha val="10000"/>
               </a:srgbClr>
             </a:outerShdw>
@@ -7063,7 +7063,7 @@
           </a:ln>
           <a:effectLst>
             <a:outerShdw sx="100000" sy="100000" kx="0" ky="0" algn="bl" rotWithShape="0" blurRad="127000" dist="25400" dir="5400000">
-              <a:srgbClr val="11182B">
+              <a:srgbClr val="181818">
                 <a:alpha val="10000"/>
               </a:srgbClr>
             </a:outerShdw>
@@ -8493,7 +8493,7 @@
           </a:ln>
           <a:effectLst>
             <a:outerShdw sx="100000" sy="100000" kx="0" ky="0" algn="bl" rotWithShape="0" blurRad="127000" dist="25400" dir="5400000">
-              <a:srgbClr val="11182B">
+              <a:srgbClr val="181818">
                 <a:alpha val="10000"/>
               </a:srgbClr>
             </a:outerShdw>
@@ -9459,7 +9459,7 @@
           </a:ln>
           <a:effectLst>
             <a:outerShdw sx="100000" sy="100000" kx="0" ky="0" algn="bl" rotWithShape="0" blurRad="127000" dist="25400" dir="5400000">
-              <a:srgbClr val="11182B">
+              <a:srgbClr val="181818">
                 <a:alpha val="10000"/>
               </a:srgbClr>
             </a:outerShdw>
@@ -9593,7 +9593,7 @@
           </a:ln>
           <a:effectLst>
             <a:outerShdw sx="100000" sy="100000" kx="0" ky="0" algn="bl" rotWithShape="0" blurRad="127000" dist="25400" dir="5400000">
-              <a:srgbClr val="11182B">
+              <a:srgbClr val="181818">
                 <a:alpha val="10000"/>
               </a:srgbClr>
             </a:outerShdw>
@@ -9727,7 +9727,7 @@
           </a:ln>
           <a:effectLst>
             <a:outerShdw sx="100000" sy="100000" kx="0" ky="0" algn="bl" rotWithShape="0" blurRad="127000" dist="25400" dir="5400000">
-              <a:srgbClr val="11182B">
+              <a:srgbClr val="181818">
                 <a:alpha val="10000"/>
               </a:srgbClr>
             </a:outerShdw>
@@ -9851,7 +9851,7 @@
           <a:noFill/>
           <a:ln w="25400">
             <a:solidFill>
-              <a:srgbClr val="6E7C94"/>
+              <a:srgbClr val="7B7B7B"/>
             </a:solidFill>
             <a:prstDash val="solid"/>
             <a:tailEnd type="triangle"/>
@@ -9875,7 +9875,7 @@
           <a:noFill/>
           <a:ln w="25400">
             <a:solidFill>
-              <a:srgbClr val="6E7C94"/>
+              <a:srgbClr val="7B7B7B"/>
             </a:solidFill>
             <a:prstDash val="solid"/>
             <a:tailEnd type="triangle"/>
@@ -10452,7 +10452,7 @@
           </a:ln>
           <a:effectLst>
             <a:outerShdw sx="100000" sy="100000" kx="0" ky="0" algn="bl" rotWithShape="0" blurRad="127000" dist="25400" dir="5400000">
-              <a:srgbClr val="11182B">
+              <a:srgbClr val="181818">
                 <a:alpha val="10000"/>
               </a:srgbClr>
             </a:outerShdw>
@@ -10569,7 +10569,7 @@
           </a:ln>
           <a:effectLst>
             <a:outerShdw sx="100000" sy="100000" kx="0" ky="0" algn="bl" rotWithShape="0" blurRad="127000" dist="25400" dir="5400000">
-              <a:srgbClr val="11182B">
+              <a:srgbClr val="181818">
                 <a:alpha val="10000"/>
               </a:srgbClr>
             </a:outerShdw>
@@ -10686,7 +10686,7 @@
           </a:ln>
           <a:effectLst>
             <a:outerShdw sx="100000" sy="100000" kx="0" ky="0" algn="bl" rotWithShape="0" blurRad="127000" dist="25400" dir="5400000">
-              <a:srgbClr val="11182B">
+              <a:srgbClr val="181818">
                 <a:alpha val="10000"/>
               </a:srgbClr>
             </a:outerShdw>
@@ -10803,7 +10803,7 @@
           </a:ln>
           <a:effectLst>
             <a:outerShdw sx="100000" sy="100000" kx="0" ky="0" algn="bl" rotWithShape="0" blurRad="127000" dist="25400" dir="5400000">
-              <a:srgbClr val="11182B">
+              <a:srgbClr val="181818">
                 <a:alpha val="10000"/>
               </a:srgbClr>
             </a:outerShdw>
@@ -11028,7 +11028,7 @@
           </a:ln>
           <a:effectLst>
             <a:outerShdw sx="100000" sy="100000" kx="0" ky="0" algn="bl" rotWithShape="0" blurRad="127000" dist="25400" dir="5400000">
-              <a:srgbClr val="11182B">
+              <a:srgbClr val="181818">
                 <a:alpha val="10000"/>
               </a:srgbClr>
             </a:outerShdw>
@@ -11154,7 +11154,7 @@
           </a:ln>
           <a:effectLst>
             <a:outerShdw sx="100000" sy="100000" kx="0" ky="0" algn="bl" rotWithShape="0" blurRad="127000" dist="25400" dir="5400000">
-              <a:srgbClr val="11182B">
+              <a:srgbClr val="181818">
                 <a:alpha val="10000"/>
               </a:srgbClr>
             </a:outerShdw>
@@ -11280,7 +11280,7 @@
           </a:ln>
           <a:effectLst>
             <a:outerShdw sx="100000" sy="100000" kx="0" ky="0" algn="bl" rotWithShape="0" blurRad="127000" dist="25400" dir="5400000">
-              <a:srgbClr val="11182B">
+              <a:srgbClr val="181818">
                 <a:alpha val="10000"/>
               </a:srgbClr>
             </a:outerShdw>
@@ -13371,7 +13371,7 @@
           </a:ln>
           <a:effectLst>
             <a:outerShdw sx="100000" sy="100000" kx="0" ky="0" algn="bl" rotWithShape="0" blurRad="127000" dist="25400" dir="5400000">
-              <a:srgbClr val="11182B">
+              <a:srgbClr val="181818">
                 <a:alpha val="10000"/>
               </a:srgbClr>
             </a:outerShdw>
@@ -13477,7 +13477,7 @@
           </a:ln>
           <a:effectLst>
             <a:outerShdw sx="100000" sy="100000" kx="0" ky="0" algn="bl" rotWithShape="0" blurRad="127000" dist="25400" dir="5400000">
-              <a:srgbClr val="11182B">
+              <a:srgbClr val="181818">
                 <a:alpha val="10000"/>
               </a:srgbClr>
             </a:outerShdw>
@@ -13691,7 +13691,7 @@
           </a:ln>
           <a:effectLst>
             <a:outerShdw sx="100000" sy="100000" kx="0" ky="0" algn="bl" rotWithShape="0" blurRad="127000" dist="25400" dir="5400000">
-              <a:srgbClr val="11182B">
+              <a:srgbClr val="181818">
                 <a:alpha val="10000"/>
               </a:srgbClr>
             </a:outerShdw>
@@ -13825,7 +13825,7 @@
           </a:ln>
           <a:effectLst>
             <a:outerShdw sx="100000" sy="100000" kx="0" ky="0" algn="bl" rotWithShape="0" blurRad="127000" dist="25400" dir="5400000">
-              <a:srgbClr val="11182B">
+              <a:srgbClr val="181818">
                 <a:alpha val="10000"/>
               </a:srgbClr>
             </a:outerShdw>
@@ -13959,7 +13959,7 @@
           </a:ln>
           <a:effectLst>
             <a:outerShdw sx="100000" sy="100000" kx="0" ky="0" algn="bl" rotWithShape="0" blurRad="127000" dist="25400" dir="5400000">
-              <a:srgbClr val="11182B">
+              <a:srgbClr val="181818">
                 <a:alpha val="10000"/>
               </a:srgbClr>
             </a:outerShdw>
@@ -14093,7 +14093,7 @@
           </a:ln>
           <a:effectLst>
             <a:outerShdw sx="100000" sy="100000" kx="0" ky="0" algn="bl" rotWithShape="0" blurRad="127000" dist="25400" dir="5400000">
-              <a:srgbClr val="11182B">
+              <a:srgbClr val="181818">
                 <a:alpha val="10000"/>
               </a:srgbClr>
             </a:outerShdw>
@@ -14446,7 +14446,7 @@
                   <a:schemeClr val="accent3"/>
                 </a:solidFill>
               </a:rPr>
-              <a:t>Blue is the high note on the top row. Orange is the low note on the bottom row.</a:t>
+              <a:t>Dark blocks are the high note on the top row. Light blocks are the low note on the bottom row.</a:t>
             </a:r>
             <a:endParaRPr lang="en-US" sz="1600" dirty="0"/>
           </a:p>
@@ -14570,40 +14570,40 @@
   <a:themeElements>
     <a:clrScheme name="Beat Navy">
       <a:dk1>
-        <a:srgbClr val="11182B"/>
+        <a:srgbClr val="181818"/>
       </a:dk1>
       <a:lt1>
         <a:srgbClr val="FFFFFF"/>
       </a:lt1>
       <a:dk2>
-        <a:srgbClr val="16233F"/>
+        <a:srgbClr val="222222"/>
       </a:dk2>
       <a:lt2>
-        <a:srgbClr val="EEF3F9"/>
+        <a:srgbClr val="F2F2F2"/>
       </a:lt2>
       <a:accent1>
-        <a:srgbClr val="378ADD"/>
+        <a:srgbClr val="7B7B7B"/>
       </a:accent1>
       <a:accent2>
-        <a:srgbClr val="EF9F27"/>
+        <a:srgbClr val="666666"/>
       </a:accent2>
       <a:accent3>
-        <a:srgbClr val="6E7C94"/>
+        <a:srgbClr val="7B7B7B"/>
       </a:accent3>
       <a:accent4>
-        <a:srgbClr val="2C4675"/>
+        <a:srgbClr val="444444"/>
       </a:accent4>
       <a:accent5>
-        <a:srgbClr val="C7D9EE"/>
+        <a:srgbClr val="D6D6D6"/>
       </a:accent5>
       <a:accent6>
-        <a:srgbClr val="B0411F"/>
+        <a:srgbClr val="5E5E5E"/>
       </a:accent6>
       <a:hlink>
-        <a:srgbClr val="378ADD"/>
+        <a:srgbClr val="7B7B7B"/>
       </a:hlink>
       <a:folHlink>
-        <a:srgbClr val="6E7C94"/>
+        <a:srgbClr val="7B7B7B"/>
       </a:folHlink>
     </a:clrScheme>
     <a:fontScheme name="Beat Navy">

</xml_diff>

<commit_message>
Strip speaker notes and set document metadata
All twelve notes slides removed from the deck. Author, title, subject
and keywords set on the presentation and on the code documentation.

Print-ready PDFs are generated into print/, which is ignored.
</commit_message>
<xml_diff>
--- a/Presentation.pptx
+++ b/Presentation.pptx
@@ -4,20 +4,22 @@
   <p:sldMasterIdLst>
     <p:sldMasterId id="2147483648" r:id="rId1"/>
   </p:sldMasterIdLst>
+  <p:notesMasterIdLst>
+    <p:notesMasterId r:id="rId14"/>
+  </p:notesMasterIdLst>
   <p:sldIdLst>
-    <p:sldId id="256" r:id="rId7"/>
-    <p:sldId id="257" r:id="rId9"/>
-    <p:sldId id="258" r:id="rId10"/>
-    <p:sldId id="259" r:id="rId11"/>
-    <p:sldId id="260" r:id="rId12"/>
-    <p:sldId id="261" r:id="rId13"/>
-    <p:sldId id="262" r:id="rId14"/>
-    <p:sldId id="263" r:id="rId15"/>
-    <p:sldId id="264" r:id="rId16"/>
-    <p:sldId id="265" r:id="rId17"/>
-    <p:sldId id="266" r:id="rId18"/>
-    <p:sldId id="267" r:id="rId19"/>
-    <p:sldId id="268" r:id="rId20"/>
+    <p:sldId id="256" r:id="rId2"/>
+    <p:sldId id="257" r:id="rId3"/>
+    <p:sldId id="258" r:id="rId4"/>
+    <p:sldId id="259" r:id="rId5"/>
+    <p:sldId id="260" r:id="rId6"/>
+    <p:sldId id="261" r:id="rId7"/>
+    <p:sldId id="263" r:id="rId8"/>
+    <p:sldId id="264" r:id="rId9"/>
+    <p:sldId id="265" r:id="rId10"/>
+    <p:sldId id="266" r:id="rId11"/>
+    <p:sldId id="267" r:id="rId12"/>
+    <p:sldId id="268" r:id="rId13"/>
   </p:sldIdLst>
   <p:sldSz cx="9144000" cy="6858000" type="screen4x3"/>
   <p:notesSz cx="6858000" cy="9144000"/>
@@ -116,11 +118,27 @@
       </a:defRPr>
     </a:lvl9pPr>
   </p:defaultTextStyle>
+  <p:extLst>
+    <p:ext uri="{EFAFB233-063F-42B5-8137-9DF3F51BA10A}">
+      <p15:sldGuideLst xmlns:p15="http://schemas.microsoft.com/office/powerpoint/2012/main">
+        <p15:guide id="1" orient="horz" pos="2160">
+          <p15:clr>
+            <a:srgbClr val="A4A3A4"/>
+          </p15:clr>
+        </p15:guide>
+        <p15:guide id="2" pos="2880">
+          <p15:clr>
+            <a:srgbClr val="A4A3A4"/>
+          </p15:clr>
+        </p15:guide>
+      </p15:sldGuideLst>
+    </p:ext>
+  </p:extLst>
 </p:presentation>
 </file>
 
 <file path=ppt/notesMasters/notesMaster1.xml><?xml version="1.0" encoding="utf-8"?>
-<p:notesMaster xmlns:a="http://schemas.openxmlformats.org/drawingml/2006/main" xmlns:p="http://schemas.openxmlformats.org/presentationml/2006/main" xmlns:r="http://schemas.openxmlformats.org/officeDocument/2006/relationships">
+<p:notesMaster xmlns:a="http://schemas.openxmlformats.org/drawingml/2006/main" xmlns:r="http://schemas.openxmlformats.org/officeDocument/2006/relationships" xmlns:p="http://schemas.openxmlformats.org/presentationml/2006/main">
   <p:cSld>
     <p:bg>
       <p:bgRef idx="1001">
@@ -141,241 +159,16 @@
           <a:chExt cx="0" cy="0"/>
         </a:xfrm>
       </p:grpSpPr>
-      <p:sp>
-        <p:nvSpPr>
-          <p:cNvPr id="2" name="Header Placeholder 1"/>
-          <p:cNvSpPr>
-            <a:spLocks noGrp="1"/>
-          </p:cNvSpPr>
-          <p:nvPr>
-            <p:ph type="hdr" sz="quarter"/>
-          </p:nvPr>
-        </p:nvSpPr>
-        <p:spPr>
-          <a:xfrm>
-            <a:off x="0" y="0"/>
-            <a:ext cx="2971800" cy="457200"/>
-          </a:xfrm>
-          <a:prstGeom prst="rect">
-            <a:avLst/>
-          </a:prstGeom>
-        </p:spPr>
-        <p:txBody>
-          <a:bodyPr vert="horz" lIns="91440" tIns="45720" rIns="91440" bIns="45720" rtlCol="0"/>
-          <a:lstStyle>
-            <a:lvl1pPr algn="l">
-              <a:defRPr sz="1200"/>
-            </a:lvl1pPr>
-          </a:lstStyle>
-          <a:p>
-            <a:endParaRPr lang="en-US"/>
-          </a:p>
-        </p:txBody>
-      </p:sp>
-      <p:sp>
-        <p:nvSpPr>
-          <p:cNvPr id="3" name="Date Placeholder 2"/>
-          <p:cNvSpPr>
-            <a:spLocks noGrp="1"/>
-          </p:cNvSpPr>
-          <p:nvPr>
-            <p:ph type="dt" idx="1"/>
-          </p:nvPr>
-        </p:nvSpPr>
-        <p:spPr>
-          <a:xfrm>
-            <a:off x="3884613" y="0"/>
-            <a:ext cx="2971800" cy="457200"/>
-          </a:xfrm>
-          <a:prstGeom prst="rect">
-            <a:avLst/>
-          </a:prstGeom>
-        </p:spPr>
-        <p:txBody>
-          <a:bodyPr vert="horz" lIns="91440" tIns="45720" rIns="91440" bIns="45720" rtlCol="0"/>
-          <a:lstStyle>
-            <a:lvl1pPr algn="r">
-              <a:defRPr sz="1200"/>
-            </a:lvl1pPr>
-          </a:lstStyle>
-          <a:p>
-            <a:fld id="{0F89C1C7-3DCD-1040-A9CF-14679D8B5DDD}" type="datetimeFigureOut">
-              <a:rPr lang="en-US" smtClean="0"/>
-              <a:t>10/17/16</a:t>
-            </a:fld>
-            <a:endParaRPr lang="en-US"/>
-          </a:p>
-        </p:txBody>
-      </p:sp>
-      <p:sp>
-        <p:nvSpPr>
-          <p:cNvPr id="4" name="Slide Image Placeholder 3"/>
-          <p:cNvSpPr>
-            <a:spLocks noGrp="1" noRot="1" noChangeAspect="1"/>
-          </p:cNvSpPr>
-          <p:nvPr>
-            <p:ph type="sldImg" idx="2"/>
-          </p:nvPr>
-        </p:nvSpPr>
-        <p:spPr>
-          <a:xfrm>
-            <a:off x="1143000" y="685800"/>
-            <a:ext cx="4572000" cy="3429000"/>
-          </a:xfrm>
-          <a:prstGeom prst="rect">
-            <a:avLst/>
-          </a:prstGeom>
-          <a:noFill/>
-          <a:ln w="12700">
-            <a:solidFill>
-              <a:prstClr val="black"/>
-            </a:solidFill>
-          </a:ln>
-        </p:spPr>
-        <p:txBody>
-          <a:bodyPr vert="horz" lIns="91440" tIns="45720" rIns="91440" bIns="45720" rtlCol="0" anchor="ctr"/>
-          <a:lstStyle/>
-          <a:p>
-            <a:endParaRPr lang="en-US"/>
-          </a:p>
-        </p:txBody>
-      </p:sp>
-      <p:sp>
-        <p:nvSpPr>
-          <p:cNvPr id="5" name="Notes Placeholder 4"/>
-          <p:cNvSpPr>
-            <a:spLocks noGrp="1"/>
-          </p:cNvSpPr>
-          <p:nvPr>
-            <p:ph type="body" sz="quarter" idx="3"/>
-          </p:nvPr>
-        </p:nvSpPr>
-        <p:spPr>
-          <a:xfrm>
-            <a:off x="685800" y="4343400"/>
-            <a:ext cx="5486400" cy="4114800"/>
-          </a:xfrm>
-          <a:prstGeom prst="rect">
-            <a:avLst/>
-          </a:prstGeom>
-        </p:spPr>
-        <p:txBody>
-          <a:bodyPr vert="horz" lIns="91440" tIns="45720" rIns="91440" bIns="45720" rtlCol="0"/>
-          <a:lstStyle/>
-          <a:p>
-            <a:pPr lvl="0"/>
-            <a:r>
-              <a:rPr lang="en-US" smtClean="0"/>
-              <a:t>Click to edit Master text styles</a:t>
-            </a:r>
-          </a:p>
-          <a:p>
-            <a:pPr lvl="1"/>
-            <a:r>
-              <a:rPr lang="en-US" smtClean="0"/>
-              <a:t>Second level</a:t>
-            </a:r>
-          </a:p>
-          <a:p>
-            <a:pPr lvl="2"/>
-            <a:r>
-              <a:rPr lang="en-US" smtClean="0"/>
-              <a:t>Third level</a:t>
-            </a:r>
-          </a:p>
-          <a:p>
-            <a:pPr lvl="3"/>
-            <a:r>
-              <a:rPr lang="en-US" smtClean="0"/>
-              <a:t>Fourth level</a:t>
-            </a:r>
-          </a:p>
-          <a:p>
-            <a:pPr lvl="4"/>
-            <a:r>
-              <a:rPr lang="en-US" smtClean="0"/>
-              <a:t>Fifth level</a:t>
-            </a:r>
-            <a:endParaRPr lang="en-US"/>
-          </a:p>
-        </p:txBody>
-      </p:sp>
-      <p:sp>
-        <p:nvSpPr>
-          <p:cNvPr id="6" name="Footer Placeholder 5"/>
-          <p:cNvSpPr>
-            <a:spLocks noGrp="1"/>
-          </p:cNvSpPr>
-          <p:nvPr>
-            <p:ph type="ftr" sz="quarter" idx="4"/>
-          </p:nvPr>
-        </p:nvSpPr>
-        <p:spPr>
-          <a:xfrm>
-            <a:off x="0" y="8685213"/>
-            <a:ext cx="2971800" cy="457200"/>
-          </a:xfrm>
-          <a:prstGeom prst="rect">
-            <a:avLst/>
-          </a:prstGeom>
-        </p:spPr>
-        <p:txBody>
-          <a:bodyPr vert="horz" lIns="91440" tIns="45720" rIns="91440" bIns="45720" rtlCol="0" anchor="b"/>
-          <a:lstStyle>
-            <a:lvl1pPr algn="l">
-              <a:defRPr sz="1200"/>
-            </a:lvl1pPr>
-          </a:lstStyle>
-          <a:p>
-            <a:endParaRPr lang="en-US"/>
-          </a:p>
-        </p:txBody>
-      </p:sp>
-      <p:sp>
-        <p:nvSpPr>
-          <p:cNvPr id="7" name="Slide Number Placeholder 6"/>
-          <p:cNvSpPr>
-            <a:spLocks noGrp="1"/>
-          </p:cNvSpPr>
-          <p:nvPr>
-            <p:ph type="sldNum" sz="quarter" idx="5"/>
-          </p:nvPr>
-        </p:nvSpPr>
-        <p:spPr>
-          <a:xfrm>
-            <a:off x="3884613" y="8685213"/>
-            <a:ext cx="2971800" cy="457200"/>
-          </a:xfrm>
-          <a:prstGeom prst="rect">
-            <a:avLst/>
-          </a:prstGeom>
-        </p:spPr>
-        <p:txBody>
-          <a:bodyPr vert="horz" lIns="91440" tIns="45720" rIns="91440" bIns="45720" rtlCol="0" anchor="b"/>
-          <a:lstStyle>
-            <a:lvl1pPr algn="r">
-              <a:defRPr sz="1200"/>
-            </a:lvl1pPr>
-          </a:lstStyle>
-          <a:p>
-            <a:fld id="{BB5E49A5-4136-284D-997B-48E1D791AD67}" type="slidenum">
-              <a:rPr lang="en-US" smtClean="0"/>
-              <a:t>‹#›</a:t>
-            </a:fld>
-            <a:endParaRPr lang="en-US"/>
-          </a:p>
-        </p:txBody>
-      </p:sp>
     </p:spTree>
     <p:extLst>
       <p:ext uri="{BB962C8B-B14F-4D97-AF65-F5344CB8AC3E}">
-        <p14:creationId xmlns:p14="http://schemas.microsoft.com/office/powerpoint/2010/main" val="2623252185"/>
+        <p14:creationId xmlns:p14="http://schemas.microsoft.com/office/powerpoint/2010/main" val="3605804033"/>
       </p:ext>
     </p:extLst>
   </p:cSld>
   <p:clrMap bg1="lt1" tx1="dk1" bg2="lt2" tx2="dk2" accent1="accent1" accent2="accent2" accent3="accent3" accent4="accent4" accent5="accent5" accent6="accent6" hlink="hlink" folHlink="folHlink"/>
   <p:notesStyle>
-    <a:lvl1pPr marL="0" algn="l" defTabSz="457200" rtl="0" eaLnBrk="1" latinLnBrk="0" hangingPunct="1">
+    <a:lvl1pPr marL="0" algn="l" defTabSz="914400" rtl="0" eaLnBrk="1" latinLnBrk="0" hangingPunct="1">
       <a:defRPr sz="1200" kern="1200">
         <a:solidFill>
           <a:schemeClr val="tx1"/>
@@ -385,7 +178,7 @@
         <a:cs typeface="+mn-cs"/>
       </a:defRPr>
     </a:lvl1pPr>
-    <a:lvl2pPr marL="457200" algn="l" defTabSz="457200" rtl="0" eaLnBrk="1" latinLnBrk="0" hangingPunct="1">
+    <a:lvl2pPr marL="457200" algn="l" defTabSz="914400" rtl="0" eaLnBrk="1" latinLnBrk="0" hangingPunct="1">
       <a:defRPr sz="1200" kern="1200">
         <a:solidFill>
           <a:schemeClr val="tx1"/>
@@ -395,7 +188,7 @@
         <a:cs typeface="+mn-cs"/>
       </a:defRPr>
     </a:lvl2pPr>
-    <a:lvl3pPr marL="914400" algn="l" defTabSz="457200" rtl="0" eaLnBrk="1" latinLnBrk="0" hangingPunct="1">
+    <a:lvl3pPr marL="914400" algn="l" defTabSz="914400" rtl="0" eaLnBrk="1" latinLnBrk="0" hangingPunct="1">
       <a:defRPr sz="1200" kern="1200">
         <a:solidFill>
           <a:schemeClr val="tx1"/>
@@ -405,7 +198,7 @@
         <a:cs typeface="+mn-cs"/>
       </a:defRPr>
     </a:lvl3pPr>
-    <a:lvl4pPr marL="1371600" algn="l" defTabSz="457200" rtl="0" eaLnBrk="1" latinLnBrk="0" hangingPunct="1">
+    <a:lvl4pPr marL="1371600" algn="l" defTabSz="914400" rtl="0" eaLnBrk="1" latinLnBrk="0" hangingPunct="1">
       <a:defRPr sz="1200" kern="1200">
         <a:solidFill>
           <a:schemeClr val="tx1"/>
@@ -415,7 +208,7 @@
         <a:cs typeface="+mn-cs"/>
       </a:defRPr>
     </a:lvl4pPr>
-    <a:lvl5pPr marL="1828800" algn="l" defTabSz="457200" rtl="0" eaLnBrk="1" latinLnBrk="0" hangingPunct="1">
+    <a:lvl5pPr marL="1828800" algn="l" defTabSz="914400" rtl="0" eaLnBrk="1" latinLnBrk="0" hangingPunct="1">
       <a:defRPr sz="1200" kern="1200">
         <a:solidFill>
           <a:schemeClr val="tx1"/>
@@ -425,7 +218,7 @@
         <a:cs typeface="+mn-cs"/>
       </a:defRPr>
     </a:lvl5pPr>
-    <a:lvl6pPr marL="2286000" algn="l" defTabSz="457200" rtl="0" eaLnBrk="1" latinLnBrk="0" hangingPunct="1">
+    <a:lvl6pPr marL="2286000" algn="l" defTabSz="914400" rtl="0" eaLnBrk="1" latinLnBrk="0" hangingPunct="1">
       <a:defRPr sz="1200" kern="1200">
         <a:solidFill>
           <a:schemeClr val="tx1"/>
@@ -435,7 +228,7 @@
         <a:cs typeface="+mn-cs"/>
       </a:defRPr>
     </a:lvl6pPr>
-    <a:lvl7pPr marL="2743200" algn="l" defTabSz="457200" rtl="0" eaLnBrk="1" latinLnBrk="0" hangingPunct="1">
+    <a:lvl7pPr marL="2743200" algn="l" defTabSz="914400" rtl="0" eaLnBrk="1" latinLnBrk="0" hangingPunct="1">
       <a:defRPr sz="1200" kern="1200">
         <a:solidFill>
           <a:schemeClr val="tx1"/>
@@ -445,7 +238,7 @@
         <a:cs typeface="+mn-cs"/>
       </a:defRPr>
     </a:lvl7pPr>
-    <a:lvl8pPr marL="3200400" algn="l" defTabSz="457200" rtl="0" eaLnBrk="1" latinLnBrk="0" hangingPunct="1">
+    <a:lvl8pPr marL="3200400" algn="l" defTabSz="914400" rtl="0" eaLnBrk="1" latinLnBrk="0" hangingPunct="1">
       <a:defRPr sz="1200" kern="1200">
         <a:solidFill>
           <a:schemeClr val="tx1"/>
@@ -455,7 +248,7 @@
         <a:cs typeface="+mn-cs"/>
       </a:defRPr>
     </a:lvl8pPr>
-    <a:lvl9pPr marL="3657600" algn="l" defTabSz="457200" rtl="0" eaLnBrk="1" latinLnBrk="0" hangingPunct="1">
+    <a:lvl9pPr marL="3657600" algn="l" defTabSz="914400" rtl="0" eaLnBrk="1" latinLnBrk="0" hangingPunct="1">
       <a:defRPr sz="1200" kern="1200">
         <a:solidFill>
           <a:schemeClr val="tx1"/>
@@ -467,916 +260,6 @@
     </a:lvl9pPr>
   </p:notesStyle>
 </p:notesMaster>
-</file>
-
-<file path=ppt/notesSlides/notesSlide1.xml><?xml version="1.0" encoding="utf-8"?>
-<p:notes xmlns:a="http://schemas.openxmlformats.org/drawingml/2006/main" xmlns:p="http://schemas.openxmlformats.org/presentationml/2006/main" xmlns:r="http://schemas.openxmlformats.org/officeDocument/2006/relationships">
-  <p:cSld>
-    <p:spTree>
-      <p:nvGrpSpPr>
-        <p:cNvPr id="1" name=""/>
-        <p:cNvGrpSpPr/>
-        <p:nvPr/>
-      </p:nvGrpSpPr>
-      <p:grpSpPr>
-        <a:xfrm>
-          <a:off x="0" y="0"/>
-          <a:ext cx="0" cy="0"/>
-          <a:chOff x="0" y="0"/>
-          <a:chExt cx="0" cy="0"/>
-        </a:xfrm>
-      </p:grpSpPr>
-      <p:sp>
-        <p:nvSpPr>
-          <p:cNvPr id="2" name="Slide Image Placeholder 1"/>
-          <p:cNvSpPr>
-            <a:spLocks noGrp="1"/>
-          </p:cNvSpPr>
-          <p:nvPr>
-            <p:ph type="sldImg" idx="2"/>
-          </p:nvPr>
-        </p:nvSpPr>
-        <p:spPr/>
-      </p:sp>
-      <p:sp>
-        <p:nvSpPr>
-          <p:cNvPr id="3" name="Notes Placeholder 2"/>
-          <p:cNvSpPr>
-            <a:spLocks noGrp="1"/>
-          </p:cNvSpPr>
-          <p:nvPr>
-            <p:ph type="body" idx="3" sz="quarter"/>
-          </p:nvPr>
-        </p:nvSpPr>
-        <p:spPr/>
-        <p:txBody>
-          <a:bodyPr/>
-          <a:lstStyle/>
-          <a:p>
-            <a:r>
-              <a:t>A procedural music generator written in Java.</a:t>
-            </a:r>
-          </a:p>
-        </p:txBody>
-      </p:sp>
-      <p:sp>
-        <p:nvSpPr>
-          <p:cNvPr id="4" name="Slide Number Placeholder 3"/>
-          <p:cNvSpPr>
-            <a:spLocks noGrp="1"/>
-          </p:cNvSpPr>
-          <p:nvPr>
-            <p:ph type="sldNum" idx="5" sz="quarter"/>
-          </p:nvPr>
-        </p:nvSpPr>
-        <p:spPr/>
-      </p:sp>
-    </p:spTree>
-  </p:cSld>
-  <p:clrMapOvr>
-    <a:masterClrMapping/>
-  </p:clrMapOvr>
-</p:notes>
-</file>
-
-<file path=ppt/notesSlides/notesSlide10.xml><?xml version="1.0" encoding="utf-8"?>
-<p:notes xmlns:a="http://schemas.openxmlformats.org/drawingml/2006/main" xmlns:p="http://schemas.openxmlformats.org/presentationml/2006/main" xmlns:r="http://schemas.openxmlformats.org/officeDocument/2006/relationships">
-  <p:cSld>
-    <p:spTree>
-      <p:nvGrpSpPr>
-        <p:cNvPr id="1" name=""/>
-        <p:cNvGrpSpPr/>
-        <p:nvPr/>
-      </p:nvGrpSpPr>
-      <p:grpSpPr>
-        <a:xfrm>
-          <a:off x="0" y="0"/>
-          <a:ext cx="0" cy="0"/>
-          <a:chOff x="0" y="0"/>
-          <a:chExt cx="0" cy="0"/>
-        </a:xfrm>
-      </p:grpSpPr>
-      <p:sp>
-        <p:nvSpPr>
-          <p:cNvPr id="2" name="Slide Image Placeholder 1"/>
-          <p:cNvSpPr>
-            <a:spLocks noGrp="1"/>
-          </p:cNvSpPr>
-          <p:nvPr>
-            <p:ph type="sldImg" idx="2"/>
-          </p:nvPr>
-        </p:nvSpPr>
-        <p:spPr/>
-      </p:sp>
-      <p:sp>
-        <p:nvSpPr>
-          <p:cNvPr id="3" name="Notes Placeholder 2"/>
-          <p:cNvSpPr>
-            <a:spLocks noGrp="1"/>
-          </p:cNvSpPr>
-          <p:nvPr>
-            <p:ph type="body" idx="3" sz="quarter"/>
-          </p:nvPr>
-        </p:nvSpPr>
-        <p:spPr/>
-        <p:txBody>
-          <a:bodyPr/>
-          <a:lstStyle/>
-          <a:p>
-            <a:r>
-              <a:t>Play level 1 and level 5 here. The contrast is the demo. Level 5 is 2.5 times busier.</a:t>
-            </a:r>
-          </a:p>
-        </p:txBody>
-      </p:sp>
-      <p:sp>
-        <p:nvSpPr>
-          <p:cNvPr id="4" name="Slide Number Placeholder 3"/>
-          <p:cNvSpPr>
-            <a:spLocks noGrp="1"/>
-          </p:cNvSpPr>
-          <p:nvPr>
-            <p:ph type="sldNum" idx="5" sz="quarter"/>
-          </p:nvPr>
-        </p:nvSpPr>
-        <p:spPr/>
-      </p:sp>
-    </p:spTree>
-  </p:cSld>
-  <p:clrMapOvr>
-    <a:masterClrMapping/>
-  </p:clrMapOvr>
-</p:notes>
-</file>
-
-<file path=ppt/notesSlides/notesSlide11.xml><?xml version="1.0" encoding="utf-8"?>
-<p:notes xmlns:a="http://schemas.openxmlformats.org/drawingml/2006/main" xmlns:p="http://schemas.openxmlformats.org/presentationml/2006/main" xmlns:r="http://schemas.openxmlformats.org/officeDocument/2006/relationships">
-  <p:cSld>
-    <p:spTree>
-      <p:nvGrpSpPr>
-        <p:cNvPr id="1" name=""/>
-        <p:cNvGrpSpPr/>
-        <p:nvPr/>
-      </p:nvGrpSpPr>
-      <p:grpSpPr>
-        <a:xfrm>
-          <a:off x="0" y="0"/>
-          <a:ext cx="0" cy="0"/>
-          <a:chOff x="0" y="0"/>
-          <a:chExt cx="0" cy="0"/>
-        </a:xfrm>
-      </p:grpSpPr>
-      <p:sp>
-        <p:nvSpPr>
-          <p:cNvPr id="2" name="Slide Image Placeholder 1"/>
-          <p:cNvSpPr>
-            <a:spLocks noGrp="1"/>
-          </p:cNvSpPr>
-          <p:nvPr>
-            <p:ph type="sldImg" idx="2"/>
-          </p:nvPr>
-        </p:nvSpPr>
-        <p:spPr/>
-      </p:sp>
-      <p:sp>
-        <p:nvSpPr>
-          <p:cNvPr id="3" name="Notes Placeholder 2"/>
-          <p:cNvSpPr>
-            <a:spLocks noGrp="1"/>
-          </p:cNvSpPr>
-          <p:nvPr>
-            <p:ph type="body" idx="3" sz="quarter"/>
-          </p:nvPr>
-        </p:nvSpPr>
-        <p:spPr/>
-        <p:txBody>
-          <a:bodyPr/>
-          <a:lstStyle/>
-          <a:p>
-            <a:r>
-              <a:t>Be upfront. Saying it yourself beats being told it.</a:t>
-            </a:r>
-          </a:p>
-        </p:txBody>
-      </p:sp>
-      <p:sp>
-        <p:nvSpPr>
-          <p:cNvPr id="4" name="Slide Number Placeholder 3"/>
-          <p:cNvSpPr>
-            <a:spLocks noGrp="1"/>
-          </p:cNvSpPr>
-          <p:nvPr>
-            <p:ph type="sldNum" idx="5" sz="quarter"/>
-          </p:nvPr>
-        </p:nvSpPr>
-        <p:spPr/>
-      </p:sp>
-    </p:spTree>
-  </p:cSld>
-  <p:clrMapOvr>
-    <a:masterClrMapping/>
-  </p:clrMapOvr>
-</p:notes>
-</file>
-
-<file path=ppt/notesSlides/notesSlide12.xml><?xml version="1.0" encoding="utf-8"?>
-<p:notes xmlns:a="http://schemas.openxmlformats.org/drawingml/2006/main" xmlns:p="http://schemas.openxmlformats.org/presentationml/2006/main" xmlns:r="http://schemas.openxmlformats.org/officeDocument/2006/relationships">
-  <p:cSld>
-    <p:spTree>
-      <p:nvGrpSpPr>
-        <p:cNvPr id="1" name=""/>
-        <p:cNvGrpSpPr/>
-        <p:nvPr/>
-      </p:nvGrpSpPr>
-      <p:grpSpPr>
-        <a:xfrm>
-          <a:off x="0" y="0"/>
-          <a:ext cx="0" cy="0"/>
-          <a:chOff x="0" y="0"/>
-          <a:chExt cx="0" cy="0"/>
-        </a:xfrm>
-      </p:grpSpPr>
-      <p:sp>
-        <p:nvSpPr>
-          <p:cNvPr id="2" name="Slide Image Placeholder 1"/>
-          <p:cNvSpPr>
-            <a:spLocks noGrp="1"/>
-          </p:cNvSpPr>
-          <p:nvPr>
-            <p:ph type="sldImg" idx="2"/>
-          </p:nvPr>
-        </p:nvSpPr>
-        <p:spPr/>
-      </p:sp>
-      <p:sp>
-        <p:nvSpPr>
-          <p:cNvPr id="3" name="Notes Placeholder 2"/>
-          <p:cNvSpPr>
-            <a:spLocks noGrp="1"/>
-          </p:cNvSpPr>
-          <p:nvPr>
-            <p:ph type="body" idx="3" sz="quarter"/>
-          </p:nvPr>
-        </p:nvSpPr>
-        <p:spPr/>
-        <p:txBody>
-          <a:bodyPr/>
-          <a:lstStyle/>
-          <a:p>
-            <a:r>
-              <a:t>The Left 4 Dead point connects back to the course.</a:t>
-            </a:r>
-          </a:p>
-        </p:txBody>
-      </p:sp>
-      <p:sp>
-        <p:nvSpPr>
-          <p:cNvPr id="4" name="Slide Number Placeholder 3"/>
-          <p:cNvSpPr>
-            <a:spLocks noGrp="1"/>
-          </p:cNvSpPr>
-          <p:nvPr>
-            <p:ph type="sldNum" idx="5" sz="quarter"/>
-          </p:nvPr>
-        </p:nvSpPr>
-        <p:spPr/>
-      </p:sp>
-    </p:spTree>
-  </p:cSld>
-  <p:clrMapOvr>
-    <a:masterClrMapping/>
-  </p:clrMapOvr>
-</p:notes>
-</file>
-
-<file path=ppt/notesSlides/notesSlide13.xml><?xml version="1.0" encoding="utf-8"?>
-<p:notes xmlns:a="http://schemas.openxmlformats.org/drawingml/2006/main" xmlns:p="http://schemas.openxmlformats.org/presentationml/2006/main" xmlns:r="http://schemas.openxmlformats.org/officeDocument/2006/relationships">
-  <p:cSld>
-    <p:spTree>
-      <p:nvGrpSpPr>
-        <p:cNvPr id="1" name=""/>
-        <p:cNvGrpSpPr/>
-        <p:nvPr/>
-      </p:nvGrpSpPr>
-      <p:grpSpPr>
-        <a:xfrm>
-          <a:off x="0" y="0"/>
-          <a:ext cx="0" cy="0"/>
-          <a:chOff x="0" y="0"/>
-          <a:chExt cx="0" cy="0"/>
-        </a:xfrm>
-      </p:grpSpPr>
-      <p:sp>
-        <p:nvSpPr>
-          <p:cNvPr id="2" name="Slide Image Placeholder 1"/>
-          <p:cNvSpPr>
-            <a:spLocks noGrp="1"/>
-          </p:cNvSpPr>
-          <p:nvPr>
-            <p:ph type="sldImg" idx="2"/>
-          </p:nvPr>
-        </p:nvSpPr>
-        <p:spPr/>
-      </p:sp>
-      <p:sp>
-        <p:nvSpPr>
-          <p:cNvPr id="3" name="Notes Placeholder 2"/>
-          <p:cNvSpPr>
-            <a:spLocks noGrp="1"/>
-          </p:cNvSpPr>
-          <p:nvPr>
-            <p:ph type="body" idx="3" sz="quarter"/>
-          </p:nvPr>
-        </p:nvSpPr>
-        <p:spPr/>
-        <p:txBody>
-          <a:bodyPr/>
-          <a:lstStyle/>
-          <a:p>
-            <a:r>
-              <a:t>Have level 1 and level 5 ready to play.</a:t>
-            </a:r>
-          </a:p>
-        </p:txBody>
-      </p:sp>
-      <p:sp>
-        <p:nvSpPr>
-          <p:cNvPr id="4" name="Slide Number Placeholder 3"/>
-          <p:cNvSpPr>
-            <a:spLocks noGrp="1"/>
-          </p:cNvSpPr>
-          <p:nvPr>
-            <p:ph type="sldNum" idx="5" sz="quarter"/>
-          </p:nvPr>
-        </p:nvSpPr>
-        <p:spPr/>
-      </p:sp>
-    </p:spTree>
-  </p:cSld>
-  <p:clrMapOvr>
-    <a:masterClrMapping/>
-  </p:clrMapOvr>
-</p:notes>
-</file>
-
-<file path=ppt/notesSlides/notesSlide2.xml><?xml version="1.0" encoding="utf-8"?>
-<p:notes xmlns:a="http://schemas.openxmlformats.org/drawingml/2006/main" xmlns:p="http://schemas.openxmlformats.org/presentationml/2006/main" xmlns:r="http://schemas.openxmlformats.org/officeDocument/2006/relationships">
-  <p:cSld>
-    <p:spTree>
-      <p:nvGrpSpPr>
-        <p:cNvPr id="1" name=""/>
-        <p:cNvGrpSpPr/>
-        <p:nvPr/>
-      </p:nvGrpSpPr>
-      <p:grpSpPr>
-        <a:xfrm>
-          <a:off x="0" y="0"/>
-          <a:ext cx="0" cy="0"/>
-          <a:chOff x="0" y="0"/>
-          <a:chExt cx="0" cy="0"/>
-        </a:xfrm>
-      </p:grpSpPr>
-      <p:sp>
-        <p:nvSpPr>
-          <p:cNvPr id="2" name="Slide Image Placeholder 1"/>
-          <p:cNvSpPr>
-            <a:spLocks noGrp="1"/>
-          </p:cNvSpPr>
-          <p:nvPr>
-            <p:ph type="sldImg" idx="2"/>
-          </p:nvPr>
-        </p:nvSpPr>
-        <p:spPr/>
-      </p:sp>
-      <p:sp>
-        <p:nvSpPr>
-          <p:cNvPr id="3" name="Notes Placeholder 2"/>
-          <p:cNvSpPr>
-            <a:spLocks noGrp="1"/>
-          </p:cNvSpPr>
-          <p:nvPr>
-            <p:ph type="body" idx="3" sz="quarter"/>
-          </p:nvPr>
-        </p:nvSpPr>
-        <p:spPr/>
-        <p:txBody>
-          <a:bodyPr/>
-          <a:lstStyle/>
-          <a:p>
-            <a:r>
-              <a:t>A normal soundtrack is recorded once and never changes.</a:t>
-            </a:r>
-          </a:p>
-        </p:txBody>
-      </p:sp>
-      <p:sp>
-        <p:nvSpPr>
-          <p:cNvPr id="4" name="Slide Number Placeholder 3"/>
-          <p:cNvSpPr>
-            <a:spLocks noGrp="1"/>
-          </p:cNvSpPr>
-          <p:nvPr>
-            <p:ph type="sldNum" idx="5" sz="quarter"/>
-          </p:nvPr>
-        </p:nvSpPr>
-        <p:spPr/>
-      </p:sp>
-    </p:spTree>
-  </p:cSld>
-  <p:clrMapOvr>
-    <a:masterClrMapping/>
-  </p:clrMapOvr>
-</p:notes>
-</file>
-
-<file path=ppt/notesSlides/notesSlide3.xml><?xml version="1.0" encoding="utf-8"?>
-<p:notes xmlns:a="http://schemas.openxmlformats.org/drawingml/2006/main" xmlns:p="http://schemas.openxmlformats.org/presentationml/2006/main" xmlns:r="http://schemas.openxmlformats.org/officeDocument/2006/relationships">
-  <p:cSld>
-    <p:spTree>
-      <p:nvGrpSpPr>
-        <p:cNvPr id="1" name=""/>
-        <p:cNvGrpSpPr/>
-        <p:nvPr/>
-      </p:nvGrpSpPr>
-      <p:grpSpPr>
-        <a:xfrm>
-          <a:off x="0" y="0"/>
-          <a:ext cx="0" cy="0"/>
-          <a:chOff x="0" y="0"/>
-          <a:chExt cx="0" cy="0"/>
-        </a:xfrm>
-      </p:grpSpPr>
-      <p:sp>
-        <p:nvSpPr>
-          <p:cNvPr id="2" name="Slide Image Placeholder 1"/>
-          <p:cNvSpPr>
-            <a:spLocks noGrp="1"/>
-          </p:cNvSpPr>
-          <p:nvPr>
-            <p:ph type="sldImg" idx="2"/>
-          </p:nvPr>
-        </p:nvSpPr>
-        <p:spPr/>
-      </p:sp>
-      <p:sp>
-        <p:nvSpPr>
-          <p:cNvPr id="3" name="Notes Placeholder 2"/>
-          <p:cNvSpPr>
-            <a:spLocks noGrp="1"/>
-          </p:cNvSpPr>
-          <p:nvPr>
-            <p:ph type="body" idx="3" sz="quarter"/>
-          </p:nvPr>
-        </p:nvSpPr>
-        <p:spPr/>
-        <p:txBody>
-          <a:bodyPr/>
-          <a:lstStyle/>
-          <a:p>
-            <a:r>
-              <a:t>Keep it short. Level number in, music out.</a:t>
-            </a:r>
-          </a:p>
-        </p:txBody>
-      </p:sp>
-      <p:sp>
-        <p:nvSpPr>
-          <p:cNvPr id="4" name="Slide Number Placeholder 3"/>
-          <p:cNvSpPr>
-            <a:spLocks noGrp="1"/>
-          </p:cNvSpPr>
-          <p:nvPr>
-            <p:ph type="sldNum" idx="5" sz="quarter"/>
-          </p:nvPr>
-        </p:nvSpPr>
-        <p:spPr/>
-      </p:sp>
-    </p:spTree>
-  </p:cSld>
-  <p:clrMapOvr>
-    <a:masterClrMapping/>
-  </p:clrMapOvr>
-</p:notes>
-</file>
-
-<file path=ppt/notesSlides/notesSlide4.xml><?xml version="1.0" encoding="utf-8"?>
-<p:notes xmlns:a="http://schemas.openxmlformats.org/drawingml/2006/main" xmlns:p="http://schemas.openxmlformats.org/presentationml/2006/main" xmlns:r="http://schemas.openxmlformats.org/officeDocument/2006/relationships">
-  <p:cSld>
-    <p:spTree>
-      <p:nvGrpSpPr>
-        <p:cNvPr id="1" name=""/>
-        <p:cNvGrpSpPr/>
-        <p:nvPr/>
-      </p:nvGrpSpPr>
-      <p:grpSpPr>
-        <a:xfrm>
-          <a:off x="0" y="0"/>
-          <a:ext cx="0" cy="0"/>
-          <a:chOff x="0" y="0"/>
-          <a:chExt cx="0" cy="0"/>
-        </a:xfrm>
-      </p:grpSpPr>
-      <p:sp>
-        <p:nvSpPr>
-          <p:cNvPr id="2" name="Slide Image Placeholder 1"/>
-          <p:cNvSpPr>
-            <a:spLocks noGrp="1"/>
-          </p:cNvSpPr>
-          <p:nvPr>
-            <p:ph type="sldImg" idx="2"/>
-          </p:nvPr>
-        </p:nvSpPr>
-        <p:spPr/>
-      </p:sp>
-      <p:sp>
-        <p:nvSpPr>
-          <p:cNvPr id="3" name="Notes Placeholder 2"/>
-          <p:cNvSpPr>
-            <a:spLocks noGrp="1"/>
-          </p:cNvSpPr>
-          <p:nvPr>
-            <p:ph type="body" idx="3" sz="quarter"/>
-          </p:nvPr>
-        </p:nvSpPr>
-        <p:spPr/>
-        <p:txBody>
-          <a:bodyPr/>
-          <a:lstStyle/>
-          <a:p>
-            <a:r>
-              <a:t>MIDI numbers every piano key. 60 is middle C and 72 is the C above it. They are 12 apart, so they are the same note name and always sound right together. The program only uses these two.</a:t>
-            </a:r>
-          </a:p>
-        </p:txBody>
-      </p:sp>
-      <p:sp>
-        <p:nvSpPr>
-          <p:cNvPr id="4" name="Slide Number Placeholder 3"/>
-          <p:cNvSpPr>
-            <a:spLocks noGrp="1"/>
-          </p:cNvSpPr>
-          <p:nvPr>
-            <p:ph type="sldNum" idx="5" sz="quarter"/>
-          </p:nvPr>
-        </p:nvSpPr>
-        <p:spPr/>
-      </p:sp>
-    </p:spTree>
-  </p:cSld>
-  <p:clrMapOvr>
-    <a:masterClrMapping/>
-  </p:clrMapOvr>
-</p:notes>
-</file>
-
-<file path=ppt/notesSlides/notesSlide5.xml><?xml version="1.0" encoding="utf-8"?>
-<p:notes xmlns:a="http://schemas.openxmlformats.org/drawingml/2006/main" xmlns:p="http://schemas.openxmlformats.org/presentationml/2006/main" xmlns:r="http://schemas.openxmlformats.org/officeDocument/2006/relationships">
-  <p:cSld>
-    <p:spTree>
-      <p:nvGrpSpPr>
-        <p:cNvPr id="1" name=""/>
-        <p:cNvGrpSpPr/>
-        <p:nvPr/>
-      </p:nvGrpSpPr>
-      <p:grpSpPr>
-        <a:xfrm>
-          <a:off x="0" y="0"/>
-          <a:ext cx="0" cy="0"/>
-          <a:chOff x="0" y="0"/>
-          <a:chExt cx="0" cy="0"/>
-        </a:xfrm>
-      </p:grpSpPr>
-      <p:sp>
-        <p:nvSpPr>
-          <p:cNvPr id="2" name="Slide Image Placeholder 1"/>
-          <p:cNvSpPr>
-            <a:spLocks noGrp="1"/>
-          </p:cNvSpPr>
-          <p:nvPr>
-            <p:ph type="sldImg" idx="2"/>
-          </p:nvPr>
-        </p:nvSpPr>
-        <p:spPr/>
-      </p:sp>
-      <p:sp>
-        <p:nvSpPr>
-          <p:cNvPr id="3" name="Notes Placeholder 2"/>
-          <p:cNvSpPr>
-            <a:spLocks noGrp="1"/>
-          </p:cNvSpPr>
-          <p:nvPr>
-            <p:ph type="body" idx="3" sz="quarter"/>
-          </p:nvPr>
-        </p:nvSpPr>
-        <p:spPr/>
-        <p:txBody>
-          <a:bodyPr/>
-          <a:lstStyle/>
-          <a:p>
-            <a:r>
-              <a:t>Tempo matters later, because difficulty controls it. MIDI is a recipe, not a cake.</a:t>
-            </a:r>
-          </a:p>
-        </p:txBody>
-      </p:sp>
-      <p:sp>
-        <p:nvSpPr>
-          <p:cNvPr id="4" name="Slide Number Placeholder 3"/>
-          <p:cNvSpPr>
-            <a:spLocks noGrp="1"/>
-          </p:cNvSpPr>
-          <p:nvPr>
-            <p:ph type="sldNum" idx="5" sz="quarter"/>
-          </p:nvPr>
-        </p:nvSpPr>
-        <p:spPr/>
-      </p:sp>
-    </p:spTree>
-  </p:cSld>
-  <p:clrMapOvr>
-    <a:masterClrMapping/>
-  </p:clrMapOvr>
-</p:notes>
-</file>
-
-<file path=ppt/notesSlides/notesSlide6.xml><?xml version="1.0" encoding="utf-8"?>
-<p:notes xmlns:a="http://schemas.openxmlformats.org/drawingml/2006/main" xmlns:p="http://schemas.openxmlformats.org/presentationml/2006/main" xmlns:r="http://schemas.openxmlformats.org/officeDocument/2006/relationships">
-  <p:cSld>
-    <p:spTree>
-      <p:nvGrpSpPr>
-        <p:cNvPr id="1" name=""/>
-        <p:cNvGrpSpPr/>
-        <p:nvPr/>
-      </p:nvGrpSpPr>
-      <p:grpSpPr>
-        <a:xfrm>
-          <a:off x="0" y="0"/>
-          <a:ext cx="0" cy="0"/>
-          <a:chOff x="0" y="0"/>
-          <a:chExt cx="0" cy="0"/>
-        </a:xfrm>
-      </p:grpSpPr>
-      <p:sp>
-        <p:nvSpPr>
-          <p:cNvPr id="2" name="Slide Image Placeholder 1"/>
-          <p:cNvSpPr>
-            <a:spLocks noGrp="1"/>
-          </p:cNvSpPr>
-          <p:nvPr>
-            <p:ph type="sldImg" idx="2"/>
-          </p:nvPr>
-        </p:nvSpPr>
-        <p:spPr/>
-      </p:sp>
-      <p:sp>
-        <p:nvSpPr>
-          <p:cNvPr id="3" name="Notes Placeholder 2"/>
-          <p:cNvSpPr>
-            <a:spLocks noGrp="1"/>
-          </p:cNvSpPr>
-          <p:nvPr>
-            <p:ph type="body" idx="3" sz="quarter"/>
-          </p:nvPr>
-        </p:nvSpPr>
-        <p:spPr/>
-        <p:txBody>
-          <a:bodyPr/>
-          <a:lstStyle/>
-          <a:p>
-            <a:r>
-              <a:t>This is the core. Without the repeat you get low high low high forever and every level is identical. The repeat creates the variety. The proper name is a two state Markov chain.</a:t>
-            </a:r>
-          </a:p>
-        </p:txBody>
-      </p:sp>
-      <p:sp>
-        <p:nvSpPr>
-          <p:cNvPr id="4" name="Slide Number Placeholder 3"/>
-          <p:cNvSpPr>
-            <a:spLocks noGrp="1"/>
-          </p:cNvSpPr>
-          <p:nvPr>
-            <p:ph type="sldNum" idx="5" sz="quarter"/>
-          </p:nvPr>
-        </p:nvSpPr>
-        <p:spPr/>
-      </p:sp>
-    </p:spTree>
-  </p:cSld>
-  <p:clrMapOvr>
-    <a:masterClrMapping/>
-  </p:clrMapOvr>
-</p:notes>
-</file>
-
-<file path=ppt/notesSlides/notesSlide7.xml><?xml version="1.0" encoding="utf-8"?>
-<p:notes xmlns:a="http://schemas.openxmlformats.org/drawingml/2006/main" xmlns:p="http://schemas.openxmlformats.org/presentationml/2006/main" xmlns:r="http://schemas.openxmlformats.org/officeDocument/2006/relationships">
-  <p:cSld>
-    <p:spTree>
-      <p:nvGrpSpPr>
-        <p:cNvPr id="1" name=""/>
-        <p:cNvGrpSpPr/>
-        <p:nvPr/>
-      </p:nvGrpSpPr>
-      <p:grpSpPr>
-        <a:xfrm>
-          <a:off x="0" y="0"/>
-          <a:ext cx="0" cy="0"/>
-          <a:chOff x="0" y="0"/>
-          <a:chExt cx="0" cy="0"/>
-        </a:xfrm>
-      </p:grpSpPr>
-      <p:sp>
-        <p:nvSpPr>
-          <p:cNvPr id="2" name="Slide Image Placeholder 1"/>
-          <p:cNvSpPr>
-            <a:spLocks noGrp="1"/>
-          </p:cNvSpPr>
-          <p:nvPr>
-            <p:ph type="sldImg" idx="2"/>
-          </p:nvPr>
-        </p:nvSpPr>
-        <p:spPr/>
-      </p:sp>
-      <p:sp>
-        <p:nvSpPr>
-          <p:cNvPr id="3" name="Notes Placeholder 2"/>
-          <p:cNvSpPr>
-            <a:spLocks noGrp="1"/>
-          </p:cNvSpPr>
-          <p:nvPr>
-            <p:ph type="body" idx="3" sz="quarter"/>
-          </p:nvPr>
-        </p:nvSpPr>
-        <p:spPr/>
-        <p:txBody>
-          <a:bodyPr/>
-          <a:lstStyle/>
-          <a:p>
-            <a:r>
-              <a:t>The strongest practical argument. Five numbers instead of five audio files.</a:t>
-            </a:r>
-          </a:p>
-        </p:txBody>
-      </p:sp>
-      <p:sp>
-        <p:nvSpPr>
-          <p:cNvPr id="4" name="Slide Number Placeholder 3"/>
-          <p:cNvSpPr>
-            <a:spLocks noGrp="1"/>
-          </p:cNvSpPr>
-          <p:nvPr>
-            <p:ph type="sldNum" idx="5" sz="quarter"/>
-          </p:nvPr>
-        </p:nvSpPr>
-        <p:spPr/>
-      </p:sp>
-    </p:spTree>
-  </p:cSld>
-  <p:clrMapOvr>
-    <a:masterClrMapping/>
-  </p:clrMapOvr>
-</p:notes>
-</file>
-
-<file path=ppt/notesSlides/notesSlide8.xml><?xml version="1.0" encoding="utf-8"?>
-<p:notes xmlns:a="http://schemas.openxmlformats.org/drawingml/2006/main" xmlns:p="http://schemas.openxmlformats.org/presentationml/2006/main" xmlns:r="http://schemas.openxmlformats.org/officeDocument/2006/relationships">
-  <p:cSld>
-    <p:spTree>
-      <p:nvGrpSpPr>
-        <p:cNvPr id="1" name=""/>
-        <p:cNvGrpSpPr/>
-        <p:nvPr/>
-      </p:nvGrpSpPr>
-      <p:grpSpPr>
-        <a:xfrm>
-          <a:off x="0" y="0"/>
-          <a:ext cx="0" cy="0"/>
-          <a:chOff x="0" y="0"/>
-          <a:chExt cx="0" cy="0"/>
-        </a:xfrm>
-      </p:grpSpPr>
-      <p:sp>
-        <p:nvSpPr>
-          <p:cNvPr id="2" name="Slide Image Placeholder 1"/>
-          <p:cNvSpPr>
-            <a:spLocks noGrp="1"/>
-          </p:cNvSpPr>
-          <p:nvPr>
-            <p:ph type="sldImg" idx="2"/>
-          </p:nvPr>
-        </p:nvSpPr>
-        <p:spPr/>
-      </p:sp>
-      <p:sp>
-        <p:nvSpPr>
-          <p:cNvPr id="3" name="Notes Placeholder 2"/>
-          <p:cNvSpPr>
-            <a:spLocks noGrp="1"/>
-          </p:cNvSpPr>
-          <p:nvPr>
-            <p:ph type="body" idx="3" sz="quarter"/>
-          </p:nvPr>
-        </p:nvSpPr>
-        <p:spPr/>
-        <p:txBody>
-          <a:bodyPr/>
-          <a:lstStyle/>
-          <a:p>
-            <a:r>
-              <a:t>Taxonomy is from Shaker, Togelius and Nelson. Almost everything in the course is generic. This one reacts to the game.</a:t>
-            </a:r>
-          </a:p>
-        </p:txBody>
-      </p:sp>
-      <p:sp>
-        <p:nvSpPr>
-          <p:cNvPr id="4" name="Slide Number Placeholder 3"/>
-          <p:cNvSpPr>
-            <a:spLocks noGrp="1"/>
-          </p:cNvSpPr>
-          <p:nvPr>
-            <p:ph type="sldNum" idx="5" sz="quarter"/>
-          </p:nvPr>
-        </p:nvSpPr>
-        <p:spPr/>
-      </p:sp>
-    </p:spTree>
-  </p:cSld>
-  <p:clrMapOvr>
-    <a:masterClrMapping/>
-  </p:clrMapOvr>
-</p:notes>
-</file>
-
-<file path=ppt/notesSlides/notesSlide9.xml><?xml version="1.0" encoding="utf-8"?>
-<p:notes xmlns:a="http://schemas.openxmlformats.org/drawingml/2006/main" xmlns:p="http://schemas.openxmlformats.org/presentationml/2006/main" xmlns:r="http://schemas.openxmlformats.org/officeDocument/2006/relationships">
-  <p:cSld>
-    <p:spTree>
-      <p:nvGrpSpPr>
-        <p:cNvPr id="1" name=""/>
-        <p:cNvGrpSpPr/>
-        <p:nvPr/>
-      </p:nvGrpSpPr>
-      <p:grpSpPr>
-        <a:xfrm>
-          <a:off x="0" y="0"/>
-          <a:ext cx="0" cy="0"/>
-          <a:chOff x="0" y="0"/>
-          <a:chExt cx="0" cy="0"/>
-        </a:xfrm>
-      </p:grpSpPr>
-      <p:sp>
-        <p:nvSpPr>
-          <p:cNvPr id="2" name="Slide Image Placeholder 1"/>
-          <p:cNvSpPr>
-            <a:spLocks noGrp="1"/>
-          </p:cNvSpPr>
-          <p:nvPr>
-            <p:ph type="sldImg" idx="2"/>
-          </p:nvPr>
-        </p:nvSpPr>
-        <p:spPr/>
-      </p:sp>
-      <p:sp>
-        <p:nvSpPr>
-          <p:cNvPr id="3" name="Notes Placeholder 2"/>
-          <p:cNvSpPr>
-            <a:spLocks noGrp="1"/>
-          </p:cNvSpPr>
-          <p:nvPr>
-            <p:ph type="body" idx="3" sz="quarter"/>
-          </p:nvPr>
-        </p:nvSpPr>
-        <p:spPr/>
-        <p:txBody>
-          <a:bodyPr/>
-          <a:lstStyle/>
-          <a:p>
-            <a:r>
-              <a:t>Each block is one beat. Top row is the high note, bottom row is the low note. The zig zag is the swapping. Two blocks together on one row is a repeat. Same two notes every level. Only the repeats and the speed change.</a:t>
-            </a:r>
-          </a:p>
-        </p:txBody>
-      </p:sp>
-      <p:sp>
-        <p:nvSpPr>
-          <p:cNvPr id="4" name="Slide Number Placeholder 3"/>
-          <p:cNvSpPr>
-            <a:spLocks noGrp="1"/>
-          </p:cNvSpPr>
-          <p:nvPr>
-            <p:ph type="sldNum" idx="5" sz="quarter"/>
-          </p:nvPr>
-        </p:nvSpPr>
-        <p:spPr/>
-      </p:sp>
-    </p:spTree>
-  </p:cSld>
-  <p:clrMapOvr>
-    <a:masterClrMapping/>
-  </p:clrMapOvr>
-</p:notes>
 </file>
 
 <file path=ppt/slideLayouts/slideLayout1.xml><?xml version="1.0" encoding="utf-8"?>
@@ -1417,10 +300,9 @@
           <a:lstStyle/>
           <a:p>
             <a:r>
-              <a:rPr lang="en-US" smtClean="0"/>
+              <a:rPr lang="en-US"/>
               <a:t>Click to edit Master title style</a:t>
             </a:r>
-            <a:endParaRPr lang="en-US"/>
           </a:p>
         </p:txBody>
       </p:sp>
@@ -1536,10 +418,9 @@
           </a:lstStyle>
           <a:p>
             <a:r>
-              <a:rPr lang="en-US" smtClean="0"/>
+              <a:rPr lang="en-US"/>
               <a:t>Click to edit Master subtitle style</a:t>
             </a:r>
-            <a:endParaRPr lang="en-US"/>
           </a:p>
         </p:txBody>
       </p:sp>
@@ -1560,7 +441,7 @@
           <a:p>
             <a:fld id="{5BCAD085-E8A6-8845-BD4E-CB4CCA059FC4}" type="datetimeFigureOut">
               <a:rPr lang="en-US" smtClean="0"/>
-              <a:t>1/27/13</a:t>
+              <a:t>10/18/26</a:t>
             </a:fld>
             <a:endParaRPr lang="en-US"/>
           </a:p>
@@ -1654,10 +535,9 @@
           <a:lstStyle/>
           <a:p>
             <a:r>
-              <a:rPr lang="en-US" smtClean="0"/>
+              <a:rPr lang="en-US"/>
               <a:t>Click to edit Master title style</a:t>
             </a:r>
-            <a:endParaRPr lang="en-US"/>
           </a:p>
         </p:txBody>
       </p:sp>
@@ -1678,38 +558,37 @@
           <a:p>
             <a:pPr lvl="0"/>
             <a:r>
-              <a:rPr lang="en-US" smtClean="0"/>
+              <a:rPr lang="en-US"/>
               <a:t>Click to edit Master text styles</a:t>
             </a:r>
           </a:p>
           <a:p>
             <a:pPr lvl="1"/>
             <a:r>
-              <a:rPr lang="en-US" smtClean="0"/>
+              <a:rPr lang="en-US"/>
               <a:t>Second level</a:t>
             </a:r>
           </a:p>
           <a:p>
             <a:pPr lvl="2"/>
             <a:r>
-              <a:rPr lang="en-US" smtClean="0"/>
+              <a:rPr lang="en-US"/>
               <a:t>Third level</a:t>
             </a:r>
           </a:p>
           <a:p>
             <a:pPr lvl="3"/>
             <a:r>
-              <a:rPr lang="en-US" smtClean="0"/>
+              <a:rPr lang="en-US"/>
               <a:t>Fourth level</a:t>
             </a:r>
           </a:p>
           <a:p>
             <a:pPr lvl="4"/>
             <a:r>
-              <a:rPr lang="en-US" smtClean="0"/>
+              <a:rPr lang="en-US"/>
               <a:t>Fifth level</a:t>
             </a:r>
-            <a:endParaRPr lang="en-US"/>
           </a:p>
         </p:txBody>
       </p:sp>
@@ -1730,7 +609,7 @@
           <a:p>
             <a:fld id="{5BCAD085-E8A6-8845-BD4E-CB4CCA059FC4}" type="datetimeFigureOut">
               <a:rPr lang="en-US" smtClean="0"/>
-              <a:t>1/27/13</a:t>
+              <a:t>10/18/26</a:t>
             </a:fld>
             <a:endParaRPr lang="en-US"/>
           </a:p>
@@ -1829,10 +708,9 @@
           <a:lstStyle/>
           <a:p>
             <a:r>
-              <a:rPr lang="en-US" smtClean="0"/>
+              <a:rPr lang="en-US"/>
               <a:t>Click to edit Master title style</a:t>
             </a:r>
-            <a:endParaRPr lang="en-US"/>
           </a:p>
         </p:txBody>
       </p:sp>
@@ -1858,38 +736,37 @@
           <a:p>
             <a:pPr lvl="0"/>
             <a:r>
-              <a:rPr lang="en-US" smtClean="0"/>
+              <a:rPr lang="en-US"/>
               <a:t>Click to edit Master text styles</a:t>
             </a:r>
           </a:p>
           <a:p>
             <a:pPr lvl="1"/>
             <a:r>
-              <a:rPr lang="en-US" smtClean="0"/>
+              <a:rPr lang="en-US"/>
               <a:t>Second level</a:t>
             </a:r>
           </a:p>
           <a:p>
             <a:pPr lvl="2"/>
             <a:r>
-              <a:rPr lang="en-US" smtClean="0"/>
+              <a:rPr lang="en-US"/>
               <a:t>Third level</a:t>
             </a:r>
           </a:p>
           <a:p>
             <a:pPr lvl="3"/>
             <a:r>
-              <a:rPr lang="en-US" smtClean="0"/>
+              <a:rPr lang="en-US"/>
               <a:t>Fourth level</a:t>
             </a:r>
           </a:p>
           <a:p>
             <a:pPr lvl="4"/>
             <a:r>
-              <a:rPr lang="en-US" smtClean="0"/>
+              <a:rPr lang="en-US"/>
               <a:t>Fifth level</a:t>
             </a:r>
-            <a:endParaRPr lang="en-US"/>
           </a:p>
         </p:txBody>
       </p:sp>
@@ -1910,7 +787,7 @@
           <a:p>
             <a:fld id="{5BCAD085-E8A6-8845-BD4E-CB4CCA059FC4}" type="datetimeFigureOut">
               <a:rPr lang="en-US" smtClean="0"/>
-              <a:t>1/27/13</a:t>
+              <a:t>10/18/26</a:t>
             </a:fld>
             <a:endParaRPr lang="en-US"/>
           </a:p>
@@ -2004,10 +881,9 @@
           <a:lstStyle/>
           <a:p>
             <a:r>
-              <a:rPr lang="en-US" smtClean="0"/>
+              <a:rPr lang="en-US"/>
               <a:t>Click to edit Master title style</a:t>
             </a:r>
-            <a:endParaRPr lang="en-US"/>
           </a:p>
         </p:txBody>
       </p:sp>
@@ -2028,38 +904,37 @@
           <a:p>
             <a:pPr lvl="0"/>
             <a:r>
-              <a:rPr lang="en-US" smtClean="0"/>
+              <a:rPr lang="en-US"/>
               <a:t>Click to edit Master text styles</a:t>
             </a:r>
           </a:p>
           <a:p>
             <a:pPr lvl="1"/>
             <a:r>
-              <a:rPr lang="en-US" smtClean="0"/>
+              <a:rPr lang="en-US"/>
               <a:t>Second level</a:t>
             </a:r>
           </a:p>
           <a:p>
             <a:pPr lvl="2"/>
             <a:r>
-              <a:rPr lang="en-US" smtClean="0"/>
+              <a:rPr lang="en-US"/>
               <a:t>Third level</a:t>
             </a:r>
           </a:p>
           <a:p>
             <a:pPr lvl="3"/>
             <a:r>
-              <a:rPr lang="en-US" smtClean="0"/>
+              <a:rPr lang="en-US"/>
               <a:t>Fourth level</a:t>
             </a:r>
           </a:p>
           <a:p>
             <a:pPr lvl="4"/>
             <a:r>
-              <a:rPr lang="en-US" smtClean="0"/>
+              <a:rPr lang="en-US"/>
               <a:t>Fifth level</a:t>
             </a:r>
-            <a:endParaRPr lang="en-US"/>
           </a:p>
         </p:txBody>
       </p:sp>
@@ -2080,7 +955,7 @@
           <a:p>
             <a:fld id="{5BCAD085-E8A6-8845-BD4E-CB4CCA059FC4}" type="datetimeFigureOut">
               <a:rPr lang="en-US" smtClean="0"/>
-              <a:t>1/27/13</a:t>
+              <a:t>10/18/26</a:t>
             </a:fld>
             <a:endParaRPr lang="en-US"/>
           </a:p>
@@ -2183,10 +1058,9 @@
           </a:lstStyle>
           <a:p>
             <a:r>
-              <a:rPr lang="en-US" smtClean="0"/>
+              <a:rPr lang="en-US"/>
               <a:t>Click to edit Master title style</a:t>
             </a:r>
-            <a:endParaRPr lang="en-US"/>
           </a:p>
         </p:txBody>
       </p:sp>
@@ -2303,7 +1177,7 @@
           <a:p>
             <a:pPr lvl="0"/>
             <a:r>
-              <a:rPr lang="en-US" smtClean="0"/>
+              <a:rPr lang="en-US"/>
               <a:t>Click to edit Master text styles</a:t>
             </a:r>
           </a:p>
@@ -2326,7 +1200,7 @@
           <a:p>
             <a:fld id="{5BCAD085-E8A6-8845-BD4E-CB4CCA059FC4}" type="datetimeFigureOut">
               <a:rPr lang="en-US" smtClean="0"/>
-              <a:t>1/27/13</a:t>
+              <a:t>10/18/26</a:t>
             </a:fld>
             <a:endParaRPr lang="en-US"/>
           </a:p>
@@ -2420,10 +1294,9 @@
           <a:lstStyle/>
           <a:p>
             <a:r>
-              <a:rPr lang="en-US" smtClean="0"/>
+              <a:rPr lang="en-US"/>
               <a:t>Click to edit Master title style</a:t>
             </a:r>
-            <a:endParaRPr lang="en-US"/>
           </a:p>
         </p:txBody>
       </p:sp>
@@ -2477,38 +1350,37 @@
           <a:p>
             <a:pPr lvl="0"/>
             <a:r>
-              <a:rPr lang="en-US" smtClean="0"/>
+              <a:rPr lang="en-US"/>
               <a:t>Click to edit Master text styles</a:t>
             </a:r>
           </a:p>
           <a:p>
             <a:pPr lvl="1"/>
             <a:r>
-              <a:rPr lang="en-US" smtClean="0"/>
+              <a:rPr lang="en-US"/>
               <a:t>Second level</a:t>
             </a:r>
           </a:p>
           <a:p>
             <a:pPr lvl="2"/>
             <a:r>
-              <a:rPr lang="en-US" smtClean="0"/>
+              <a:rPr lang="en-US"/>
               <a:t>Third level</a:t>
             </a:r>
           </a:p>
           <a:p>
             <a:pPr lvl="3"/>
             <a:r>
-              <a:rPr lang="en-US" smtClean="0"/>
+              <a:rPr lang="en-US"/>
               <a:t>Fourth level</a:t>
             </a:r>
           </a:p>
           <a:p>
             <a:pPr lvl="4"/>
             <a:r>
-              <a:rPr lang="en-US" smtClean="0"/>
+              <a:rPr lang="en-US"/>
               <a:t>Fifth level</a:t>
             </a:r>
-            <a:endParaRPr lang="en-US"/>
           </a:p>
         </p:txBody>
       </p:sp>
@@ -2562,38 +1434,37 @@
           <a:p>
             <a:pPr lvl="0"/>
             <a:r>
-              <a:rPr lang="en-US" smtClean="0"/>
+              <a:rPr lang="en-US"/>
               <a:t>Click to edit Master text styles</a:t>
             </a:r>
           </a:p>
           <a:p>
             <a:pPr lvl="1"/>
             <a:r>
-              <a:rPr lang="en-US" smtClean="0"/>
+              <a:rPr lang="en-US"/>
               <a:t>Second level</a:t>
             </a:r>
           </a:p>
           <a:p>
             <a:pPr lvl="2"/>
             <a:r>
-              <a:rPr lang="en-US" smtClean="0"/>
+              <a:rPr lang="en-US"/>
               <a:t>Third level</a:t>
             </a:r>
           </a:p>
           <a:p>
             <a:pPr lvl="3"/>
             <a:r>
-              <a:rPr lang="en-US" smtClean="0"/>
+              <a:rPr lang="en-US"/>
               <a:t>Fourth level</a:t>
             </a:r>
           </a:p>
           <a:p>
             <a:pPr lvl="4"/>
             <a:r>
-              <a:rPr lang="en-US" smtClean="0"/>
+              <a:rPr lang="en-US"/>
               <a:t>Fifth level</a:t>
             </a:r>
-            <a:endParaRPr lang="en-US"/>
           </a:p>
         </p:txBody>
       </p:sp>
@@ -2614,7 +1485,7 @@
           <a:p>
             <a:fld id="{5BCAD085-E8A6-8845-BD4E-CB4CCA059FC4}" type="datetimeFigureOut">
               <a:rPr lang="en-US" smtClean="0"/>
-              <a:t>1/27/13</a:t>
+              <a:t>10/18/26</a:t>
             </a:fld>
             <a:endParaRPr lang="en-US"/>
           </a:p>
@@ -2712,10 +1583,9 @@
           </a:lstStyle>
           <a:p>
             <a:r>
-              <a:rPr lang="en-US" smtClean="0"/>
+              <a:rPr lang="en-US"/>
               <a:t>Click to edit Master title style</a:t>
             </a:r>
-            <a:endParaRPr lang="en-US"/>
           </a:p>
         </p:txBody>
       </p:sp>
@@ -2778,7 +1648,7 @@
           <a:p>
             <a:pPr lvl="0"/>
             <a:r>
-              <a:rPr lang="en-US" smtClean="0"/>
+              <a:rPr lang="en-US"/>
               <a:t>Click to edit Master text styles</a:t>
             </a:r>
           </a:p>
@@ -2834,38 +1704,37 @@
           <a:p>
             <a:pPr lvl="0"/>
             <a:r>
-              <a:rPr lang="en-US" smtClean="0"/>
+              <a:rPr lang="en-US"/>
               <a:t>Click to edit Master text styles</a:t>
             </a:r>
           </a:p>
           <a:p>
             <a:pPr lvl="1"/>
             <a:r>
-              <a:rPr lang="en-US" smtClean="0"/>
+              <a:rPr lang="en-US"/>
               <a:t>Second level</a:t>
             </a:r>
           </a:p>
           <a:p>
             <a:pPr lvl="2"/>
             <a:r>
-              <a:rPr lang="en-US" smtClean="0"/>
+              <a:rPr lang="en-US"/>
               <a:t>Third level</a:t>
             </a:r>
           </a:p>
           <a:p>
             <a:pPr lvl="3"/>
             <a:r>
-              <a:rPr lang="en-US" smtClean="0"/>
+              <a:rPr lang="en-US"/>
               <a:t>Fourth level</a:t>
             </a:r>
           </a:p>
           <a:p>
             <a:pPr lvl="4"/>
             <a:r>
-              <a:rPr lang="en-US" smtClean="0"/>
+              <a:rPr lang="en-US"/>
               <a:t>Fifth level</a:t>
             </a:r>
-            <a:endParaRPr lang="en-US"/>
           </a:p>
         </p:txBody>
       </p:sp>
@@ -2928,7 +1797,7 @@
           <a:p>
             <a:pPr lvl="0"/>
             <a:r>
-              <a:rPr lang="en-US" smtClean="0"/>
+              <a:rPr lang="en-US"/>
               <a:t>Click to edit Master text styles</a:t>
             </a:r>
           </a:p>
@@ -2984,38 +1853,37 @@
           <a:p>
             <a:pPr lvl="0"/>
             <a:r>
-              <a:rPr lang="en-US" smtClean="0"/>
+              <a:rPr lang="en-US"/>
               <a:t>Click to edit Master text styles</a:t>
             </a:r>
           </a:p>
           <a:p>
             <a:pPr lvl="1"/>
             <a:r>
-              <a:rPr lang="en-US" smtClean="0"/>
+              <a:rPr lang="en-US"/>
               <a:t>Second level</a:t>
             </a:r>
           </a:p>
           <a:p>
             <a:pPr lvl="2"/>
             <a:r>
-              <a:rPr lang="en-US" smtClean="0"/>
+              <a:rPr lang="en-US"/>
               <a:t>Third level</a:t>
             </a:r>
           </a:p>
           <a:p>
             <a:pPr lvl="3"/>
             <a:r>
-              <a:rPr lang="en-US" smtClean="0"/>
+              <a:rPr lang="en-US"/>
               <a:t>Fourth level</a:t>
             </a:r>
           </a:p>
           <a:p>
             <a:pPr lvl="4"/>
             <a:r>
-              <a:rPr lang="en-US" smtClean="0"/>
+              <a:rPr lang="en-US"/>
               <a:t>Fifth level</a:t>
             </a:r>
-            <a:endParaRPr lang="en-US"/>
           </a:p>
         </p:txBody>
       </p:sp>
@@ -3036,7 +1904,7 @@
           <a:p>
             <a:fld id="{5BCAD085-E8A6-8845-BD4E-CB4CCA059FC4}" type="datetimeFigureOut">
               <a:rPr lang="en-US" smtClean="0"/>
-              <a:t>1/27/13</a:t>
+              <a:t>10/18/26</a:t>
             </a:fld>
             <a:endParaRPr lang="en-US"/>
           </a:p>
@@ -3130,10 +1998,9 @@
           <a:lstStyle/>
           <a:p>
             <a:r>
-              <a:rPr lang="en-US" smtClean="0"/>
+              <a:rPr lang="en-US"/>
               <a:t>Click to edit Master title style</a:t>
             </a:r>
-            <a:endParaRPr lang="en-US"/>
           </a:p>
         </p:txBody>
       </p:sp>
@@ -3154,7 +2021,7 @@
           <a:p>
             <a:fld id="{5BCAD085-E8A6-8845-BD4E-CB4CCA059FC4}" type="datetimeFigureOut">
               <a:rPr lang="en-US" smtClean="0"/>
-              <a:t>1/27/13</a:t>
+              <a:t>10/18/26</a:t>
             </a:fld>
             <a:endParaRPr lang="en-US"/>
           </a:p>
@@ -3249,7 +2116,7 @@
           <a:p>
             <a:fld id="{5BCAD085-E8A6-8845-BD4E-CB4CCA059FC4}" type="datetimeFigureOut">
               <a:rPr lang="en-US" smtClean="0"/>
-              <a:t>1/27/13</a:t>
+              <a:t>10/18/26</a:t>
             </a:fld>
             <a:endParaRPr lang="en-US"/>
           </a:p>
@@ -3352,10 +2219,9 @@
           </a:lstStyle>
           <a:p>
             <a:r>
-              <a:rPr lang="en-US" smtClean="0"/>
+              <a:rPr lang="en-US"/>
               <a:t>Click to edit Master title style</a:t>
             </a:r>
-            <a:endParaRPr lang="en-US"/>
           </a:p>
         </p:txBody>
       </p:sp>
@@ -3409,38 +2275,37 @@
           <a:p>
             <a:pPr lvl="0"/>
             <a:r>
-              <a:rPr lang="en-US" smtClean="0"/>
+              <a:rPr lang="en-US"/>
               <a:t>Click to edit Master text styles</a:t>
             </a:r>
           </a:p>
           <a:p>
             <a:pPr lvl="1"/>
             <a:r>
-              <a:rPr lang="en-US" smtClean="0"/>
+              <a:rPr lang="en-US"/>
               <a:t>Second level</a:t>
             </a:r>
           </a:p>
           <a:p>
             <a:pPr lvl="2"/>
             <a:r>
-              <a:rPr lang="en-US" smtClean="0"/>
+              <a:rPr lang="en-US"/>
               <a:t>Third level</a:t>
             </a:r>
           </a:p>
           <a:p>
             <a:pPr lvl="3"/>
             <a:r>
-              <a:rPr lang="en-US" smtClean="0"/>
+              <a:rPr lang="en-US"/>
               <a:t>Fourth level</a:t>
             </a:r>
           </a:p>
           <a:p>
             <a:pPr lvl="4"/>
             <a:r>
-              <a:rPr lang="en-US" smtClean="0"/>
+              <a:rPr lang="en-US"/>
               <a:t>Fifth level</a:t>
             </a:r>
-            <a:endParaRPr lang="en-US"/>
           </a:p>
         </p:txBody>
       </p:sp>
@@ -3503,7 +2368,7 @@
           <a:p>
             <a:pPr lvl="0"/>
             <a:r>
-              <a:rPr lang="en-US" smtClean="0"/>
+              <a:rPr lang="en-US"/>
               <a:t>Click to edit Master text styles</a:t>
             </a:r>
           </a:p>
@@ -3526,7 +2391,7 @@
           <a:p>
             <a:fld id="{5BCAD085-E8A6-8845-BD4E-CB4CCA059FC4}" type="datetimeFigureOut">
               <a:rPr lang="en-US" smtClean="0"/>
-              <a:t>1/27/13</a:t>
+              <a:t>10/18/26</a:t>
             </a:fld>
             <a:endParaRPr lang="en-US"/>
           </a:p>
@@ -3629,10 +2494,9 @@
           </a:lstStyle>
           <a:p>
             <a:r>
-              <a:rPr lang="en-US" smtClean="0"/>
+              <a:rPr lang="en-US"/>
               <a:t>Click to edit Master title style</a:t>
             </a:r>
-            <a:endParaRPr lang="en-US"/>
           </a:p>
         </p:txBody>
       </p:sp>
@@ -3756,7 +2620,7 @@
           <a:p>
             <a:pPr lvl="0"/>
             <a:r>
-              <a:rPr lang="en-US" smtClean="0"/>
+              <a:rPr lang="en-US"/>
               <a:t>Click to edit Master text styles</a:t>
             </a:r>
           </a:p>
@@ -3779,7 +2643,7 @@
           <a:p>
             <a:fld id="{5BCAD085-E8A6-8845-BD4E-CB4CCA059FC4}" type="datetimeFigureOut">
               <a:rPr lang="en-US" smtClean="0"/>
-              <a:t>1/27/13</a:t>
+              <a:t>10/18/26</a:t>
             </a:fld>
             <a:endParaRPr lang="en-US"/>
           </a:p>
@@ -3888,10 +2752,9 @@
           <a:lstStyle/>
           <a:p>
             <a:r>
-              <a:rPr lang="en-US" smtClean="0"/>
+              <a:rPr lang="en-US"/>
               <a:t>Click to edit Master title style</a:t>
             </a:r>
-            <a:endParaRPr lang="en-US"/>
           </a:p>
         </p:txBody>
       </p:sp>
@@ -3922,38 +2785,37 @@
           <a:p>
             <a:pPr lvl="0"/>
             <a:r>
-              <a:rPr lang="en-US" smtClean="0"/>
+              <a:rPr lang="en-US"/>
               <a:t>Click to edit Master text styles</a:t>
             </a:r>
           </a:p>
           <a:p>
             <a:pPr lvl="1"/>
             <a:r>
-              <a:rPr lang="en-US" smtClean="0"/>
+              <a:rPr lang="en-US"/>
               <a:t>Second level</a:t>
             </a:r>
           </a:p>
           <a:p>
             <a:pPr lvl="2"/>
             <a:r>
-              <a:rPr lang="en-US" smtClean="0"/>
+              <a:rPr lang="en-US"/>
               <a:t>Third level</a:t>
             </a:r>
           </a:p>
           <a:p>
             <a:pPr lvl="3"/>
             <a:r>
-              <a:rPr lang="en-US" smtClean="0"/>
+              <a:rPr lang="en-US"/>
               <a:t>Fourth level</a:t>
             </a:r>
           </a:p>
           <a:p>
             <a:pPr lvl="4"/>
             <a:r>
-              <a:rPr lang="en-US" smtClean="0"/>
+              <a:rPr lang="en-US"/>
               <a:t>Fifth level</a:t>
             </a:r>
-            <a:endParaRPr lang="en-US"/>
           </a:p>
         </p:txBody>
       </p:sp>
@@ -3992,7 +2854,7 @@
           <a:p>
             <a:fld id="{5BCAD085-E8A6-8845-BD4E-CB4CCA059FC4}" type="datetimeFigureOut">
               <a:rPr lang="en-US" smtClean="0"/>
-              <a:t>1/27/13</a:t>
+              <a:t>10/18/26</a:t>
             </a:fld>
             <a:endParaRPr lang="en-US"/>
           </a:p>
@@ -4351,7 +3213,7 @@
 </file>
 
 <file path=ppt/slides/slide1.xml><?xml version="1.0" encoding="utf-8"?>
-<p:sld xmlns:a="http://schemas.openxmlformats.org/drawingml/2006/main" xmlns:p="http://schemas.openxmlformats.org/presentationml/2006/main" xmlns:r="http://schemas.openxmlformats.org/officeDocument/2006/relationships">
+<p:sld xmlns:a="http://schemas.openxmlformats.org/drawingml/2006/main" xmlns:r="http://schemas.openxmlformats.org/officeDocument/2006/relationships" xmlns:p="http://schemas.openxmlformats.org/presentationml/2006/main">
   <p:cSld>
     <p:spTree>
       <p:nvGrpSpPr>
@@ -4359,7 +3221,14 @@
         <p:cNvGrpSpPr/>
         <p:nvPr/>
       </p:nvGrpSpPr>
-      <p:grpSpPr/>
+      <p:grpSpPr>
+        <a:xfrm>
+          <a:off x="0" y="0"/>
+          <a:ext cx="0" cy="0"/>
+          <a:chOff x="0" y="0"/>
+          <a:chExt cx="0" cy="0"/>
+        </a:xfrm>
+      </p:grpSpPr>
       <p:sp>
         <p:nvSpPr>
           <p:cNvPr id="2" name="Title 1"/>
@@ -4397,12 +3266,14 @@
           <a:lstStyle/>
           <a:p>
             <a:r>
+              <a:rPr dirty="0"/>
               <a:t>Samar Khajuria, T00714740</a:t>
             </a:r>
           </a:p>
           <a:p>
             <a:r>
-              <a:t>COMP 4980, Category 3</a:t>
+              <a:rPr dirty="0"/>
+              <a:t>COMP 4980</a:t>
             </a:r>
           </a:p>
         </p:txBody>
@@ -4416,7 +3287,7 @@
 </file>
 
 <file path=ppt/slides/slide10.xml><?xml version="1.0" encoding="utf-8"?>
-<p:sld xmlns:a="http://schemas.openxmlformats.org/drawingml/2006/main" xmlns:p="http://schemas.openxmlformats.org/presentationml/2006/main" xmlns:r="http://schemas.openxmlformats.org/officeDocument/2006/relationships">
+<p:sld xmlns:a="http://schemas.openxmlformats.org/drawingml/2006/main" xmlns:r="http://schemas.openxmlformats.org/officeDocument/2006/relationships" xmlns:p="http://schemas.openxmlformats.org/presentationml/2006/main">
   <p:cSld>
     <p:spTree>
       <p:nvGrpSpPr>
@@ -4424,7 +3295,14 @@
         <p:cNvGrpSpPr/>
         <p:nvPr/>
       </p:nvGrpSpPr>
-      <p:grpSpPr/>
+      <p:grpSpPr>
+        <a:xfrm>
+          <a:off x="0" y="0"/>
+          <a:ext cx="0" cy="0"/>
+          <a:chOff x="0" y="0"/>
+          <a:chExt cx="0" cy="0"/>
+        </a:xfrm>
+      </p:grpSpPr>
       <p:sp>
         <p:nvSpPr>
           <p:cNvPr id="2" name="Title 1"/>
@@ -4441,7 +3319,7 @@
           <a:lstStyle/>
           <a:p>
             <a:r>
-              <a:t>Difficulty Sets The Speed</a:t>
+              <a:t>What It Does Not Do</a:t>
             </a:r>
           </a:p>
         </p:txBody>
@@ -4462,32 +3340,20 @@
           <a:lstStyle/>
           <a:p>
             <a:r>
-              <a:t>Level 1, 80 beats per minute, 24.0 seconds</a:t>
-            </a:r>
-          </a:p>
-          <a:p>
-            <a:r>
-              <a:t>Level 2, 110 beats per minute, 17.5 seconds</a:t>
-            </a:r>
-          </a:p>
-          <a:p>
-            <a:r>
-              <a:t>Level 3, 140 beats per minute, 13.7 seconds</a:t>
-            </a:r>
-          </a:p>
-          <a:p>
-            <a:r>
-              <a:t>Level 4, 170 beats per minute, 11.3 seconds</a:t>
-            </a:r>
-          </a:p>
-          <a:p>
-            <a:r>
-              <a:t>Level 5, 200 beats per minute, 9.6 seconds</a:t>
-            </a:r>
-          </a:p>
-          <a:p>
-            <a:r>
-              <a:t>Each level adds 30 beats per minute</a:t>
+              <a:rPr dirty="0"/>
+              <a:t>Two notes is not really a melody</a:t>
+            </a:r>
+          </a:p>
+          <a:p>
+            <a:r>
+              <a:rPr dirty="0"/>
+              <a:t>The rhythm never changes</a:t>
+            </a:r>
+          </a:p>
+          <a:p>
+            <a:r>
+              <a:rPr dirty="0"/>
+              <a:t>Difficulty only controls the speed</a:t>
             </a:r>
           </a:p>
         </p:txBody>
@@ -4501,7 +3367,7 @@
 </file>
 
 <file path=ppt/slides/slide11.xml><?xml version="1.0" encoding="utf-8"?>
-<p:sld xmlns:a="http://schemas.openxmlformats.org/drawingml/2006/main" xmlns:p="http://schemas.openxmlformats.org/presentationml/2006/main" xmlns:r="http://schemas.openxmlformats.org/officeDocument/2006/relationships">
+<p:sld xmlns:a="http://schemas.openxmlformats.org/drawingml/2006/main" xmlns:r="http://schemas.openxmlformats.org/officeDocument/2006/relationships" xmlns:p="http://schemas.openxmlformats.org/presentationml/2006/main">
   <p:cSld>
     <p:spTree>
       <p:nvGrpSpPr>
@@ -4509,7 +3375,14 @@
         <p:cNvGrpSpPr/>
         <p:nvPr/>
       </p:nvGrpSpPr>
-      <p:grpSpPr/>
+      <p:grpSpPr>
+        <a:xfrm>
+          <a:off x="0" y="0"/>
+          <a:ext cx="0" cy="0"/>
+          <a:chOff x="0" y="0"/>
+          <a:chExt cx="0" cy="0"/>
+        </a:xfrm>
+      </p:grpSpPr>
       <p:sp>
         <p:nvSpPr>
           <p:cNvPr id="2" name="Title 1"/>
@@ -4526,7 +3399,7 @@
           <a:lstStyle/>
           <a:p>
             <a:r>
-              <a:t>What It Does Not Do</a:t>
+              <a:t>Where I Would Take It Next</a:t>
             </a:r>
           </a:p>
         </p:txBody>
@@ -4547,22 +3420,20 @@
           <a:lstStyle/>
           <a:p>
             <a:r>
-              <a:t>Two notes is not really a melody</a:t>
-            </a:r>
-          </a:p>
-          <a:p>
-            <a:r>
-              <a:t>The rhythm never changes</a:t>
-            </a:r>
-          </a:p>
-          <a:p>
-            <a:r>
-              <a:t>Difficulty only controls the speed</a:t>
-            </a:r>
-          </a:p>
-          <a:p>
-            <a:r>
-              <a:t>Nobody has listened to it and rated it</a:t>
+              <a:rPr dirty="0"/>
+              <a:t>Use a few more notes, so it can suggest a key</a:t>
+            </a:r>
+          </a:p>
+          <a:p>
+            <a:r>
+              <a:rPr dirty="0"/>
+              <a:t>Let difficulty change the randomness too</a:t>
+            </a:r>
+          </a:p>
+          <a:p>
+            <a:r>
+              <a:rPr dirty="0"/>
+              <a:t>Vary the drum as well as the speed</a:t>
             </a:r>
           </a:p>
         </p:txBody>
@@ -4576,7 +3447,7 @@
 </file>
 
 <file path=ppt/slides/slide12.xml><?xml version="1.0" encoding="utf-8"?>
-<p:sld xmlns:a="http://schemas.openxmlformats.org/drawingml/2006/main" xmlns:p="http://schemas.openxmlformats.org/presentationml/2006/main" xmlns:r="http://schemas.openxmlformats.org/officeDocument/2006/relationships">
+<p:sld xmlns:a="http://schemas.openxmlformats.org/drawingml/2006/main" xmlns:r="http://schemas.openxmlformats.org/officeDocument/2006/relationships" xmlns:p="http://schemas.openxmlformats.org/presentationml/2006/main">
   <p:cSld>
     <p:spTree>
       <p:nvGrpSpPr>
@@ -4584,82 +3455,14 @@
         <p:cNvGrpSpPr/>
         <p:nvPr/>
       </p:nvGrpSpPr>
-      <p:grpSpPr/>
-      <p:sp>
-        <p:nvSpPr>
-          <p:cNvPr id="2" name="Title 1"/>
-          <p:cNvSpPr>
-            <a:spLocks noGrp="1"/>
-          </p:cNvSpPr>
-          <p:nvPr>
-            <p:ph type="title"/>
-          </p:nvPr>
-        </p:nvSpPr>
-        <p:spPr/>
-        <p:txBody>
-          <a:bodyPr/>
-          <a:lstStyle/>
-          <a:p>
-            <a:r>
-              <a:t>Where I Would Take It Next</a:t>
-            </a:r>
-          </a:p>
-        </p:txBody>
-      </p:sp>
-      <p:sp>
-        <p:nvSpPr>
-          <p:cNvPr id="3" name="Content Placeholder 2"/>
-          <p:cNvSpPr>
-            <a:spLocks noGrp="1"/>
-          </p:cNvSpPr>
-          <p:nvPr>
-            <p:ph idx="1"/>
-          </p:nvPr>
-        </p:nvSpPr>
-        <p:spPr/>
-        <p:txBody>
-          <a:bodyPr/>
-          <a:lstStyle/>
-          <a:p>
-            <a:r>
-              <a:t>Use a few more notes, so it can suggest a key</a:t>
-            </a:r>
-          </a:p>
-          <a:p>
-            <a:r>
-              <a:t>Let difficulty change the randomness too</a:t>
-            </a:r>
-          </a:p>
-          <a:p>
-            <a:r>
-              <a:t>Vary the drum as well as the speed</a:t>
-            </a:r>
-          </a:p>
-          <a:p>
-            <a:r>
-              <a:t>Drive it from live game state, like Left 4 Dead</a:t>
-            </a:r>
-          </a:p>
-        </p:txBody>
-      </p:sp>
-    </p:spTree>
-  </p:cSld>
-  <p:clrMapOvr>
-    <a:masterClrMapping/>
-  </p:clrMapOvr>
-</p:sld>
-</file>
-
-<file path=ppt/slides/slide13.xml><?xml version="1.0" encoding="utf-8"?>
-<p:sld xmlns:a="http://schemas.openxmlformats.org/drawingml/2006/main" xmlns:p="http://schemas.openxmlformats.org/presentationml/2006/main" xmlns:r="http://schemas.openxmlformats.org/officeDocument/2006/relationships">
-  <p:cSld>
-    <p:spTree>
-      <p:nvGrpSpPr>
-        <p:cNvPr id="1" name=""/>
-        <p:cNvGrpSpPr/>
-        <p:nvPr/>
-      </p:nvGrpSpPr>
-      <p:grpSpPr/>
+      <p:grpSpPr>
+        <a:xfrm>
+          <a:off x="0" y="0"/>
+          <a:ext cx="0" cy="0"/>
+          <a:chOff x="0" y="0"/>
+          <a:chExt cx="0" cy="0"/>
+        </a:xfrm>
+      </p:grpSpPr>
       <p:sp>
         <p:nvSpPr>
           <p:cNvPr id="2" name="Title 1"/>
@@ -4711,7 +3514,7 @@
 </file>
 
 <file path=ppt/slides/slide2.xml><?xml version="1.0" encoding="utf-8"?>
-<p:sld xmlns:a="http://schemas.openxmlformats.org/drawingml/2006/main" xmlns:p="http://schemas.openxmlformats.org/presentationml/2006/main" xmlns:r="http://schemas.openxmlformats.org/officeDocument/2006/relationships">
+<p:sld xmlns:a="http://schemas.openxmlformats.org/drawingml/2006/main" xmlns:r="http://schemas.openxmlformats.org/officeDocument/2006/relationships" xmlns:p="http://schemas.openxmlformats.org/presentationml/2006/main">
   <p:cSld>
     <p:spTree>
       <p:nvGrpSpPr>
@@ -4719,7 +3522,14 @@
         <p:cNvGrpSpPr/>
         <p:nvPr/>
       </p:nvGrpSpPr>
-      <p:grpSpPr/>
+      <p:grpSpPr>
+        <a:xfrm>
+          <a:off x="0" y="0"/>
+          <a:ext cx="0" cy="0"/>
+          <a:chOff x="0" y="0"/>
+          <a:chExt cx="0" cy="0"/>
+        </a:xfrm>
+      </p:grpSpPr>
       <p:sp>
         <p:nvSpPr>
           <p:cNvPr id="2" name="Title 1"/>
@@ -4757,26 +3567,31 @@
           <a:lstStyle/>
           <a:p>
             <a:r>
+              <a:rPr dirty="0"/>
               <a:t>Game music is normally a fixed audio file</a:t>
             </a:r>
           </a:p>
           <a:p>
             <a:r>
+              <a:rPr dirty="0"/>
               <a:t>It plays the same way on every replay</a:t>
             </a:r>
           </a:p>
           <a:p>
             <a:r>
+              <a:rPr dirty="0"/>
               <a:t>It does not know what the player is doing</a:t>
             </a:r>
           </a:p>
           <a:p>
             <a:r>
+              <a:rPr dirty="0"/>
               <a:t>PCG means the computer builds content instead</a:t>
             </a:r>
           </a:p>
           <a:p>
             <a:r>
+              <a:rPr dirty="0"/>
               <a:t>This project does that for the music</a:t>
             </a:r>
           </a:p>
@@ -4791,7 +3606,7 @@
 </file>
 
 <file path=ppt/slides/slide3.xml><?xml version="1.0" encoding="utf-8"?>
-<p:sld xmlns:a="http://schemas.openxmlformats.org/drawingml/2006/main" xmlns:p="http://schemas.openxmlformats.org/presentationml/2006/main" xmlns:r="http://schemas.openxmlformats.org/officeDocument/2006/relationships">
+<p:sld xmlns:a="http://schemas.openxmlformats.org/drawingml/2006/main" xmlns:r="http://schemas.openxmlformats.org/officeDocument/2006/relationships" xmlns:p="http://schemas.openxmlformats.org/presentationml/2006/main">
   <p:cSld>
     <p:spTree>
       <p:nvGrpSpPr>
@@ -4799,7 +3614,14 @@
         <p:cNvGrpSpPr/>
         <p:nvPr/>
       </p:nvGrpSpPr>
-      <p:grpSpPr/>
+      <p:grpSpPr>
+        <a:xfrm>
+          <a:off x="0" y="0"/>
+          <a:ext cx="0" cy="0"/>
+          <a:chOff x="0" y="0"/>
+          <a:chExt cx="0" cy="0"/>
+        </a:xfrm>
+      </p:grpSpPr>
       <p:sp>
         <p:nvSpPr>
           <p:cNvPr id="2" name="Title 1"/>
@@ -4837,27 +3659,14 @@
           <a:lstStyle/>
           <a:p>
             <a:r>
+              <a:rPr dirty="0"/>
               <a:t>A program that writes music for each level</a:t>
             </a:r>
           </a:p>
           <a:p>
             <a:r>
+              <a:rPr dirty="0"/>
               <a:t>A level number goes in, a music file comes out</a:t>
-            </a:r>
-          </a:p>
-          <a:p>
-            <a:r>
-              <a:t>One Java file, about 220 lines</a:t>
-            </a:r>
-          </a:p>
-          <a:p>
-            <a:r>
-              <a:t>No outside libraries</a:t>
-            </a:r>
-          </a:p>
-          <a:p>
-            <a:r>
-              <a:t>Five pieces of music in under a second</a:t>
             </a:r>
           </a:p>
         </p:txBody>
@@ -4871,7 +3680,7 @@
 </file>
 
 <file path=ppt/slides/slide4.xml><?xml version="1.0" encoding="utf-8"?>
-<p:sld xmlns:a="http://schemas.openxmlformats.org/drawingml/2006/main" xmlns:p="http://schemas.openxmlformats.org/presentationml/2006/main" xmlns:r="http://schemas.openxmlformats.org/officeDocument/2006/relationships">
+<p:sld xmlns:a="http://schemas.openxmlformats.org/drawingml/2006/main" xmlns:r="http://schemas.openxmlformats.org/officeDocument/2006/relationships" xmlns:p="http://schemas.openxmlformats.org/presentationml/2006/main">
   <p:cSld>
     <p:spTree>
       <p:nvGrpSpPr>
@@ -4879,7 +3688,14 @@
         <p:cNvGrpSpPr/>
         <p:nvPr/>
       </p:nvGrpSpPr>
-      <p:grpSpPr/>
+      <p:grpSpPr>
+        <a:xfrm>
+          <a:off x="0" y="0"/>
+          <a:ext cx="0" cy="0"/>
+          <a:chOff x="0" y="0"/>
+          <a:chExt cx="0" cy="0"/>
+        </a:xfrm>
+      </p:grpSpPr>
       <p:sp>
         <p:nvSpPr>
           <p:cNvPr id="2" name="Title 1"/>
@@ -4910,7 +3726,7 @@
           <p:nvPr/>
         </p:nvPicPr>
         <p:blipFill>
-          <a:blip r:embed="rId2"/>
+          <a:blip r:embed="rId3"/>
           <a:stretch>
             <a:fillRect/>
           </a:stretch>
@@ -4934,7 +3750,7 @@
 </file>
 
 <file path=ppt/slides/slide5.xml><?xml version="1.0" encoding="utf-8"?>
-<p:sld xmlns:a="http://schemas.openxmlformats.org/drawingml/2006/main" xmlns:p="http://schemas.openxmlformats.org/presentationml/2006/main" xmlns:r="http://schemas.openxmlformats.org/officeDocument/2006/relationships">
+<p:sld xmlns:a="http://schemas.openxmlformats.org/drawingml/2006/main" xmlns:r="http://schemas.openxmlformats.org/officeDocument/2006/relationships" xmlns:p="http://schemas.openxmlformats.org/presentationml/2006/main">
   <p:cSld>
     <p:spTree>
       <p:nvGrpSpPr>
@@ -4942,7 +3758,14 @@
         <p:cNvGrpSpPr/>
         <p:nvPr/>
       </p:nvGrpSpPr>
-      <p:grpSpPr/>
+      <p:grpSpPr>
+        <a:xfrm>
+          <a:off x="0" y="0"/>
+          <a:ext cx="0" cy="0"/>
+          <a:chOff x="0" y="0"/>
+          <a:chExt cx="0" cy="0"/>
+        </a:xfrm>
+      </p:grpSpPr>
       <p:sp>
         <p:nvSpPr>
           <p:cNvPr id="2" name="Title 1"/>
@@ -4980,26 +3803,31 @@
           <a:lstStyle/>
           <a:p>
             <a:r>
+              <a:rPr dirty="0"/>
               <a:t>A beat is the pulse you tap your foot to</a:t>
             </a:r>
           </a:p>
           <a:p>
             <a:r>
+              <a:rPr dirty="0"/>
               <a:t>Tempo is beats per minute, so higher is faster</a:t>
             </a:r>
           </a:p>
           <a:p>
             <a:r>
+              <a:rPr dirty="0"/>
               <a:t>A MIDI file is not a recording</a:t>
             </a:r>
           </a:p>
           <a:p>
             <a:r>
+              <a:rPr dirty="0"/>
               <a:t>It is a list of which note to play and when</a:t>
             </a:r>
           </a:p>
           <a:p>
             <a:r>
+              <a:rPr dirty="0"/>
               <a:t>That is why one level is only 600 bytes</a:t>
             </a:r>
           </a:p>
@@ -5014,7 +3842,7 @@
 </file>
 
 <file path=ppt/slides/slide6.xml><?xml version="1.0" encoding="utf-8"?>
-<p:sld xmlns:a="http://schemas.openxmlformats.org/drawingml/2006/main" xmlns:p="http://schemas.openxmlformats.org/presentationml/2006/main" xmlns:r="http://schemas.openxmlformats.org/officeDocument/2006/relationships">
+<p:sld xmlns:a="http://schemas.openxmlformats.org/drawingml/2006/main" xmlns:r="http://schemas.openxmlformats.org/officeDocument/2006/relationships" xmlns:p="http://schemas.openxmlformats.org/presentationml/2006/main">
   <p:cSld>
     <p:spTree>
       <p:nvGrpSpPr>
@@ -5022,7 +3850,14 @@
         <p:cNvGrpSpPr/>
         <p:nvPr/>
       </p:nvGrpSpPr>
-      <p:grpSpPr/>
+      <p:grpSpPr>
+        <a:xfrm>
+          <a:off x="0" y="0"/>
+          <a:ext cx="0" cy="0"/>
+          <a:chOff x="0" y="0"/>
+          <a:chExt cx="0" cy="0"/>
+        </a:xfrm>
+      </p:grpSpPr>
       <p:sp>
         <p:nvSpPr>
           <p:cNvPr id="2" name="Title 1"/>
@@ -5099,7 +3934,7 @@
 </file>
 
 <file path=ppt/slides/slide7.xml><?xml version="1.0" encoding="utf-8"?>
-<p:sld xmlns:a="http://schemas.openxmlformats.org/drawingml/2006/main" xmlns:p="http://schemas.openxmlformats.org/presentationml/2006/main" xmlns:r="http://schemas.openxmlformats.org/officeDocument/2006/relationships">
+<p:sld xmlns:a="http://schemas.openxmlformats.org/drawingml/2006/main" xmlns:r="http://schemas.openxmlformats.org/officeDocument/2006/relationships" xmlns:p="http://schemas.openxmlformats.org/presentationml/2006/main">
   <p:cSld>
     <p:spTree>
       <p:nvGrpSpPr>
@@ -5107,7 +3942,14 @@
         <p:cNvGrpSpPr/>
         <p:nvPr/>
       </p:nvGrpSpPr>
-      <p:grpSpPr/>
+      <p:grpSpPr>
+        <a:xfrm>
+          <a:off x="0" y="0"/>
+          <a:ext cx="0" cy="0"/>
+          <a:chOff x="0" y="0"/>
+          <a:chExt cx="0" cy="0"/>
+        </a:xfrm>
+      </p:grpSpPr>
       <p:sp>
         <p:nvSpPr>
           <p:cNvPr id="2" name="Title 1"/>
@@ -5124,7 +3966,7 @@
           <a:lstStyle/>
           <a:p>
             <a:r>
-              <a:t>One Number Holds The Song</a:t>
+              <a:t>Where This Sits In PCG</a:t>
             </a:r>
           </a:p>
         </p:txBody>
@@ -5145,27 +3987,26 @@
           <a:lstStyle/>
           <a:p>
             <a:r>
-              <a:t>The level number starts the random numbers</a:t>
-            </a:r>
-          </a:p>
-          <a:p>
-            <a:r>
-              <a:t>Level 3 always gives exactly the same music</a:t>
-            </a:r>
-          </a:p>
-          <a:p>
-            <a:r>
-              <a:t>Level 4 gives different music</a:t>
-            </a:r>
-          </a:p>
-          <a:p>
-            <a:r>
-              <a:t>The game stores a number, not an audio file</a:t>
-            </a:r>
-          </a:p>
-          <a:p>
-            <a:r>
-              <a:t>The music is rebuilt from it every time</a:t>
+              <a:rPr dirty="0"/>
+              <a:t>Stochastic, because it uses randomness</a:t>
+            </a:r>
+          </a:p>
+          <a:p>
+            <a:r>
+              <a:rPr dirty="0"/>
+              <a:t>Constructive, it builds in one pass</a:t>
+            </a:r>
+          </a:p>
+          <a:p>
+            <a:r>
+              <a:rPr dirty="0"/>
+              <a:t>Automatic, no human picks the notes</a:t>
+            </a:r>
+          </a:p>
+          <a:p>
+            <a:r>
+              <a:rPr dirty="0"/>
+              <a:t>Adaptive, the output follows the game</a:t>
             </a:r>
           </a:p>
         </p:txBody>
@@ -5179,7 +4020,7 @@
 </file>
 
 <file path=ppt/slides/slide8.xml><?xml version="1.0" encoding="utf-8"?>
-<p:sld xmlns:a="http://schemas.openxmlformats.org/drawingml/2006/main" xmlns:p="http://schemas.openxmlformats.org/presentationml/2006/main" xmlns:r="http://schemas.openxmlformats.org/officeDocument/2006/relationships">
+<p:sld xmlns:a="http://schemas.openxmlformats.org/drawingml/2006/main" xmlns:r="http://schemas.openxmlformats.org/officeDocument/2006/relationships" xmlns:p="http://schemas.openxmlformats.org/presentationml/2006/main">
   <p:cSld>
     <p:spTree>
       <p:nvGrpSpPr>
@@ -5187,87 +4028,14 @@
         <p:cNvGrpSpPr/>
         <p:nvPr/>
       </p:nvGrpSpPr>
-      <p:grpSpPr/>
-      <p:sp>
-        <p:nvSpPr>
-          <p:cNvPr id="2" name="Title 1"/>
-          <p:cNvSpPr>
-            <a:spLocks noGrp="1"/>
-          </p:cNvSpPr>
-          <p:nvPr>
-            <p:ph type="title"/>
-          </p:nvPr>
-        </p:nvSpPr>
-        <p:spPr/>
-        <p:txBody>
-          <a:bodyPr/>
-          <a:lstStyle/>
-          <a:p>
-            <a:r>
-              <a:t>Where This Sits In PCG</a:t>
-            </a:r>
-          </a:p>
-        </p:txBody>
-      </p:sp>
-      <p:sp>
-        <p:nvSpPr>
-          <p:cNvPr id="3" name="Content Placeholder 2"/>
-          <p:cNvSpPr>
-            <a:spLocks noGrp="1"/>
-          </p:cNvSpPr>
-          <p:nvPr>
-            <p:ph idx="1"/>
-          </p:nvPr>
-        </p:nvSpPr>
-        <p:spPr/>
-        <p:txBody>
-          <a:bodyPr/>
-          <a:lstStyle/>
-          <a:p>
-            <a:r>
-              <a:t>Stochastic, because it uses randomness</a:t>
-            </a:r>
-          </a:p>
-          <a:p>
-            <a:r>
-              <a:t>Constructive, it builds in one pass</a:t>
-            </a:r>
-          </a:p>
-          <a:p>
-            <a:r>
-              <a:t>Automatic, no human picks the notes</a:t>
-            </a:r>
-          </a:p>
-          <a:p>
-            <a:r>
-              <a:t>Adaptive, the output follows the game</a:t>
-            </a:r>
-          </a:p>
-          <a:p>
-            <a:r>
-              <a:t>Adaptive is the important one</a:t>
-            </a:r>
-          </a:p>
-        </p:txBody>
-      </p:sp>
-    </p:spTree>
-  </p:cSld>
-  <p:clrMapOvr>
-    <a:masterClrMapping/>
-  </p:clrMapOvr>
-</p:sld>
-</file>
-
-<file path=ppt/slides/slide9.xml><?xml version="1.0" encoding="utf-8"?>
-<p:sld xmlns:a="http://schemas.openxmlformats.org/drawingml/2006/main" xmlns:p="http://schemas.openxmlformats.org/presentationml/2006/main" xmlns:r="http://schemas.openxmlformats.org/officeDocument/2006/relationships">
-  <p:cSld>
-    <p:spTree>
-      <p:nvGrpSpPr>
-        <p:cNvPr id="1" name=""/>
-        <p:cNvGrpSpPr/>
-        <p:nvPr/>
-      </p:nvGrpSpPr>
-      <p:grpSpPr/>
+      <p:grpSpPr>
+        <a:xfrm>
+          <a:off x="0" y="0"/>
+          <a:ext cx="0" cy="0"/>
+          <a:chOff x="0" y="0"/>
+          <a:chExt cx="0" cy="0"/>
+        </a:xfrm>
+      </p:grpSpPr>
       <p:sp>
         <p:nvSpPr>
           <p:cNvPr id="2" name="Title 1"/>
@@ -5298,7 +4066,7 @@
           <p:nvPr/>
         </p:nvPicPr>
         <p:blipFill>
-          <a:blip r:embed="rId2"/>
+          <a:blip r:embed="rId3"/>
           <a:stretch>
             <a:fillRect/>
           </a:stretch>
@@ -5313,6 +4081,98 @@
           </a:prstGeom>
         </p:spPr>
       </p:pic>
+    </p:spTree>
+  </p:cSld>
+  <p:clrMapOvr>
+    <a:masterClrMapping/>
+  </p:clrMapOvr>
+</p:sld>
+</file>
+
+<file path=ppt/slides/slide9.xml><?xml version="1.0" encoding="utf-8"?>
+<p:sld xmlns:a="http://schemas.openxmlformats.org/drawingml/2006/main" xmlns:r="http://schemas.openxmlformats.org/officeDocument/2006/relationships" xmlns:p="http://schemas.openxmlformats.org/presentationml/2006/main">
+  <p:cSld>
+    <p:spTree>
+      <p:nvGrpSpPr>
+        <p:cNvPr id="1" name=""/>
+        <p:cNvGrpSpPr/>
+        <p:nvPr/>
+      </p:nvGrpSpPr>
+      <p:grpSpPr>
+        <a:xfrm>
+          <a:off x="0" y="0"/>
+          <a:ext cx="0" cy="0"/>
+          <a:chOff x="0" y="0"/>
+          <a:chExt cx="0" cy="0"/>
+        </a:xfrm>
+      </p:grpSpPr>
+      <p:sp>
+        <p:nvSpPr>
+          <p:cNvPr id="2" name="Title 1"/>
+          <p:cNvSpPr>
+            <a:spLocks noGrp="1"/>
+          </p:cNvSpPr>
+          <p:nvPr>
+            <p:ph type="title"/>
+          </p:nvPr>
+        </p:nvSpPr>
+        <p:spPr/>
+        <p:txBody>
+          <a:bodyPr/>
+          <a:lstStyle/>
+          <a:p>
+            <a:r>
+              <a:t>Difficulty Sets The Speed</a:t>
+            </a:r>
+          </a:p>
+        </p:txBody>
+      </p:sp>
+      <p:sp>
+        <p:nvSpPr>
+          <p:cNvPr id="3" name="Content Placeholder 2"/>
+          <p:cNvSpPr>
+            <a:spLocks noGrp="1"/>
+          </p:cNvSpPr>
+          <p:nvPr>
+            <p:ph idx="1"/>
+          </p:nvPr>
+        </p:nvSpPr>
+        <p:spPr/>
+        <p:txBody>
+          <a:bodyPr/>
+          <a:lstStyle/>
+          <a:p>
+            <a:r>
+              <a:t>Level 1, 80 beats per minute, 24.0 seconds</a:t>
+            </a:r>
+          </a:p>
+          <a:p>
+            <a:r>
+              <a:t>Level 2, 110 beats per minute, 17.5 seconds</a:t>
+            </a:r>
+          </a:p>
+          <a:p>
+            <a:r>
+              <a:t>Level 3, 140 beats per minute, 13.7 seconds</a:t>
+            </a:r>
+          </a:p>
+          <a:p>
+            <a:r>
+              <a:t>Level 4, 170 beats per minute, 11.3 seconds</a:t>
+            </a:r>
+          </a:p>
+          <a:p>
+            <a:r>
+              <a:t>Level 5, 200 beats per minute, 9.6 seconds</a:t>
+            </a:r>
+          </a:p>
+          <a:p>
+            <a:r>
+              <a:t>Each level adds 30 beats per minute</a:t>
+            </a:r>
+          </a:p>
+        </p:txBody>
+      </p:sp>
     </p:spTree>
   </p:cSld>
   <p:clrMapOvr>
@@ -5652,44 +4512,44 @@
         <a:sysClr val="window" lastClr="FFFFFF"/>
       </a:lt1>
       <a:dk2>
-        <a:srgbClr val="1F497D"/>
+        <a:srgbClr val="0E2841"/>
       </a:dk2>
       <a:lt2>
-        <a:srgbClr val="EEECE1"/>
+        <a:srgbClr val="E8E8E8"/>
       </a:lt2>
       <a:accent1>
-        <a:srgbClr val="4F81BD"/>
+        <a:srgbClr val="156082"/>
       </a:accent1>
       <a:accent2>
-        <a:srgbClr val="C0504D"/>
+        <a:srgbClr val="E97132"/>
       </a:accent2>
       <a:accent3>
-        <a:srgbClr val="9BBB59"/>
+        <a:srgbClr val="196B24"/>
       </a:accent3>
       <a:accent4>
-        <a:srgbClr val="8064A2"/>
+        <a:srgbClr val="0F9ED5"/>
       </a:accent4>
       <a:accent5>
-        <a:srgbClr val="4BACC6"/>
+        <a:srgbClr val="A02B93"/>
       </a:accent5>
       <a:accent6>
-        <a:srgbClr val="F79646"/>
+        <a:srgbClr val="4EA72E"/>
       </a:accent6>
       <a:hlink>
-        <a:srgbClr val="0000FF"/>
+        <a:srgbClr val="467886"/>
       </a:hlink>
       <a:folHlink>
-        <a:srgbClr val="800080"/>
+        <a:srgbClr val="96607D"/>
       </a:folHlink>
     </a:clrScheme>
     <a:fontScheme name="Office">
       <a:majorFont>
-        <a:latin typeface="Calibri"/>
+        <a:latin typeface="Aptos Display" panose="02110004020202020204"/>
         <a:ea typeface=""/>
         <a:cs typeface=""/>
-        <a:font script="Jpan" typeface="ＭＳ Ｐゴシック"/>
+        <a:font script="Jpan" typeface="游ゴシック Light"/>
         <a:font script="Hang" typeface="맑은 고딕"/>
-        <a:font script="Hans" typeface="宋体"/>
+        <a:font script="Hans" typeface="等线 Light"/>
         <a:font script="Hant" typeface="新細明體"/>
         <a:font script="Arab" typeface="Times New Roman"/>
         <a:font script="Hebr" typeface="Times New Roman"/>
@@ -5717,14 +4577,31 @@
         <a:font script="Viet" typeface="Times New Roman"/>
         <a:font script="Uigh" typeface="Microsoft Uighur"/>
         <a:font script="Geor" typeface="Sylfaen"/>
+        <a:font script="Armn" typeface="Arial"/>
+        <a:font script="Bugi" typeface="Leelawadee UI"/>
+        <a:font script="Bopo" typeface="Microsoft JhengHei"/>
+        <a:font script="Java" typeface="Javanese Text"/>
+        <a:font script="Lisu" typeface="Segoe UI"/>
+        <a:font script="Mymr" typeface="Myanmar Text"/>
+        <a:font script="Nkoo" typeface="Ebrima"/>
+        <a:font script="Olck" typeface="Nirmala UI"/>
+        <a:font script="Osma" typeface="Ebrima"/>
+        <a:font script="Phag" typeface="Phagspa"/>
+        <a:font script="Syrn" typeface="Estrangelo Edessa"/>
+        <a:font script="Syrj" typeface="Estrangelo Edessa"/>
+        <a:font script="Syre" typeface="Estrangelo Edessa"/>
+        <a:font script="Sora" typeface="Nirmala UI"/>
+        <a:font script="Tale" typeface="Microsoft Tai Le"/>
+        <a:font script="Talu" typeface="Microsoft New Tai Lue"/>
+        <a:font script="Tfng" typeface="Ebrima"/>
       </a:majorFont>
       <a:minorFont>
-        <a:latin typeface="Calibri"/>
+        <a:latin typeface="Aptos" panose="02110004020202020204"/>
         <a:ea typeface=""/>
         <a:cs typeface=""/>
-        <a:font script="Jpan" typeface="ＭＳ Ｐゴシック"/>
+        <a:font script="Jpan" typeface="游ゴシック"/>
         <a:font script="Hang" typeface="맑은 고딕"/>
-        <a:font script="Hans" typeface="宋体"/>
+        <a:font script="Hans" typeface="等线"/>
         <a:font script="Hant" typeface="新細明體"/>
         <a:font script="Arab" typeface="Arial"/>
         <a:font script="Hebr" typeface="Arial"/>
@@ -5752,6 +4629,23 @@
         <a:font script="Viet" typeface="Arial"/>
         <a:font script="Uigh" typeface="Microsoft Uighur"/>
         <a:font script="Geor" typeface="Sylfaen"/>
+        <a:font script="Armn" typeface="Arial"/>
+        <a:font script="Bugi" typeface="Leelawadee UI"/>
+        <a:font script="Bopo" typeface="Microsoft JhengHei"/>
+        <a:font script="Java" typeface="Javanese Text"/>
+        <a:font script="Lisu" typeface="Segoe UI"/>
+        <a:font script="Mymr" typeface="Myanmar Text"/>
+        <a:font script="Nkoo" typeface="Ebrima"/>
+        <a:font script="Olck" typeface="Nirmala UI"/>
+        <a:font script="Osma" typeface="Ebrima"/>
+        <a:font script="Phag" typeface="Phagspa"/>
+        <a:font script="Syrn" typeface="Estrangelo Edessa"/>
+        <a:font script="Syrj" typeface="Estrangelo Edessa"/>
+        <a:font script="Syre" typeface="Estrangelo Edessa"/>
+        <a:font script="Sora" typeface="Nirmala UI"/>
+        <a:font script="Tale" typeface="Microsoft Tai Le"/>
+        <a:font script="Talu" typeface="Microsoft New Tai Lue"/>
+        <a:font script="Tfng" typeface="Ebrima"/>
       </a:minorFont>
     </a:fontScheme>
     <a:fmtScheme name="Office">
@@ -5763,180 +4657,136 @@
           <a:gsLst>
             <a:gs pos="0">
               <a:schemeClr val="phClr">
-                <a:tint val="50000"/>
-                <a:satMod val="300000"/>
+                <a:lumMod val="110000"/>
+                <a:satMod val="105000"/>
+                <a:tint val="67000"/>
               </a:schemeClr>
             </a:gs>
-            <a:gs pos="35000">
+            <a:gs pos="50000">
               <a:schemeClr val="phClr">
-                <a:tint val="37000"/>
-                <a:satMod val="300000"/>
+                <a:lumMod val="105000"/>
+                <a:satMod val="103000"/>
+                <a:tint val="73000"/>
               </a:schemeClr>
             </a:gs>
             <a:gs pos="100000">
               <a:schemeClr val="phClr">
-                <a:tint val="15000"/>
-                <a:satMod val="350000"/>
+                <a:lumMod val="105000"/>
+                <a:satMod val="109000"/>
+                <a:tint val="81000"/>
               </a:schemeClr>
             </a:gs>
           </a:gsLst>
-          <a:lin ang="16200000" scaled="1"/>
+          <a:lin ang="5400000" scaled="0"/>
         </a:gradFill>
         <a:gradFill rotWithShape="1">
           <a:gsLst>
             <a:gs pos="0">
               <a:schemeClr val="phClr">
-                <a:tint val="100000"/>
+                <a:satMod val="103000"/>
+                <a:lumMod val="102000"/>
+                <a:tint val="94000"/>
+              </a:schemeClr>
+            </a:gs>
+            <a:gs pos="50000">
+              <a:schemeClr val="phClr">
+                <a:satMod val="110000"/>
+                <a:lumMod val="100000"/>
                 <a:shade val="100000"/>
-                <a:satMod val="130000"/>
               </a:schemeClr>
             </a:gs>
             <a:gs pos="100000">
               <a:schemeClr val="phClr">
-                <a:tint val="50000"/>
-                <a:shade val="100000"/>
-                <a:satMod val="350000"/>
+                <a:lumMod val="99000"/>
+                <a:satMod val="120000"/>
+                <a:shade val="78000"/>
               </a:schemeClr>
             </a:gs>
           </a:gsLst>
-          <a:lin ang="16200000" scaled="0"/>
+          <a:lin ang="5400000" scaled="0"/>
         </a:gradFill>
       </a:fillStyleLst>
       <a:lnStyleLst>
-        <a:ln w="9525" cap="flat" cmpd="sng" algn="ctr">
+        <a:ln w="12700" cap="flat" cmpd="sng" algn="ctr">
           <a:solidFill>
-            <a:schemeClr val="phClr">
-              <a:shade val="95000"/>
-              <a:satMod val="105000"/>
-            </a:schemeClr>
+            <a:schemeClr val="phClr"/>
           </a:solidFill>
           <a:prstDash val="solid"/>
+          <a:miter lim="800000"/>
+        </a:ln>
+        <a:ln w="19050" cap="flat" cmpd="sng" algn="ctr">
+          <a:solidFill>
+            <a:schemeClr val="phClr"/>
+          </a:solidFill>
+          <a:prstDash val="solid"/>
+          <a:miter lim="800000"/>
         </a:ln>
         <a:ln w="25400" cap="flat" cmpd="sng" algn="ctr">
           <a:solidFill>
             <a:schemeClr val="phClr"/>
           </a:solidFill>
           <a:prstDash val="solid"/>
-        </a:ln>
-        <a:ln w="38100" cap="flat" cmpd="sng" algn="ctr">
-          <a:solidFill>
-            <a:schemeClr val="phClr"/>
-          </a:solidFill>
-          <a:prstDash val="solid"/>
+          <a:miter lim="800000"/>
         </a:ln>
       </a:lnStyleLst>
       <a:effectStyleLst>
         <a:effectStyle>
+          <a:effectLst/>
+        </a:effectStyle>
+        <a:effectStyle>
+          <a:effectLst/>
+        </a:effectStyle>
+        <a:effectStyle>
           <a:effectLst>
-            <a:outerShdw blurRad="40000" dist="20000" dir="5400000" rotWithShape="0">
+            <a:outerShdw blurRad="57150" dist="19050" dir="5400000" algn="ctr" rotWithShape="0">
               <a:srgbClr val="000000">
-                <a:alpha val="38000"/>
+                <a:alpha val="63000"/>
               </a:srgbClr>
             </a:outerShdw>
           </a:effectLst>
-        </a:effectStyle>
-        <a:effectStyle>
-          <a:effectLst>
-            <a:outerShdw blurRad="40000" dist="23000" dir="5400000" rotWithShape="0">
-              <a:srgbClr val="000000">
-                <a:alpha val="35000"/>
-              </a:srgbClr>
-            </a:outerShdw>
-          </a:effectLst>
-        </a:effectStyle>
-        <a:effectStyle>
-          <a:effectLst>
-            <a:outerShdw blurRad="40000" dist="23000" dir="5400000" rotWithShape="0">
-              <a:srgbClr val="000000">
-                <a:alpha val="35000"/>
-              </a:srgbClr>
-            </a:outerShdw>
-          </a:effectLst>
-          <a:scene3d>
-            <a:camera prst="orthographicFront">
-              <a:rot lat="0" lon="0" rev="0"/>
-            </a:camera>
-            <a:lightRig rig="threePt" dir="t">
-              <a:rot lat="0" lon="0" rev="1200000"/>
-            </a:lightRig>
-          </a:scene3d>
-          <a:sp3d>
-            <a:bevelT w="63500" h="25400"/>
-          </a:sp3d>
         </a:effectStyle>
       </a:effectStyleLst>
       <a:bgFillStyleLst>
         <a:solidFill>
           <a:schemeClr val="phClr"/>
         </a:solidFill>
+        <a:solidFill>
+          <a:schemeClr val="phClr">
+            <a:tint val="95000"/>
+            <a:satMod val="170000"/>
+          </a:schemeClr>
+        </a:solidFill>
         <a:gradFill rotWithShape="1">
           <a:gsLst>
             <a:gs pos="0">
               <a:schemeClr val="phClr">
-                <a:tint val="40000"/>
-                <a:satMod val="350000"/>
+                <a:tint val="93000"/>
+                <a:satMod val="150000"/>
+                <a:shade val="98000"/>
+                <a:lumMod val="102000"/>
               </a:schemeClr>
             </a:gs>
-            <a:gs pos="40000">
+            <a:gs pos="50000">
               <a:schemeClr val="phClr">
-                <a:tint val="45000"/>
-                <a:shade val="99000"/>
-                <a:satMod val="350000"/>
+                <a:tint val="98000"/>
+                <a:satMod val="130000"/>
+                <a:shade val="90000"/>
+                <a:lumMod val="103000"/>
               </a:schemeClr>
             </a:gs>
             <a:gs pos="100000">
               <a:schemeClr val="phClr">
-                <a:shade val="20000"/>
-                <a:satMod val="255000"/>
+                <a:shade val="63000"/>
+                <a:satMod val="120000"/>
               </a:schemeClr>
             </a:gs>
           </a:gsLst>
-          <a:path path="circle">
-            <a:fillToRect l="50000" t="-80000" r="50000" b="180000"/>
-          </a:path>
-        </a:gradFill>
-        <a:gradFill rotWithShape="1">
-          <a:gsLst>
-            <a:gs pos="0">
-              <a:schemeClr val="phClr">
-                <a:tint val="80000"/>
-                <a:satMod val="300000"/>
-              </a:schemeClr>
-            </a:gs>
-            <a:gs pos="100000">
-              <a:schemeClr val="phClr">
-                <a:shade val="30000"/>
-                <a:satMod val="200000"/>
-              </a:schemeClr>
-            </a:gs>
-          </a:gsLst>
-          <a:path path="circle">
-            <a:fillToRect l="50000" t="50000" r="50000" b="50000"/>
-          </a:path>
+          <a:lin ang="5400000" scaled="0"/>
         </a:gradFill>
       </a:bgFillStyleLst>
     </a:fmtScheme>
   </a:themeElements>
   <a:objectDefaults>
-    <a:spDef>
-      <a:spPr/>
-      <a:bodyPr/>
-      <a:lstStyle/>
-      <a:style>
-        <a:lnRef idx="1">
-          <a:schemeClr val="accent1"/>
-        </a:lnRef>
-        <a:fillRef idx="3">
-          <a:schemeClr val="accent1"/>
-        </a:fillRef>
-        <a:effectRef idx="2">
-          <a:schemeClr val="accent1"/>
-        </a:effectRef>
-        <a:fontRef idx="minor">
-          <a:schemeClr val="lt1"/>
-        </a:fontRef>
-      </a:style>
-    </a:spDef>
     <a:lnDef>
       <a:spPr/>
       <a:bodyPr/>
@@ -5958,5 +4808,10 @@
     </a:lnDef>
   </a:objectDefaults>
   <a:extraClrSchemeLst/>
+  <a:extLst>
+    <a:ext uri="{05A4C25C-085E-4340-85A3-A5531E510DB2}">
+      <thm15:themeFamily xmlns:thm15="http://schemas.microsoft.com/office/thememl/2012/main" name="Office Theme" id="{2E142A2C-CD16-42D6-873A-C26D2A0506FA}" vid="{1BDDFF52-6CD6-40A5-AB3C-68EB2F1E4D0A}"/>
+    </a:ext>
+  </a:extLst>
 </a:theme>
 </file>
</xml_diff>

<commit_message>
Add playable audio for level 1 and level 5
The MIDI files cannot play inside PowerPoint, so the two levels are
rendered to WAV and embedded on the results slide behind play buttons.
WAV rather than a compressed format so no codec is needed on whatever
machine it is presented from.

The audio is rendered from the MIDI files themselves, so the notes and
timing are exactly what the generator produced.
</commit_message>
<xml_diff>
--- a/Presentation.pptx
+++ b/Presentation.pptx
@@ -4137,7 +4137,12 @@
             <p:ph idx="1"/>
           </p:nvPr>
         </p:nvSpPr>
-        <p:spPr/>
+        <p:spPr>
+          <a:xfrm>
+            <a:off x="457200" y="1600200"/>
+            <a:ext cx="8229600" cy="3200400"/>
+          </a:xfrm>
+        </p:spPr>
         <p:txBody>
           <a:bodyPr/>
           <a:lstStyle/>
@@ -4169,6 +4174,130 @@
           <a:p>
             <a:r>
               <a:t>Each level adds 30 beats per minute</a:t>
+            </a:r>
+          </a:p>
+        </p:txBody>
+      </p:sp>
+      <p:pic>
+        <p:nvPicPr>
+          <p:cNvPr id="4" name="level1.wav">
+            <a:hlinkClick r:id="" action="ppaction://media"/>
+          </p:cNvPr>
+          <p:cNvPicPr>
+            <a:picLocks noChangeAspect="1"/>
+          </p:cNvPicPr>
+          <p:nvPr>
+            <a:audioFile r:link="rId3"/>
+            <p:extLst>
+              <p:ext uri="{DAA4B4D4-6D71-4841-9C94-3DE7FCFB9230}">
+                <p14:media xmlns:p14="http://schemas.microsoft.com/office/powerpoint/2010/main" r:embed="rId2"/>
+              </p:ext>
+            </p:extLst>
+          </p:nvPr>
+        </p:nvPicPr>
+        <p:blipFill>
+          <a:blip r:embed="rId4"/>
+          <a:stretch>
+            <a:fillRect/>
+          </a:stretch>
+        </p:blipFill>
+        <p:spPr>
+          <a:xfrm>
+            <a:off x="1371600" y="5029200"/>
+            <a:ext cx="914400" cy="914400"/>
+          </a:xfrm>
+          <a:prstGeom prst="rect">
+            <a:avLst/>
+          </a:prstGeom>
+        </p:spPr>
+      </p:pic>
+      <p:sp>
+        <p:nvSpPr>
+          <p:cNvPr id="5" name="TextBox 4"/>
+          <p:cNvSpPr txBox="1"/>
+          <p:nvPr/>
+        </p:nvSpPr>
+        <p:spPr>
+          <a:xfrm>
+            <a:off x="2423160" y="5303520"/>
+            <a:ext cx="1463040" cy="365760"/>
+          </a:xfrm>
+          <a:prstGeom prst="rect">
+            <a:avLst/>
+          </a:prstGeom>
+          <a:noFill/>
+        </p:spPr>
+        <p:txBody>
+          <a:bodyPr wrap="none">
+            <a:spAutoFit/>
+          </a:bodyPr>
+          <a:lstStyle/>
+          <a:p>
+            <a:r>
+              <a:rPr sz="1800"/>
+              <a:t>Level 1</a:t>
+            </a:r>
+          </a:p>
+        </p:txBody>
+      </p:sp>
+      <p:pic>
+        <p:nvPicPr>
+          <p:cNvPr id="6" name="level5.wav">
+            <a:hlinkClick r:id="" action="ppaction://media"/>
+          </p:cNvPr>
+          <p:cNvPicPr>
+            <a:picLocks noChangeAspect="1"/>
+          </p:cNvPicPr>
+          <p:nvPr>
+            <a:audioFile r:link="rId6"/>
+            <p:extLst>
+              <p:ext uri="{DAA4B4D4-6D71-4841-9C94-3DE7FCFB9230}">
+                <p14:media xmlns:p14="http://schemas.microsoft.com/office/powerpoint/2010/main" r:embed="rId5"/>
+              </p:ext>
+            </p:extLst>
+          </p:nvPr>
+        </p:nvPicPr>
+        <p:blipFill>
+          <a:blip r:embed="rId4"/>
+          <a:stretch>
+            <a:fillRect/>
+          </a:stretch>
+        </p:blipFill>
+        <p:spPr>
+          <a:xfrm>
+            <a:off x="5029200" y="5029200"/>
+            <a:ext cx="914400" cy="914400"/>
+          </a:xfrm>
+          <a:prstGeom prst="rect">
+            <a:avLst/>
+          </a:prstGeom>
+        </p:spPr>
+      </p:pic>
+      <p:sp>
+        <p:nvSpPr>
+          <p:cNvPr id="7" name="TextBox 6"/>
+          <p:cNvSpPr txBox="1"/>
+          <p:nvPr/>
+        </p:nvSpPr>
+        <p:spPr>
+          <a:xfrm>
+            <a:off x="6080760" y="5303520"/>
+            <a:ext cx="1463040" cy="365760"/>
+          </a:xfrm>
+          <a:prstGeom prst="rect">
+            <a:avLst/>
+          </a:prstGeom>
+          <a:noFill/>
+        </p:spPr>
+        <p:txBody>
+          <a:bodyPr wrap="none">
+            <a:spAutoFit/>
+          </a:bodyPr>
+          <a:lstStyle/>
+          <a:p>
+            <a:r>
+              <a:rPr sz="1800"/>
+              <a:t>Level 5</a:t>
             </a:r>
           </a:p>
         </p:txBody>
@@ -4178,6 +4307,40 @@
   <p:clrMapOvr>
     <a:masterClrMapping/>
   </p:clrMapOvr>
+  <p:timing>
+    <p:tnLst>
+      <p:par>
+        <p:cTn id="1" dur="indefinite" restart="never" nodeType="tmRoot">
+          <p:childTnLst>
+            <p:video>
+              <p:cMediaNode vol="80000">
+                <p:cTn id="2" fill="hold" display="0">
+                  <p:stCondLst>
+                    <p:cond delay="indefinite"/>
+                  </p:stCondLst>
+                </p:cTn>
+                <p:tgtEl>
+                  <p:spTgt spid="4"/>
+                </p:tgtEl>
+              </p:cMediaNode>
+            </p:video>
+            <p:video>
+              <p:cMediaNode vol="80000">
+                <p:cTn id="3" fill="hold" display="0">
+                  <p:stCondLst>
+                    <p:cond delay="indefinite"/>
+                  </p:stCondLst>
+                </p:cTn>
+                <p:tgtEl>
+                  <p:spTgt spid="6"/>
+                </p:tgtEl>
+              </p:cMediaNode>
+            </p:video>
+          </p:childTnLst>
+        </p:cTn>
+      </p:par>
+    </p:tnLst>
+  </p:timing>
 </p:sld>
 </file>
 

</xml_diff>

<commit_message>
Take the embedded audio back out of the deck
Reverted to the version before the clips were added. The rendered WAV
files stay in output/audio so they can be inserted by hand.
</commit_message>
<xml_diff>
--- a/Presentation.pptx
+++ b/Presentation.pptx
@@ -4137,12 +4137,7 @@
             <p:ph idx="1"/>
           </p:nvPr>
         </p:nvSpPr>
-        <p:spPr>
-          <a:xfrm>
-            <a:off x="457200" y="1600200"/>
-            <a:ext cx="8229600" cy="3200400"/>
-          </a:xfrm>
-        </p:spPr>
+        <p:spPr/>
         <p:txBody>
           <a:bodyPr/>
           <a:lstStyle/>
@@ -4174,130 +4169,6 @@
           <a:p>
             <a:r>
               <a:t>Each level adds 30 beats per minute</a:t>
-            </a:r>
-          </a:p>
-        </p:txBody>
-      </p:sp>
-      <p:pic>
-        <p:nvPicPr>
-          <p:cNvPr id="4" name="level1.wav">
-            <a:hlinkClick r:id="" action="ppaction://media"/>
-          </p:cNvPr>
-          <p:cNvPicPr>
-            <a:picLocks noChangeAspect="1"/>
-          </p:cNvPicPr>
-          <p:nvPr>
-            <a:audioFile r:link="rId3"/>
-            <p:extLst>
-              <p:ext uri="{DAA4B4D4-6D71-4841-9C94-3DE7FCFB9230}">
-                <p14:media xmlns:p14="http://schemas.microsoft.com/office/powerpoint/2010/main" r:embed="rId2"/>
-              </p:ext>
-            </p:extLst>
-          </p:nvPr>
-        </p:nvPicPr>
-        <p:blipFill>
-          <a:blip r:embed="rId4"/>
-          <a:stretch>
-            <a:fillRect/>
-          </a:stretch>
-        </p:blipFill>
-        <p:spPr>
-          <a:xfrm>
-            <a:off x="1371600" y="5029200"/>
-            <a:ext cx="914400" cy="914400"/>
-          </a:xfrm>
-          <a:prstGeom prst="rect">
-            <a:avLst/>
-          </a:prstGeom>
-        </p:spPr>
-      </p:pic>
-      <p:sp>
-        <p:nvSpPr>
-          <p:cNvPr id="5" name="TextBox 4"/>
-          <p:cNvSpPr txBox="1"/>
-          <p:nvPr/>
-        </p:nvSpPr>
-        <p:spPr>
-          <a:xfrm>
-            <a:off x="2423160" y="5303520"/>
-            <a:ext cx="1463040" cy="365760"/>
-          </a:xfrm>
-          <a:prstGeom prst="rect">
-            <a:avLst/>
-          </a:prstGeom>
-          <a:noFill/>
-        </p:spPr>
-        <p:txBody>
-          <a:bodyPr wrap="none">
-            <a:spAutoFit/>
-          </a:bodyPr>
-          <a:lstStyle/>
-          <a:p>
-            <a:r>
-              <a:rPr sz="1800"/>
-              <a:t>Level 1</a:t>
-            </a:r>
-          </a:p>
-        </p:txBody>
-      </p:sp>
-      <p:pic>
-        <p:nvPicPr>
-          <p:cNvPr id="6" name="level5.wav">
-            <a:hlinkClick r:id="" action="ppaction://media"/>
-          </p:cNvPr>
-          <p:cNvPicPr>
-            <a:picLocks noChangeAspect="1"/>
-          </p:cNvPicPr>
-          <p:nvPr>
-            <a:audioFile r:link="rId6"/>
-            <p:extLst>
-              <p:ext uri="{DAA4B4D4-6D71-4841-9C94-3DE7FCFB9230}">
-                <p14:media xmlns:p14="http://schemas.microsoft.com/office/powerpoint/2010/main" r:embed="rId5"/>
-              </p:ext>
-            </p:extLst>
-          </p:nvPr>
-        </p:nvPicPr>
-        <p:blipFill>
-          <a:blip r:embed="rId4"/>
-          <a:stretch>
-            <a:fillRect/>
-          </a:stretch>
-        </p:blipFill>
-        <p:spPr>
-          <a:xfrm>
-            <a:off x="5029200" y="5029200"/>
-            <a:ext cx="914400" cy="914400"/>
-          </a:xfrm>
-          <a:prstGeom prst="rect">
-            <a:avLst/>
-          </a:prstGeom>
-        </p:spPr>
-      </p:pic>
-      <p:sp>
-        <p:nvSpPr>
-          <p:cNvPr id="7" name="TextBox 6"/>
-          <p:cNvSpPr txBox="1"/>
-          <p:nvPr/>
-        </p:nvSpPr>
-        <p:spPr>
-          <a:xfrm>
-            <a:off x="6080760" y="5303520"/>
-            <a:ext cx="1463040" cy="365760"/>
-          </a:xfrm>
-          <a:prstGeom prst="rect">
-            <a:avLst/>
-          </a:prstGeom>
-          <a:noFill/>
-        </p:spPr>
-        <p:txBody>
-          <a:bodyPr wrap="none">
-            <a:spAutoFit/>
-          </a:bodyPr>
-          <a:lstStyle/>
-          <a:p>
-            <a:r>
-              <a:rPr sz="1800"/>
-              <a:t>Level 5</a:t>
             </a:r>
           </a:p>
         </p:txBody>
@@ -4307,40 +4178,6 @@
   <p:clrMapOvr>
     <a:masterClrMapping/>
   </p:clrMapOvr>
-  <p:timing>
-    <p:tnLst>
-      <p:par>
-        <p:cTn id="1" dur="indefinite" restart="never" nodeType="tmRoot">
-          <p:childTnLst>
-            <p:video>
-              <p:cMediaNode vol="80000">
-                <p:cTn id="2" fill="hold" display="0">
-                  <p:stCondLst>
-                    <p:cond delay="indefinite"/>
-                  </p:stCondLst>
-                </p:cTn>
-                <p:tgtEl>
-                  <p:spTgt spid="4"/>
-                </p:tgtEl>
-              </p:cMediaNode>
-            </p:video>
-            <p:video>
-              <p:cMediaNode vol="80000">
-                <p:cTn id="3" fill="hold" display="0">
-                  <p:stCondLst>
-                    <p:cond delay="indefinite"/>
-                  </p:stCondLst>
-                </p:cTn>
-                <p:tgtEl>
-                  <p:spTgt spid="6"/>
-                </p:tgtEl>
-              </p:cMediaNode>
-            </p:video>
-          </p:childTnLst>
-        </p:cTn>
-      </p:par>
-    </p:tnLst>
-  </p:timing>
 </p:sld>
 </file>
 

</xml_diff>

<commit_message>
Correct the report and make Figure 1 legible in print
Removes the Left 4 Dead reference from the conclusion and replaces it
with the same point stated plainly. Reference [2] stays, since the
introduction still cites it.

The introduction said generated music can change on every run, directly
after contrasting it with a soundtrack that repeats. This generator is
seeded by the level number, so replaying a level gives the same music.
Reworded so the paper is consistent with itself.

The storage claim now says the game has to run the generator.

Figure 1 printed its labels at about 3.3 pt, which is unreadable on
paper. The drawing code uses larger labels and drops the caption line
that duplicated the figure caption, so they now print at about 7.7 pt.

Two pages, two columns, all numbers unchanged.
</commit_message>
<xml_diff>
--- a/Presentation.pptx
+++ b/Presentation.pptx
@@ -3334,7 +3334,12 @@
             <p:ph idx="1"/>
           </p:nvPr>
         </p:nvSpPr>
-        <p:spPr/>
+        <p:spPr>
+          <a:xfrm>
+            <a:off x="457200" y="1600201"/>
+            <a:ext cx="8229600" cy="2046642"/>
+          </a:xfrm>
+        </p:spPr>
         <p:txBody>
           <a:bodyPr/>
           <a:lstStyle/>
@@ -3354,6 +3359,164 @@
             <a:r>
               <a:rPr dirty="0"/>
               <a:t>Difficulty only controls the speed</a:t>
+            </a:r>
+            <a:endParaRPr lang="en-CA" dirty="0"/>
+          </a:p>
+          <a:p>
+            <a:pPr marL="0" indent="0">
+              <a:buNone/>
+            </a:pPr>
+            <a:endParaRPr dirty="0"/>
+          </a:p>
+        </p:txBody>
+      </p:sp>
+      <p:pic>
+        <p:nvPicPr>
+          <p:cNvPr id="4" name="level1.mp3">
+            <a:hlinkClick r:id="" action="ppaction://media"/>
+            <a:extLst>
+              <a:ext uri="{FF2B5EF4-FFF2-40B4-BE49-F238E27FC236}">
+                <a16:creationId xmlns:a16="http://schemas.microsoft.com/office/drawing/2014/main" id="{9DA4A675-07B5-123E-6C69-BE6194ED685D}"/>
+              </a:ext>
+            </a:extLst>
+          </p:cNvPr>
+          <p:cNvPicPr>
+            <a:picLocks noChangeAspect="1"/>
+          </p:cNvPicPr>
+          <p:nvPr>
+            <a:audioFile r:link="rId2"/>
+            <p:extLst>
+              <p:ext uri="{DAA4B4D4-6D71-4841-9C94-3DE7FCFB9230}">
+                <p14:media xmlns:p14="http://schemas.microsoft.com/office/powerpoint/2010/main" r:embed="rId1"/>
+              </p:ext>
+            </p:extLst>
+          </p:nvPr>
+        </p:nvPicPr>
+        <p:blipFill>
+          <a:blip r:embed="rId6"/>
+          <a:stretch>
+            <a:fillRect/>
+          </a:stretch>
+        </p:blipFill>
+        <p:spPr>
+          <a:xfrm>
+            <a:off x="1486947" y="3969273"/>
+            <a:ext cx="812800" cy="812800"/>
+          </a:xfrm>
+          <a:prstGeom prst="rect">
+            <a:avLst/>
+          </a:prstGeom>
+          <a:ln>
+            <a:solidFill>
+              <a:schemeClr val="accent1"/>
+            </a:solidFill>
+          </a:ln>
+        </p:spPr>
+      </p:pic>
+      <p:sp>
+        <p:nvSpPr>
+          <p:cNvPr id="5" name="TextBox 4">
+            <a:extLst>
+              <a:ext uri="{FF2B5EF4-FFF2-40B4-BE49-F238E27FC236}">
+                <a16:creationId xmlns:a16="http://schemas.microsoft.com/office/drawing/2014/main" id="{94CA1ACF-0743-7485-EC85-5940C014BA21}"/>
+              </a:ext>
+            </a:extLst>
+          </p:cNvPr>
+          <p:cNvSpPr txBox="1"/>
+          <p:nvPr/>
+        </p:nvSpPr>
+        <p:spPr>
+          <a:xfrm>
+            <a:off x="1433756" y="5314278"/>
+            <a:ext cx="1731982" cy="369332"/>
+          </a:xfrm>
+          <a:prstGeom prst="rect">
+            <a:avLst/>
+          </a:prstGeom>
+          <a:noFill/>
+        </p:spPr>
+        <p:txBody>
+          <a:bodyPr wrap="square" rtlCol="0">
+            <a:spAutoFit/>
+          </a:bodyPr>
+          <a:lstStyle/>
+          <a:p>
+            <a:r>
+              <a:rPr lang="en-US" dirty="0"/>
+              <a:t>Level 1</a:t>
+            </a:r>
+          </a:p>
+        </p:txBody>
+      </p:sp>
+      <p:pic>
+        <p:nvPicPr>
+          <p:cNvPr id="6" name="level5.mp3">
+            <a:hlinkClick r:id="" action="ppaction://media"/>
+            <a:extLst>
+              <a:ext uri="{FF2B5EF4-FFF2-40B4-BE49-F238E27FC236}">
+                <a16:creationId xmlns:a16="http://schemas.microsoft.com/office/drawing/2014/main" id="{D8443CF0-5306-56B2-5006-328FB81B9570}"/>
+              </a:ext>
+            </a:extLst>
+          </p:cNvPr>
+          <p:cNvPicPr>
+            <a:picLocks noChangeAspect="1"/>
+          </p:cNvPicPr>
+          <p:nvPr>
+            <a:audioFile r:link="rId4"/>
+            <p:extLst>
+              <p:ext uri="{DAA4B4D4-6D71-4841-9C94-3DE7FCFB9230}">
+                <p14:media xmlns:p14="http://schemas.microsoft.com/office/powerpoint/2010/main" r:embed="rId3"/>
+              </p:ext>
+            </p:extLst>
+          </p:nvPr>
+        </p:nvPicPr>
+        <p:blipFill>
+          <a:blip r:embed="rId6"/>
+          <a:stretch>
+            <a:fillRect/>
+          </a:stretch>
+        </p:blipFill>
+        <p:spPr>
+          <a:xfrm>
+            <a:off x="6682890" y="3969273"/>
+            <a:ext cx="812800" cy="812800"/>
+          </a:xfrm>
+          <a:prstGeom prst="rect">
+            <a:avLst/>
+          </a:prstGeom>
+        </p:spPr>
+      </p:pic>
+      <p:sp>
+        <p:nvSpPr>
+          <p:cNvPr id="7" name="TextBox 6">
+            <a:extLst>
+              <a:ext uri="{FF2B5EF4-FFF2-40B4-BE49-F238E27FC236}">
+                <a16:creationId xmlns:a16="http://schemas.microsoft.com/office/drawing/2014/main" id="{7D0BE36D-9601-052B-51C2-B3FB36C06BC7}"/>
+              </a:ext>
+            </a:extLst>
+          </p:cNvPr>
+          <p:cNvSpPr txBox="1"/>
+          <p:nvPr/>
+        </p:nvSpPr>
+        <p:spPr>
+          <a:xfrm>
+            <a:off x="6682890" y="5314278"/>
+            <a:ext cx="1731982" cy="369332"/>
+          </a:xfrm>
+          <a:prstGeom prst="rect">
+            <a:avLst/>
+          </a:prstGeom>
+          <a:noFill/>
+        </p:spPr>
+        <p:txBody>
+          <a:bodyPr wrap="square" rtlCol="0">
+            <a:spAutoFit/>
+          </a:bodyPr>
+          <a:lstStyle/>
+          <a:p>
+            <a:r>
+              <a:rPr lang="en-US" dirty="0"/>
+              <a:t>Level 5</a:t>
             </a:r>
           </a:p>
         </p:txBody>
@@ -3363,6 +3526,144 @@
   <p:clrMapOvr>
     <a:masterClrMapping/>
   </p:clrMapOvr>
+  <p:timing>
+    <p:tnLst>
+      <p:par>
+        <p:cTn id="1" dur="indefinite" restart="never" nodeType="tmRoot">
+          <p:childTnLst>
+            <p:seq concurrent="1" nextAc="seek">
+              <p:cTn id="2" dur="indefinite" nodeType="mainSeq">
+                <p:childTnLst>
+                  <p:par>
+                    <p:cTn id="3" fill="hold">
+                      <p:stCondLst>
+                        <p:cond delay="indefinite"/>
+                      </p:stCondLst>
+                      <p:childTnLst>
+                        <p:par>
+                          <p:cTn id="4" fill="hold">
+                            <p:stCondLst>
+                              <p:cond delay="0"/>
+                            </p:stCondLst>
+                            <p:childTnLst>
+                              <p:par>
+                                <p:cTn id="5" presetID="1" presetClass="mediacall" presetSubtype="0" fill="hold" nodeType="clickEffect">
+                                  <p:stCondLst>
+                                    <p:cond delay="0"/>
+                                  </p:stCondLst>
+                                  <p:childTnLst>
+                                    <p:cmd type="call" cmd="playFrom(0.0)">
+                                      <p:cBhvr>
+                                        <p:cTn id="6" dur="26044" fill="hold"/>
+                                        <p:tgtEl>
+                                          <p:spTgt spid="4"/>
+                                        </p:tgtEl>
+                                      </p:cBhvr>
+                                    </p:cmd>
+                                  </p:childTnLst>
+                                </p:cTn>
+                              </p:par>
+                            </p:childTnLst>
+                          </p:cTn>
+                        </p:par>
+                      </p:childTnLst>
+                    </p:cTn>
+                  </p:par>
+                  <p:par>
+                    <p:cTn id="7" fill="hold">
+                      <p:stCondLst>
+                        <p:cond delay="indefinite"/>
+                      </p:stCondLst>
+                      <p:childTnLst>
+                        <p:par>
+                          <p:cTn id="8" fill="hold">
+                            <p:stCondLst>
+                              <p:cond delay="0"/>
+                            </p:stCondLst>
+                            <p:childTnLst>
+                              <p:par>
+                                <p:cTn id="9" presetID="1" presetClass="mediacall" presetSubtype="0" fill="hold" nodeType="clickEffect">
+                                  <p:stCondLst>
+                                    <p:cond delay="0"/>
+                                  </p:stCondLst>
+                                  <p:childTnLst>
+                                    <p:cmd type="call" cmd="playFrom(0.0)">
+                                      <p:cBhvr>
+                                        <p:cTn id="10" dur="11650" fill="hold"/>
+                                        <p:tgtEl>
+                                          <p:spTgt spid="6"/>
+                                        </p:tgtEl>
+                                      </p:cBhvr>
+                                    </p:cmd>
+                                  </p:childTnLst>
+                                </p:cTn>
+                              </p:par>
+                            </p:childTnLst>
+                          </p:cTn>
+                        </p:par>
+                      </p:childTnLst>
+                    </p:cTn>
+                  </p:par>
+                </p:childTnLst>
+              </p:cTn>
+              <p:prevCondLst>
+                <p:cond evt="onPrev" delay="0">
+                  <p:tgtEl>
+                    <p:sldTgt/>
+                  </p:tgtEl>
+                </p:cond>
+              </p:prevCondLst>
+              <p:nextCondLst>
+                <p:cond evt="onNext" delay="0">
+                  <p:tgtEl>
+                    <p:sldTgt/>
+                  </p:tgtEl>
+                </p:cond>
+              </p:nextCondLst>
+            </p:seq>
+            <p:audio>
+              <p:cMediaNode vol="80000">
+                <p:cTn id="11" fill="hold" display="0">
+                  <p:stCondLst>
+                    <p:cond delay="indefinite"/>
+                  </p:stCondLst>
+                  <p:endCondLst>
+                    <p:cond evt="onStopAudio" delay="0">
+                      <p:tgtEl>
+                        <p:sldTgt/>
+                      </p:tgtEl>
+                    </p:cond>
+                  </p:endCondLst>
+                </p:cTn>
+                <p:tgtEl>
+                  <p:spTgt spid="4"/>
+                </p:tgtEl>
+              </p:cMediaNode>
+            </p:audio>
+            <p:audio>
+              <p:cMediaNode vol="80000">
+                <p:cTn id="12" fill="hold" display="0">
+                  <p:stCondLst>
+                    <p:cond delay="indefinite"/>
+                  </p:stCondLst>
+                  <p:endCondLst>
+                    <p:cond evt="onStopAudio" delay="0">
+                      <p:tgtEl>
+                        <p:sldTgt/>
+                      </p:tgtEl>
+                    </p:cond>
+                  </p:endCondLst>
+                </p:cTn>
+                <p:tgtEl>
+                  <p:spTgt spid="6"/>
+                </p:tgtEl>
+              </p:cMediaNode>
+            </p:audio>
+          </p:childTnLst>
+        </p:cTn>
+      </p:par>
+    </p:tnLst>
+  </p:timing>
 </p:sld>
 </file>
 
@@ -3726,7 +4027,7 @@
           <p:nvPr/>
         </p:nvPicPr>
         <p:blipFill>
-          <a:blip r:embed="rId3"/>
+          <a:blip r:embed="rId2"/>
           <a:stretch>
             <a:fillRect/>
           </a:stretch>
@@ -3828,7 +4129,7 @@
           <a:p>
             <a:r>
               <a:rPr dirty="0"/>
-              <a:t>That is why one level is only 600 bytes</a:t>
+              <a:t>Each level is stored in a 620-byte MIDI file</a:t>
             </a:r>
           </a:p>
         </p:txBody>
@@ -3900,7 +4201,7 @@
           </a:p>
           <a:p>
             <a:r>
-              <a:t>One note per beat, thirty two notes in total</a:t>
+              <a:t>One note per beat, thirty-two notes in total</a:t>
             </a:r>
           </a:p>
           <a:p>
@@ -3920,7 +4221,7 @@
           </a:p>
           <a:p>
             <a:r>
-              <a:t>A repeat shifts the pattern, so levels differ</a:t>
+              <a:t>Each level uses a seed to repeat its pattern</a:t>
             </a:r>
           </a:p>
         </p:txBody>
@@ -4066,7 +4367,7 @@
           <p:nvPr/>
         </p:nvPicPr>
         <p:blipFill>
-          <a:blip r:embed="rId3"/>
+          <a:blip r:embed="rId2"/>
           <a:stretch>
             <a:fillRect/>
           </a:stretch>

</xml_diff>